<commit_message>
P3 덱 개요(slide2) 재구성 + 이상 5종(slide5)
slide2: 의미없던 2줄 → 1줄 헤드라인 + 그림 + 그림 아래 설명 박스(영역=왜 있고 뭔지 / 노이즈=왜 넣는지 / 이상 5종). slide5: avg/std/spike/drift/context 5개 모두 figure로(기존 4 → context 추가)

사용자: 2줄 의미없으니 1줄로, 밑에 trend 생성 설명(영역·노이즈 왜+무엇), 이상 5종 다시

Co-Authored-By: Claude Opus 4.8 (1M context) <noreply@anthropic.com>
</commit_message>
<xml_diff>
--- a/recommendation/presentation/발표_P3_데이터생성_최호길.pptx
+++ b/recommendation/presentation/발표_P3_데이터생성_최호길.pptx
@@ -4090,7 +4090,7 @@
                 <a:latin typeface="맑은 고딕"/>
                 <a:ea typeface="맑은 고딕"/>
               </a:rPr>
-              <a:t>이상 유형별 라벨 부족 → 도메인 규칙으로 데이터 생성</a:t>
+              <a:t>정상 baseline 위에 영역/노이즈/이상을 규칙으로 합성</a:t>
             </a:r>
           </a:p>
         </p:txBody>
@@ -4104,7 +4104,7 @@
         <p:spPr>
           <a:xfrm>
             <a:off x="640080" y="1828800"/>
-            <a:ext cx="10972800" cy="1143000"/>
+            <a:ext cx="10972800" cy="566928"/>
           </a:xfrm>
           <a:prstGeom prst="rect">
             <a:avLst/>
@@ -4123,7 +4123,7 @@
               </a:spcAft>
             </a:pPr>
             <a:r>
-              <a:rPr sz="1450" b="0">
+              <a:rPr sz="1400" b="0">
                 <a:solidFill>
                   <a:srgbClr val="5B9BD5"/>
                 </a:solidFill>
@@ -4133,134 +4133,21 @@
               <a:t>●  </a:t>
             </a:r>
             <a:r>
-              <a:rPr sz="1450">
+              <a:rPr sz="1400">
                 <a:solidFill>
                   <a:srgbClr val="1A1F2E"/>
                 </a:solidFill>
                 <a:latin typeface="맑은 고딕"/>
                 <a:ea typeface="맑은 고딕"/>
               </a:rPr>
-              <a:t>실 계측 trend는 정상은 많지만 이상은 드물고, 평균이동/산포/spike/drift 같은 </a:t>
-            </a:r>
-            <a:r>
-              <a:rPr sz="1450" b="1">
-                <a:solidFill>
-                  <a:srgbClr val="0F1E3D"/>
-                </a:solidFill>
-                <a:latin typeface="맑은 고딕"/>
-                <a:ea typeface="맑은 고딕"/>
-              </a:rPr>
-              <a:t>이상 유형별 라벨이 희소</a:t>
-            </a:r>
-            <a:r>
-              <a:rPr sz="1450">
-                <a:solidFill>
-                  <a:srgbClr val="1A1F2E"/>
-                </a:solidFill>
-                <a:latin typeface="맑은 고딕"/>
-                <a:ea typeface="맑은 고딕"/>
-              </a:rPr>
-              <a:t>해 모델 학습과 평가가 어렵습니다</a:t>
-            </a:r>
-          </a:p>
-          <a:p>
-            <a:pPr marL="274320" indent="-274320">
-              <a:spcAft>
-                <a:spcPts val="500"/>
-              </a:spcAft>
-            </a:pPr>
-            <a:r>
-              <a:rPr sz="1450" b="0">
-                <a:solidFill>
-                  <a:srgbClr val="5B9BD5"/>
-                </a:solidFill>
-                <a:latin typeface="맑은 고딕"/>
-                <a:ea typeface="맑은 고딕"/>
-              </a:rPr>
-              <a:t>●  </a:t>
-            </a:r>
-            <a:r>
-              <a:rPr sz="1450">
-                <a:solidFill>
-                  <a:srgbClr val="1A1F2E"/>
-                </a:solidFill>
-                <a:latin typeface="맑은 고딕"/>
-                <a:ea typeface="맑은 고딕"/>
-              </a:rPr>
-              <a:t>본인이 BBD담당, Overlay담당, CD담당으로 쌓은 trend 분석 경험을 바탕으로 계측 trend의 </a:t>
-            </a:r>
-            <a:r>
-              <a:rPr sz="1450" b="1">
-                <a:solidFill>
-                  <a:srgbClr val="0F1E3D"/>
-                </a:solidFill>
-                <a:latin typeface="맑은 고딕"/>
-                <a:ea typeface="맑은 고딕"/>
-              </a:rPr>
-              <a:t>영역 구조, 노이즈, 이상 발생 방식</a:t>
-            </a:r>
-            <a:r>
-              <a:rPr sz="1450">
-                <a:solidFill>
-                  <a:srgbClr val="1A1F2E"/>
-                </a:solidFill>
-                <a:latin typeface="맑은 고딕"/>
-                <a:ea typeface="맑은 고딕"/>
-              </a:rPr>
-              <a:t>을 generator 규칙으로 옮겨 검증 가능한 benchmark를 만들었습니다</a:t>
-            </a:r>
-          </a:p>
-        </p:txBody>
-      </p:sp>
-      <p:sp>
-        <p:nvSpPr>
-          <p:cNvPr id="6" name="Rectangle 5"/>
-          <p:cNvSpPr/>
-          <p:nvPr/>
-        </p:nvSpPr>
-        <p:spPr>
-          <a:xfrm>
-            <a:off x="1957199" y="3090816"/>
-            <a:ext cx="8338561" cy="2532600"/>
-          </a:xfrm>
-          <a:prstGeom prst="rect">
-            <a:avLst/>
-          </a:prstGeom>
-          <a:solidFill>
-            <a:srgbClr val="FFFFFF"/>
-          </a:solidFill>
-          <a:ln w="12700">
-            <a:solidFill>
-              <a:srgbClr val="D7DEEA"/>
-            </a:solidFill>
-          </a:ln>
-          <a:effectLst/>
-        </p:spPr>
-        <p:style>
-          <a:lnRef idx="1">
-            <a:schemeClr val="accent1"/>
-          </a:lnRef>
-          <a:fillRef idx="3">
-            <a:schemeClr val="accent1"/>
-          </a:fillRef>
-          <a:effectRef idx="2">
-            <a:schemeClr val="accent1"/>
-          </a:effectRef>
-          <a:fontRef idx="minor">
-            <a:schemeClr val="lt1"/>
-          </a:fontRef>
-        </p:style>
-        <p:txBody>
-          <a:bodyPr rtlCol="0" anchor="ctr"/>
-          <a:lstStyle/>
-          <a:p>
-            <a:pPr algn="ctr"/>
+              <a:t>이상 유형별 라벨이 희소한 계측 trend를, 도메인 규칙으로 정상 baseline과 이상을 합성해 검증 가능한 benchmark로 만들었습니다</a:t>
+            </a:r>
           </a:p>
         </p:txBody>
       </p:sp>
       <p:pic>
         <p:nvPicPr>
-          <p:cNvPr id="7" name="Picture 6" descr="p3_generator_top_reference.png"/>
+          <p:cNvPr id="6" name="Picture 5" descr="p3_generator_top_reference.png"/>
           <p:cNvPicPr>
             <a:picLocks noChangeAspect="1"/>
           </p:cNvPicPr>
@@ -4274,8 +4161,8 @@
         </p:blipFill>
         <p:spPr>
           <a:xfrm>
-            <a:off x="1966199" y="3099816"/>
-            <a:ext cx="8320561" cy="2514600"/>
+            <a:off x="3834544" y="2560320"/>
+            <a:ext cx="4583872" cy="1385316"/>
           </a:xfrm>
           <a:prstGeom prst="rect">
             <a:avLst/>
@@ -4284,14 +4171,14 @@
       </p:pic>
       <p:sp>
         <p:nvSpPr>
-          <p:cNvPr id="8" name="TextBox 7"/>
+          <p:cNvPr id="7" name="TextBox 6"/>
           <p:cNvSpPr txBox="1"/>
           <p:nvPr/>
         </p:nvSpPr>
         <p:spPr>
           <a:xfrm>
-            <a:off x="1797035" y="5614416"/>
-            <a:ext cx="8658889" cy="329184"/>
+            <a:off x="640080" y="4009644"/>
+            <a:ext cx="10972800" cy="329184"/>
           </a:xfrm>
           <a:prstGeom prst="rect">
             <a:avLst/>
@@ -4306,15 +4193,61 @@
           <a:p>
             <a:pPr algn="ctr"/>
             <a:r>
-              <a:rPr sz="1450" b="1">
+              <a:rPr sz="1250" b="1">
                 <a:solidFill>
                   <a:srgbClr val="0F1E3D"/>
                 </a:solidFill>
                 <a:latin typeface="맑은 고딕"/>
                 <a:ea typeface="맑은 고딕"/>
               </a:rPr>
-              <a:t>정상 baseline(밀집/희소/결핍 영역) 위에 이상 4종(평균이동 / 산포 / spike / drift)을 합성</a:t>
-            </a:r>
+              <a:t>정상 baseline(밀집/희소/결핍 영역) + 이상 합성 예시</a:t>
+            </a:r>
+          </a:p>
+        </p:txBody>
+      </p:sp>
+      <p:sp>
+        <p:nvSpPr>
+          <p:cNvPr id="8" name="Rectangle 7"/>
+          <p:cNvSpPr/>
+          <p:nvPr/>
+        </p:nvSpPr>
+        <p:spPr>
+          <a:xfrm>
+            <a:off x="640080" y="4567428"/>
+            <a:ext cx="10972800" cy="1458468"/>
+          </a:xfrm>
+          <a:prstGeom prst="rect">
+            <a:avLst/>
+          </a:prstGeom>
+          <a:solidFill>
+            <a:srgbClr val="FFFFFF"/>
+          </a:solidFill>
+          <a:ln w="15875">
+            <a:solidFill>
+              <a:srgbClr val="333740"/>
+            </a:solidFill>
+          </a:ln>
+          <a:effectLst/>
+        </p:spPr>
+        <p:style>
+          <a:lnRef idx="1">
+            <a:schemeClr val="accent1"/>
+          </a:lnRef>
+          <a:fillRef idx="3">
+            <a:schemeClr val="accent1"/>
+          </a:fillRef>
+          <a:effectRef idx="2">
+            <a:schemeClr val="accent1"/>
+          </a:effectRef>
+          <a:fontRef idx="minor">
+            <a:schemeClr val="lt1"/>
+          </a:fontRef>
+        </p:style>
+        <p:txBody>
+          <a:bodyPr rtlCol="0" anchor="ctr"/>
+          <a:lstStyle/>
+          <a:p>
+            <a:pPr algn="ctr"/>
           </a:p>
         </p:txBody>
       </p:sp>
@@ -4326,44 +4259,8 @@
         </p:nvSpPr>
         <p:spPr>
           <a:xfrm>
-            <a:off x="640080" y="5961888"/>
-            <a:ext cx="10972800" cy="274320"/>
-          </a:xfrm>
-          <a:prstGeom prst="rect">
-            <a:avLst/>
-          </a:prstGeom>
-          <a:noFill/>
-        </p:spPr>
-        <p:txBody>
-          <a:bodyPr wrap="square" anchor="t" lIns="0" rIns="0" tIns="0" bIns="0">
-            <a:spAutoFit/>
-          </a:bodyPr>
-          <a:lstStyle/>
-          <a:p>
-            <a:pPr algn="ctr"/>
-            <a:r>
-              <a:rPr sz="1300">
-                <a:solidFill>
-                  <a:srgbClr val="3A485C"/>
-                </a:solidFill>
-                <a:latin typeface="맑은 고딕"/>
-                <a:ea typeface="맑은 고딕"/>
-              </a:rPr>
-              <a:t>정상 신호 생성 → 노이즈 → 이상 주입 → 학습/평가 trend 이미지</a:t>
-            </a:r>
-          </a:p>
-        </p:txBody>
-      </p:sp>
-      <p:sp>
-        <p:nvSpPr>
-          <p:cNvPr id="10" name="TextBox 9"/>
-          <p:cNvSpPr txBox="1"/>
-          <p:nvPr/>
-        </p:nvSpPr>
-        <p:spPr>
-          <a:xfrm>
-            <a:off x="457200" y="6437376"/>
-            <a:ext cx="8229600" cy="292608"/>
+            <a:off x="914400" y="4695444"/>
+            <a:ext cx="10479024" cy="1202436"/>
           </a:xfrm>
           <a:prstGeom prst="rect">
             <a:avLst/>
@@ -4378,6 +4275,169 @@
           <a:p>
             <a:pPr algn="l"/>
             <a:r>
+              <a:rPr sz="1450" b="1">
+                <a:solidFill>
+                  <a:srgbClr val="0F1E3D"/>
+                </a:solidFill>
+                <a:latin typeface="맑은 고딕"/>
+                <a:ea typeface="맑은 고딕"/>
+              </a:rPr>
+              <a:t>trend 생성 구성요소 — 무엇을, 왜 넣었나</a:t>
+            </a:r>
+          </a:p>
+          <a:p>
+            <a:pPr algn="l"/>
+            <a:r>
+              <a:rPr sz="500">
+                <a:solidFill>
+                  <a:srgbClr val="FFFFFF"/>
+                </a:solidFill>
+                <a:latin typeface="맑은 고딕"/>
+                <a:ea typeface="맑은 고딕"/>
+              </a:rPr>
+              <a:t> </a:t>
+            </a:r>
+          </a:p>
+          <a:p>
+            <a:pPr algn="l"/>
+            <a:r>
+              <a:rPr sz="1350" b="1" i="0">
+                <a:solidFill>
+                  <a:srgbClr val="0F1E3D"/>
+                </a:solidFill>
+                <a:latin typeface="맑은 고딕"/>
+                <a:ea typeface="맑은 고딕"/>
+              </a:rPr>
+              <a:t>영역(Region)</a:t>
+            </a:r>
+          </a:p>
+          <a:p>
+            <a:pPr algn="l"/>
+            <a:r>
+              <a:rPr sz="1300">
+                <a:solidFill>
+                  <a:srgbClr val="1A1F2E"/>
+                </a:solidFill>
+                <a:latin typeface="맑은 고딕"/>
+                <a:ea typeface="맑은 고딕"/>
+              </a:rPr>
+              <a:t>    측정 빈도에 따라 밀집/희소/결핍이 실제로 교차하므로, 정상 baseline에 그대로 반영</a:t>
+            </a:r>
+          </a:p>
+          <a:p>
+            <a:pPr algn="l"/>
+            <a:r>
+              <a:rPr sz="1350" b="1" i="0">
+                <a:solidFill>
+                  <a:srgbClr val="0F1E3D"/>
+                </a:solidFill>
+                <a:latin typeface="맑은 고딕"/>
+                <a:ea typeface="맑은 고딕"/>
+              </a:rPr>
+              <a:t>노이즈(Noise)</a:t>
+            </a:r>
+          </a:p>
+          <a:p>
+            <a:pPr algn="l"/>
+            <a:r>
+              <a:rPr sz="1300">
+                <a:solidFill>
+                  <a:srgbClr val="1A1F2E"/>
+                </a:solidFill>
+                <a:latin typeface="맑은 고딕"/>
+                <a:ea typeface="맑은 고딕"/>
+              </a:rPr>
+              <a:t>    계측 변동을 현장 현상으로 재현: Gaussian=산포 / Correlated=설비 변동 / Laplacian=계측 헌팅</a:t>
+            </a:r>
+          </a:p>
+          <a:p>
+            <a:pPr algn="l"/>
+            <a:r>
+              <a:rPr sz="1350" b="1" i="0">
+                <a:solidFill>
+                  <a:srgbClr val="0F1E3D"/>
+                </a:solidFill>
+                <a:latin typeface="맑은 고딕"/>
+                <a:ea typeface="맑은 고딕"/>
+              </a:rPr>
+              <a:t>이상(Anomaly 5종)</a:t>
+            </a:r>
+          </a:p>
+          <a:p>
+            <a:pPr algn="l"/>
+            <a:r>
+              <a:rPr sz="1300">
+                <a:solidFill>
+                  <a:srgbClr val="1A1F2E"/>
+                </a:solidFill>
+                <a:latin typeface="맑은 고딕"/>
+                <a:ea typeface="맑은 고딕"/>
+              </a:rPr>
+              <a:t>    실제 불량 발생 방식을 라벨로 확보: avg / std / spike / drift / context</a:t>
+            </a:r>
+          </a:p>
+        </p:txBody>
+      </p:sp>
+      <p:sp>
+        <p:nvSpPr>
+          <p:cNvPr id="10" name="TextBox 9"/>
+          <p:cNvSpPr txBox="1"/>
+          <p:nvPr/>
+        </p:nvSpPr>
+        <p:spPr>
+          <a:xfrm>
+            <a:off x="640080" y="6053328"/>
+            <a:ext cx="10972800" cy="329184"/>
+          </a:xfrm>
+          <a:prstGeom prst="rect">
+            <a:avLst/>
+          </a:prstGeom>
+          <a:noFill/>
+        </p:spPr>
+        <p:txBody>
+          <a:bodyPr wrap="square" anchor="ctr" lIns="0" rIns="0" tIns="0" bIns="0">
+            <a:spAutoFit/>
+          </a:bodyPr>
+          <a:lstStyle/>
+          <a:p>
+            <a:pPr algn="ctr"/>
+            <a:r>
+              <a:rPr sz="1250" b="1">
+                <a:solidFill>
+                  <a:srgbClr val="0F1E3D"/>
+                </a:solidFill>
+                <a:latin typeface="맑은 고딕"/>
+                <a:ea typeface="맑은 고딕"/>
+              </a:rPr>
+              <a:t/>
+            </a:r>
+          </a:p>
+        </p:txBody>
+      </p:sp>
+      <p:sp>
+        <p:nvSpPr>
+          <p:cNvPr id="11" name="TextBox 10"/>
+          <p:cNvSpPr txBox="1"/>
+          <p:nvPr/>
+        </p:nvSpPr>
+        <p:spPr>
+          <a:xfrm>
+            <a:off x="457200" y="6437376"/>
+            <a:ext cx="8229600" cy="292608"/>
+          </a:xfrm>
+          <a:prstGeom prst="rect">
+            <a:avLst/>
+          </a:prstGeom>
+          <a:noFill/>
+        </p:spPr>
+        <p:txBody>
+          <a:bodyPr wrap="square" anchor="ctr" lIns="0" rIns="0" tIns="0" bIns="0">
+            <a:spAutoFit/>
+          </a:bodyPr>
+          <a:lstStyle/>
+          <a:p>
+            <a:pPr algn="l"/>
+            <a:r>
               <a:rPr sz="900">
                 <a:solidFill>
                   <a:srgbClr val="6B7280"/>
@@ -4392,7 +4452,7 @@
       </p:sp>
       <p:sp>
         <p:nvSpPr>
-          <p:cNvPr id="11" name="TextBox 10"/>
+          <p:cNvPr id="12" name="TextBox 11"/>
           <p:cNvSpPr txBox="1"/>
           <p:nvPr/>
         </p:nvSpPr>
@@ -5918,7 +5978,7 @@
                 <a:latin typeface="맑은 고딕"/>
                 <a:ea typeface="맑은 고딕"/>
               </a:rPr>
-              <a:t>정상 baseline 오른쪽 끝에 도메인 규칙으로 이상을 주입합니다. 강도는 각 series의 baseline 산포에 비례하고, 너무 약하면 보이도록 보정합니다(context는 fleet 대비 전체 이탈)</a:t>
+              <a:t>정상 baseline 오른쪽 끝에 도메인 규칙으로 이상을 주입합니다(강도는 baseline 산포에 비례). context만 오른쪽 끝이 아니라 fleet 대비 전체 시계열이 벗어나는 형태입니다</a:t>
             </a:r>
           </a:p>
         </p:txBody>
@@ -5931,8 +5991,8 @@
         </p:nvSpPr>
         <p:spPr>
           <a:xfrm>
-            <a:off x="631081" y="3350579"/>
-            <a:ext cx="2589748" cy="1671267"/>
+            <a:off x="631081" y="3538545"/>
+            <a:ext cx="2029678" cy="1311222"/>
           </a:xfrm>
           <a:prstGeom prst="rect">
             <a:avLst/>
@@ -5985,8 +6045,8 @@
         </p:blipFill>
         <p:spPr>
           <a:xfrm>
-            <a:off x="640081" y="3359579"/>
-            <a:ext cx="2571748" cy="1653267"/>
+            <a:off x="640081" y="3547545"/>
+            <a:ext cx="2011678" cy="1293222"/>
           </a:xfrm>
           <a:prstGeom prst="rect">
             <a:avLst/>
@@ -6001,8 +6061,8 @@
         </p:nvSpPr>
         <p:spPr>
           <a:xfrm>
-            <a:off x="525780" y="5104286"/>
-            <a:ext cx="2800350" cy="402336"/>
+            <a:off x="525780" y="4932207"/>
+            <a:ext cx="2240280" cy="420624"/>
           </a:xfrm>
           <a:prstGeom prst="rect">
             <a:avLst/>
@@ -6017,14 +6077,14 @@
           <a:p>
             <a:pPr algn="ctr"/>
             <a:r>
-              <a:rPr sz="1400" b="1">
+              <a:rPr sz="1300" b="1">
                 <a:solidFill>
                   <a:srgbClr val="0F1E3D"/>
                 </a:solidFill>
                 <a:latin typeface="맑은 고딕"/>
                 <a:ea typeface="맑은 고딕"/>
               </a:rPr>
-              <a:t>Mean Shift — 평균 이동</a:t>
+              <a:t>avg — 평균 이동</a:t>
             </a:r>
           </a:p>
         </p:txBody>
@@ -6037,8 +6097,8 @@
         </p:nvSpPr>
         <p:spPr>
           <a:xfrm>
-            <a:off x="3431431" y="3350579"/>
-            <a:ext cx="2589748" cy="1671267"/>
+            <a:off x="2871361" y="3538545"/>
+            <a:ext cx="2029678" cy="1311222"/>
           </a:xfrm>
           <a:prstGeom prst="rect">
             <a:avLst/>
@@ -6091,8 +6151,8 @@
         </p:blipFill>
         <p:spPr>
           <a:xfrm>
-            <a:off x="3440431" y="3359579"/>
-            <a:ext cx="2571748" cy="1653267"/>
+            <a:off x="2880361" y="3547545"/>
+            <a:ext cx="2011678" cy="1293222"/>
           </a:xfrm>
           <a:prstGeom prst="rect">
             <a:avLst/>
@@ -6107,8 +6167,8 @@
         </p:nvSpPr>
         <p:spPr>
           <a:xfrm>
-            <a:off x="3326130" y="5104286"/>
-            <a:ext cx="2800350" cy="402336"/>
+            <a:off x="2766060" y="4932207"/>
+            <a:ext cx="2240280" cy="420624"/>
           </a:xfrm>
           <a:prstGeom prst="rect">
             <a:avLst/>
@@ -6123,14 +6183,14 @@
           <a:p>
             <a:pPr algn="ctr"/>
             <a:r>
-              <a:rPr sz="1400" b="1">
+              <a:rPr sz="1300" b="1">
                 <a:solidFill>
                   <a:srgbClr val="0F1E3D"/>
                 </a:solidFill>
                 <a:latin typeface="맑은 고딕"/>
                 <a:ea typeface="맑은 고딕"/>
               </a:rPr>
-              <a:t>Std 변화 — 산포 확대</a:t>
+              <a:t>std — 산포 확대</a:t>
             </a:r>
           </a:p>
         </p:txBody>
@@ -6143,8 +6203,8 @@
         </p:nvSpPr>
         <p:spPr>
           <a:xfrm>
-            <a:off x="6231781" y="3350579"/>
-            <a:ext cx="2589748" cy="1671267"/>
+            <a:off x="5111641" y="3538545"/>
+            <a:ext cx="2029678" cy="1311222"/>
           </a:xfrm>
           <a:prstGeom prst="rect">
             <a:avLst/>
@@ -6197,8 +6257,8 @@
         </p:blipFill>
         <p:spPr>
           <a:xfrm>
-            <a:off x="6240781" y="3359579"/>
-            <a:ext cx="2571748" cy="1653267"/>
+            <a:off x="5120641" y="3547545"/>
+            <a:ext cx="2011678" cy="1293222"/>
           </a:xfrm>
           <a:prstGeom prst="rect">
             <a:avLst/>
@@ -6213,8 +6273,8 @@
         </p:nvSpPr>
         <p:spPr>
           <a:xfrm>
-            <a:off x="6126480" y="5104286"/>
-            <a:ext cx="2800350" cy="402336"/>
+            <a:off x="5006340" y="4932207"/>
+            <a:ext cx="2240280" cy="420624"/>
           </a:xfrm>
           <a:prstGeom prst="rect">
             <a:avLst/>
@@ -6229,14 +6289,14 @@
           <a:p>
             <a:pPr algn="ctr"/>
             <a:r>
-              <a:rPr sz="1400" b="1">
+              <a:rPr sz="1300" b="1">
                 <a:solidFill>
                   <a:srgbClr val="0F1E3D"/>
                 </a:solidFill>
                 <a:latin typeface="맑은 고딕"/>
                 <a:ea typeface="맑은 고딕"/>
               </a:rPr>
-              <a:t>Spike — 순간 튐</a:t>
+              <a:t>spike — 순간 튐</a:t>
             </a:r>
           </a:p>
         </p:txBody>
@@ -6249,8 +6309,8 @@
         </p:nvSpPr>
         <p:spPr>
           <a:xfrm>
-            <a:off x="9032131" y="3350579"/>
-            <a:ext cx="2589748" cy="1671267"/>
+            <a:off x="7351921" y="3538545"/>
+            <a:ext cx="2029678" cy="1311222"/>
           </a:xfrm>
           <a:prstGeom prst="rect">
             <a:avLst/>
@@ -6303,8 +6363,8 @@
         </p:blipFill>
         <p:spPr>
           <a:xfrm>
-            <a:off x="9041131" y="3359579"/>
-            <a:ext cx="2571748" cy="1653267"/>
+            <a:off x="7360921" y="3547545"/>
+            <a:ext cx="2011678" cy="1293222"/>
           </a:xfrm>
           <a:prstGeom prst="rect">
             <a:avLst/>
@@ -6319,8 +6379,8 @@
         </p:nvSpPr>
         <p:spPr>
           <a:xfrm>
-            <a:off x="8926830" y="5104286"/>
-            <a:ext cx="2800350" cy="402336"/>
+            <a:off x="7246620" y="4932207"/>
+            <a:ext cx="2240280" cy="420624"/>
           </a:xfrm>
           <a:prstGeom prst="rect">
             <a:avLst/>
@@ -6335,21 +6395,127 @@
           <a:p>
             <a:pPr algn="ctr"/>
             <a:r>
-              <a:rPr sz="1400" b="1">
+              <a:rPr sz="1300" b="1">
                 <a:solidFill>
                   <a:srgbClr val="0F1E3D"/>
                 </a:solidFill>
                 <a:latin typeface="맑은 고딕"/>
                 <a:ea typeface="맑은 고딕"/>
               </a:rPr>
-              <a:t>Drift — 선형 추세</a:t>
-            </a:r>
-          </a:p>
-        </p:txBody>
-      </p:sp>
-      <p:sp>
-        <p:nvSpPr>
-          <p:cNvPr id="18" name="TextBox 17"/>
+              <a:t>drift — 선형 추세</a:t>
+            </a:r>
+          </a:p>
+        </p:txBody>
+      </p:sp>
+      <p:sp>
+        <p:nvSpPr>
+          <p:cNvPr id="18" name="Rectangle 17"/>
+          <p:cNvSpPr/>
+          <p:nvPr/>
+        </p:nvSpPr>
+        <p:spPr>
+          <a:xfrm>
+            <a:off x="9592201" y="3538545"/>
+            <a:ext cx="2029678" cy="1311222"/>
+          </a:xfrm>
+          <a:prstGeom prst="rect">
+            <a:avLst/>
+          </a:prstGeom>
+          <a:solidFill>
+            <a:srgbClr val="FFFFFF"/>
+          </a:solidFill>
+          <a:ln w="12700">
+            <a:solidFill>
+              <a:srgbClr val="D7DEEA"/>
+            </a:solidFill>
+          </a:ln>
+          <a:effectLst/>
+        </p:spPr>
+        <p:style>
+          <a:lnRef idx="1">
+            <a:schemeClr val="accent1"/>
+          </a:lnRef>
+          <a:fillRef idx="3">
+            <a:schemeClr val="accent1"/>
+          </a:fillRef>
+          <a:effectRef idx="2">
+            <a:schemeClr val="accent1"/>
+          </a:effectRef>
+          <a:fontRef idx="minor">
+            <a:schemeClr val="lt1"/>
+          </a:fontRef>
+        </p:style>
+        <p:txBody>
+          <a:bodyPr rtlCol="0" anchor="ctr"/>
+          <a:lstStyle/>
+          <a:p>
+            <a:pPr algn="ctr"/>
+          </a:p>
+        </p:txBody>
+      </p:sp>
+      <p:pic>
+        <p:nvPicPr>
+          <p:cNvPr id="19" name="Picture 18" descr="trend_context.png"/>
+          <p:cNvPicPr>
+            <a:picLocks noChangeAspect="1"/>
+          </p:cNvPicPr>
+          <p:nvPr/>
+        </p:nvPicPr>
+        <p:blipFill>
+          <a:blip r:embed="rId6"/>
+          <a:stretch>
+            <a:fillRect/>
+          </a:stretch>
+        </p:blipFill>
+        <p:spPr>
+          <a:xfrm>
+            <a:off x="9601201" y="3547545"/>
+            <a:ext cx="2011678" cy="1293222"/>
+          </a:xfrm>
+          <a:prstGeom prst="rect">
+            <a:avLst/>
+          </a:prstGeom>
+        </p:spPr>
+      </p:pic>
+      <p:sp>
+        <p:nvSpPr>
+          <p:cNvPr id="20" name="TextBox 19"/>
+          <p:cNvSpPr txBox="1"/>
+          <p:nvPr/>
+        </p:nvSpPr>
+        <p:spPr>
+          <a:xfrm>
+            <a:off x="9486900" y="4932207"/>
+            <a:ext cx="2240280" cy="420624"/>
+          </a:xfrm>
+          <a:prstGeom prst="rect">
+            <a:avLst/>
+          </a:prstGeom>
+          <a:noFill/>
+        </p:spPr>
+        <p:txBody>
+          <a:bodyPr wrap="square" anchor="ctr" lIns="0" rIns="0" tIns="0" bIns="0">
+            <a:spAutoFit/>
+          </a:bodyPr>
+          <a:lstStyle/>
+          <a:p>
+            <a:pPr algn="ctr"/>
+            <a:r>
+              <a:rPr sz="1300" b="1">
+                <a:solidFill>
+                  <a:srgbClr val="0F1E3D"/>
+                </a:solidFill>
+                <a:latin typeface="맑은 고딕"/>
+                <a:ea typeface="맑은 고딕"/>
+              </a:rPr>
+              <a:t>context — fleet 대비 이탈</a:t>
+            </a:r>
+          </a:p>
+        </p:txBody>
+      </p:sp>
+      <p:sp>
+        <p:nvSpPr>
+          <p:cNvPr id="21" name="TextBox 20"/>
           <p:cNvSpPr txBox="1"/>
           <p:nvPr/>
         </p:nvSpPr>
@@ -6378,14 +6544,14 @@
                 <a:latin typeface="맑은 고딕"/>
                 <a:ea typeface="맑은 고딕"/>
               </a:rPr>
-              <a:t>mean_shift y=x+delta / std 산포 확대 / spike 일부 점 급등 / drift y=x+k(t-t0) / context legend 대비 outlier</a:t>
-            </a:r>
-          </a:p>
-        </p:txBody>
-      </p:sp>
-      <p:sp>
-        <p:nvSpPr>
-          <p:cNvPr id="19" name="TextBox 18"/>
+              <a:t>avg y=x+delta / std 산포 확대 / spike 일부 점 급등 / drift y=x+k(t-t0) / context legend(fleet) 대비 outlier</a:t>
+            </a:r>
+          </a:p>
+        </p:txBody>
+      </p:sp>
+      <p:sp>
+        <p:nvSpPr>
+          <p:cNvPr id="22" name="TextBox 21"/>
           <p:cNvSpPr txBox="1"/>
           <p:nvPr/>
         </p:nvSpPr>
@@ -6421,7 +6587,7 @@
       </p:sp>
       <p:sp>
         <p:nvSpPr>
-          <p:cNvPr id="20" name="TextBox 19"/>
+          <p:cNvPr id="23" name="TextBox 22"/>
           <p:cNvSpPr txBox="1"/>
           <p:nvPr/>
         </p:nvSpPr>

</xml_diff>

<commit_message>
P3 덱 원복 — reframe(12a0723) 되돌려 7f4b957(figure 7장) 상태로 복구
사용자 요청: 원복

Co-Authored-By: Claude Opus 4.8 (1M context) <noreply@anthropic.com>
</commit_message>
<xml_diff>
--- a/recommendation/presentation/발표_P3_데이터생성_최호길.pptx
+++ b/recommendation/presentation/발표_P3_데이터생성_최호길.pptx
@@ -12,7 +12,6 @@
     <p:sldId id="260" r:id="rId11"/>
     <p:sldId id="261" r:id="rId12"/>
     <p:sldId id="262" r:id="rId13"/>
-    <p:sldId id="263" r:id="rId14"/>
   </p:sldIdLst>
   <p:sldSz cx="12191695" cy="6858000" type="screen4x3"/>
   <p:notesSz cx="6858000" cy="9144000"/>
@@ -3250,7 +3249,7 @@
                 <a:latin typeface="맑은 고딕"/>
                 <a:ea typeface="맑은 고딕"/>
               </a:rPr>
-              <a:t>이상 유형별 검증 데이터가 없던 문제를, 현장에서 trend를 보던 판정 기준을 생성 규칙으로 옮겨 풀었습니다. 정상 baseline 위에 이상을 합성해 평가셋을 만들고 1차 gate로 확인했습니다</a:t>
+              <a:t>현장 계측 trend의 영역 구조와 노이즈, 이상 발생 방식을 domain knowledge로 코드화해 학습·평가 데이터를 만들고 1차 binary gate로 검증한 과제</a:t>
             </a:r>
           </a:p>
         </p:txBody>
@@ -4091,7 +4090,7 @@
                 <a:latin typeface="맑은 고딕"/>
                 <a:ea typeface="맑은 고딕"/>
               </a:rPr>
-              <a:t>없던 검증 데이터를 현장 판정 기준으로 만들었다</a:t>
+              <a:t>이상 유형별 라벨 부족을 도메인 규칙 generator로 해결</a:t>
             </a:r>
           </a:p>
         </p:txBody>
@@ -4171,7 +4170,7 @@
                 <a:latin typeface="맑은 고딕"/>
                 <a:ea typeface="맑은 고딕"/>
               </a:rPr>
-              <a:t>문제 — 이상 데이터가 거의 없다</a:t>
+              <a:t>문제 — 이상 유형별 라벨이 희소</a:t>
             </a:r>
           </a:p>
         </p:txBody>
@@ -4268,7 +4267,27 @@
                 <a:latin typeface="맑은 고딕"/>
                 <a:ea typeface="맑은 고딕"/>
               </a:rPr>
-              <a:t>정상 trend는 쌓여 있지만 avg / std / spike / drift / context 같은 이상은 드물게 나와, 유형별로 모아 둔 데이터가 거의 없습니다</a:t>
+              <a:t>실 계측 trend는 정상은 많지만 이상은 드물어, </a:t>
+            </a:r>
+            <a:r>
+              <a:rPr sz="1300" b="1">
+                <a:solidFill>
+                  <a:srgbClr val="0F1E3D"/>
+                </a:solidFill>
+                <a:latin typeface="맑은 고딕"/>
+                <a:ea typeface="맑은 고딕"/>
+              </a:rPr>
+              <a:t>avg / std / spike / drift / context</a:t>
+            </a:r>
+            <a:r>
+              <a:rPr sz="1300">
+                <a:solidFill>
+                  <a:srgbClr val="1A1F2E"/>
+                </a:solidFill>
+                <a:latin typeface="맑은 고딕"/>
+                <a:ea typeface="맑은 고딕"/>
+              </a:rPr>
+              <a:t> 같은 이상 유형별 라벨이 부족합니다</a:t>
             </a:r>
           </a:p>
           <a:p>
@@ -4298,7 +4317,7 @@
                 <a:latin typeface="맑은 고딕"/>
                 <a:ea typeface="맑은 고딕"/>
               </a:rPr>
-              <a:t>데이터가 없으니 모델을 학습시키기도, 잘 되는지 비교하기도 어려웠습니다</a:t>
+              <a:t>유형별 평가셋이 없으면 모델 학습도, 성능 비교도 어렵습니다</a:t>
             </a:r>
           </a:p>
           <a:p>
@@ -4328,7 +4347,7 @@
                 <a:latin typeface="맑은 고딕"/>
                 <a:ea typeface="맑은 고딕"/>
               </a:rPr>
-              <a:t>정답이 적어 정량 지표 자체가 잘 서지 않는 상황</a:t>
+              <a:t>정답 라벨이 적어 정량 metric 자체가 성립하기 힘든 상황</a:t>
             </a:r>
           </a:p>
         </p:txBody>
@@ -4616,7 +4635,7 @@
                 <a:latin typeface="맑은 고딕"/>
                 <a:ea typeface="맑은 고딕"/>
               </a:rPr>
-              <a:t>데이터 부재</a:t>
+              <a:t>라벨 희소</a:t>
             </a:r>
           </a:p>
         </p:txBody>
@@ -4652,7 +4671,7 @@
                 <a:latin typeface="맑은 고딕"/>
                 <a:ea typeface="맑은 고딕"/>
               </a:rPr>
-              <a:t>학습·비교 난항</a:t>
+              <a:t>정량 평가 난항</a:t>
             </a:r>
           </a:p>
         </p:txBody>
@@ -4732,7 +4751,7 @@
                 <a:latin typeface="맑은 고딕"/>
                 <a:ea typeface="맑은 고딕"/>
               </a:rPr>
-              <a:t>해법 — 판정 기준을 생성 규칙으로</a:t>
+              <a:t>해법 — domain knowledge generator</a:t>
             </a:r>
           </a:p>
         </p:txBody>
@@ -4829,7 +4848,27 @@
                 <a:latin typeface="맑은 고딕"/>
                 <a:ea typeface="맑은 고딕"/>
               </a:rPr>
-              <a:t>BBD / Overlay / CD를 담당하며 trend를 직접 보던 판정 기준을, 영역과 노이즈, 이상 발생 방식이라는 생성 규칙으로 옮겼습니다</a:t>
+              <a:t>BBD담당/Overlay담당/CD담당으로 쌓은 trend 분석 경험으로 계측의 </a:t>
+            </a:r>
+            <a:r>
+              <a:rPr sz="1300" b="1">
+                <a:solidFill>
+                  <a:srgbClr val="0F1E3D"/>
+                </a:solidFill>
+                <a:latin typeface="맑은 고딕"/>
+                <a:ea typeface="맑은 고딕"/>
+              </a:rPr>
+              <a:t>영역 구조, 노이즈, 이상 발생 방식</a:t>
+            </a:r>
+            <a:r>
+              <a:rPr sz="1300">
+                <a:solidFill>
+                  <a:srgbClr val="1A1F2E"/>
+                </a:solidFill>
+                <a:latin typeface="맑은 고딕"/>
+                <a:ea typeface="맑은 고딕"/>
+              </a:rPr>
+              <a:t>을 규칙으로 코드화했습니다</a:t>
             </a:r>
           </a:p>
           <a:p>
@@ -4859,7 +4898,27 @@
                 <a:latin typeface="맑은 고딕"/>
                 <a:ea typeface="맑은 고딕"/>
               </a:rPr>
-              <a:t>정상 baseline을 만들고 그 위에 이상을 합성해, 부족하던 검증 데이터를 직접 확보했습니다</a:t>
+              <a:t>정상 baseline을 만들고 그 위에 이상을 합성해 </a:t>
+            </a:r>
+            <a:r>
+              <a:rPr sz="1300" b="1">
+                <a:solidFill>
+                  <a:srgbClr val="0F1E3D"/>
+                </a:solidFill>
+                <a:latin typeface="맑은 고딕"/>
+                <a:ea typeface="맑은 고딕"/>
+              </a:rPr>
+              <a:t>검증 가능한 benchmark</a:t>
+            </a:r>
+            <a:r>
+              <a:rPr sz="1300">
+                <a:solidFill>
+                  <a:srgbClr val="1A1F2E"/>
+                </a:solidFill>
+                <a:latin typeface="맑은 고딕"/>
+                <a:ea typeface="맑은 고딕"/>
+              </a:rPr>
+              <a:t>를 확보했습니다</a:t>
             </a:r>
           </a:p>
           <a:p>
@@ -4889,7 +4948,7 @@
                 <a:latin typeface="맑은 고딕"/>
                 <a:ea typeface="맑은 고딕"/>
               </a:rPr>
-              <a:t>성능 수치가 아니라, 검증할 데이터를 만든 것이 이 과제의 핵심</a:t>
+              <a:t>영역(계측 밀도) + 노이즈(계측 변동) + 이상(불량 방식) 세 축을 규칙화</a:t>
             </a:r>
           </a:p>
         </p:txBody>
@@ -5015,7 +5074,7 @@
                 <a:latin typeface="맑은 고딕"/>
                 <a:ea typeface="맑은 고딕"/>
               </a:rPr>
-              <a:t>판정 기준</a:t>
+              <a:t>규칙 기반</a:t>
             </a:r>
           </a:p>
         </p:txBody>
@@ -5051,7 +5110,7 @@
                 <a:latin typeface="맑은 고딕"/>
                 <a:ea typeface="맑은 고딕"/>
               </a:rPr>
-              <a:t>현장 경험을 규칙화</a:t>
+              <a:t>영역+노이즈+이상</a:t>
             </a:r>
           </a:p>
         </p:txBody>
@@ -5177,7 +5236,7 @@
                 <a:latin typeface="맑은 고딕"/>
                 <a:ea typeface="맑은 고딕"/>
               </a:rPr>
-              <a:t>평가셋 확보</a:t>
+              <a:t>benchmark</a:t>
             </a:r>
           </a:p>
         </p:txBody>
@@ -5533,7 +5592,7 @@
                 <a:latin typeface="맑은 고딕"/>
                 <a:ea typeface="맑은 고딕"/>
               </a:rPr>
-              <a:t>한 chart를 여러 episode로 나눠 영역마다 측정 밀도를 다르게 주고, 신호 자체는 평탄하게 둔 채 변동은 노이즈로만 만들었습니다</a:t>
+              <a:t>한 chart를 12~25개 episode로 나눠 영역 밀도를 확률로 샘플링 — 실제 계측 분포를 모사하고, 신호는 평탄하게 두어 변동은 노이즈로만 만듦</a:t>
             </a:r>
           </a:p>
         </p:txBody>
@@ -5853,7 +5912,7 @@
                 <a:latin typeface="맑은 고딕"/>
                 <a:ea typeface="맑은 고딕"/>
               </a:rPr>
-              <a:t>chart 하나는 한 가지 노이즈만 씁니다. Gaussian은 기본 산포, Correlated는 설비 상태에 따라 천천히 흐르는 변동, Laplacian은 계측이 한 번씩 튀는 헌팅입니다</a:t>
+              <a:t>chart 하나는 한 가지 노이즈만 사용 — Gaussian(산포) / Correlated AR(설비 변동) / Laplacian(계측 헌팅)</a:t>
             </a:r>
           </a:p>
         </p:txBody>
@@ -6067,7 +6126,7 @@
                 <a:latin typeface="맑은 고딕"/>
                 <a:ea typeface="맑은 고딕"/>
               </a:rPr>
-              <a:t>이상 합성 5종 — 실제 불량이 나타나는 방식 (파랑 정상, 빨강 이상)</a:t>
+              <a:t>이상 합성 5종 — 실제 불량 발생 방식 (파랑 정상, 빨강 이상)</a:t>
             </a:r>
           </a:p>
         </p:txBody>
@@ -6173,7 +6232,7 @@
                 <a:latin typeface="맑은 고딕"/>
                 <a:ea typeface="맑은 고딕"/>
               </a:rPr>
-              <a:t>정상 baseline 오른쪽 끝에 이상을 주입하고 강도는 그 series의 산포에 맞춰 정합니다. context만 끝이 아니라 fleet 대비 전체가 벗어나는 형태입니다</a:t>
+              <a:t>정상 baseline 오른쪽 끝에 주입하고 강도는 baseline 산포에 비례 (context만 fleet 대비 전체 시계열이 이탈)</a:t>
             </a:r>
           </a:p>
         </p:txBody>
@@ -6387,7 +6446,7 @@
                 <a:latin typeface="맑은 고딕"/>
                 <a:ea typeface="맑은 고딕"/>
               </a:rPr>
-              <a:t>생성 흐름과 데이터 구성</a:t>
+              <a:t>생성 파이프라인과 데이터 구성</a:t>
             </a:r>
           </a:p>
         </p:txBody>
@@ -6437,7 +6496,7 @@
                 <a:latin typeface="맑은 고딕"/>
                 <a:ea typeface="맑은 고딕"/>
               </a:rPr>
-              <a:t>chart를 정의하고 episode를 이어 붙여 정상 baseline을 만든 뒤, 노이즈와 이상을 얹어 학습/평가 이미지로 렌더합니다</a:t>
+              <a:t>chart 정의부터 이미지 렌더까지 규칙 기반으로 생성하고, 이상 강도는 보이도록 floor 보정합니다</a:t>
             </a:r>
           </a:p>
         </p:txBody>
@@ -6519,7 +6578,7 @@
                 <a:latin typeface="맑은 고딕"/>
                 <a:ea typeface="맑은 고딕"/>
               </a:rPr>
-              <a:t>생성 흐름</a:t>
+              <a:t>생성 파이프라인</a:t>
             </a:r>
           </a:p>
           <a:p>
@@ -6584,7 +6643,7 @@
                 <a:latin typeface="맑은 고딕"/>
                 <a:ea typeface="맑은 고딕"/>
               </a:rPr>
-              <a:t>    12~25개를 이어 붙이며 영역 밀도를 샘플링</a:t>
+              <a:t>    12~25개, 영역 밀도 샘플링(밀집/희소/결핍)</a:t>
             </a:r>
           </a:p>
           <a:p>
@@ -6610,7 +6669,7 @@
                 <a:latin typeface="맑은 고딕"/>
                 <a:ea typeface="맑은 고딕"/>
               </a:rPr>
-              <a:t>    Gaussian / Correlated / Laplacian 중 하나</a:t>
+              <a:t>    Gaussian / Correlated / Laplacian 중 1종</a:t>
             </a:r>
           </a:p>
           <a:p>
@@ -6636,7 +6695,7 @@
                 <a:latin typeface="맑은 고딕"/>
                 <a:ea typeface="맑은 고딕"/>
               </a:rPr>
-              <a:t>    avg/std/spike/drift/context, 강도 보정</a:t>
+              <a:t>    avg/std/spike/drift/context (오른쪽 끝)</a:t>
             </a:r>
           </a:p>
           <a:p>
@@ -6662,7 +6721,7 @@
                 <a:latin typeface="맑은 고딕"/>
                 <a:ea typeface="맑은 고딕"/>
               </a:rPr>
-              <a:t>    정상/이상 trend 이미지로 출력</a:t>
+              <a:t>    강도 floor 보정 → 학습/평가 trend 이미지</a:t>
             </a:r>
           </a:p>
         </p:txBody>
@@ -6698,7 +6757,7 @@
                 <a:latin typeface="맑은 고딕"/>
                 <a:ea typeface="맑은 고딕"/>
               </a:rPr>
-              <a:t>현장 판정 기준을 그대로 옮긴 흐름</a:t>
+              <a:t>규칙 기반 생성 흐름</a:t>
             </a:r>
           </a:p>
         </p:txBody>
@@ -6832,7 +6891,7 @@
                 <a:latin typeface="맑은 고딕"/>
                 <a:ea typeface="맑은 고딕"/>
               </a:rPr>
-              <a:t>    별도 test 1,500 (이상 5종 고르게)</a:t>
+              <a:t>    별도 test 1,500 (이상 5종 stratified)</a:t>
             </a:r>
           </a:p>
           <a:p>
@@ -6858,7 +6917,7 @@
                 <a:latin typeface="맑은 고딕"/>
                 <a:ea typeface="맑은 고딕"/>
               </a:rPr>
-              <a:t>    test는 이상 강도를 0.8배로 낮춰</a:t>
+              <a:t>    test/val은 이상 강도를 0.8배로 낮춰</a:t>
             </a:r>
           </a:p>
           <a:p>
@@ -6871,7 +6930,7 @@
                 <a:latin typeface="맑은 고딕"/>
                 <a:ea typeface="맑은 고딕"/>
               </a:rPr>
-              <a:t>    일부러 더 어렵게 만들었습니다</a:t>
+              <a:t>    더 어려운 평가셋 구성</a:t>
             </a:r>
           </a:p>
           <a:p>
@@ -6897,7 +6956,7 @@
                 <a:latin typeface="맑은 고딕"/>
                 <a:ea typeface="맑은 고딕"/>
               </a:rPr>
-              <a:t>    정상은 fleet 중심에서 벗어나지 않게 둡니다</a:t>
+              <a:t>    정상은 fleet 중심에서 벗어나지 않게 강제</a:t>
             </a:r>
           </a:p>
         </p:txBody>
@@ -7111,7 +7170,7 @@
                 <a:latin typeface="맑은 고딕"/>
                 <a:ea typeface="맑은 고딕"/>
               </a:rPr>
-              <a:t>P3 | 생성 데이터 검증</a:t>
+              <a:t>P3 | 1차 binary gate (PoC)</a:t>
             </a:r>
           </a:p>
         </p:txBody>
@@ -7147,7 +7206,7 @@
                 <a:latin typeface="맑은 고딕"/>
                 <a:ea typeface="맑은 고딕"/>
               </a:rPr>
-              <a:t>만든 데이터로 1차 gate가 학습되는지 확인</a:t>
+              <a:t>생성 데이터로 정상/이상 1차 판정 검증</a:t>
             </a:r>
           </a:p>
         </p:txBody>
@@ -7227,7 +7286,7 @@
                 <a:latin typeface="맑은 고딕"/>
                 <a:ea typeface="맑은 고딕"/>
               </a:rPr>
-              <a:t>무엇을 확인했나</a:t>
+              <a:t>모델 — 1차 binary gate</a:t>
             </a:r>
           </a:p>
         </p:txBody>
@@ -7324,7 +7383,47 @@
                 <a:latin typeface="맑은 고딕"/>
                 <a:ea typeface="맑은 고딕"/>
               </a:rPr>
-              <a:t>생성한 데이터로 정상/이상을 1차로 거르는 gate를 학습시켜, 이 데이터가 실제로 쓸 만한지 봤습니다</a:t>
+              <a:t>trend 이미지를 </a:t>
+            </a:r>
+            <a:r>
+              <a:rPr sz="1300" b="1">
+                <a:solidFill>
+                  <a:srgbClr val="0F1E3D"/>
+                </a:solidFill>
+                <a:latin typeface="맑은 고딕"/>
+                <a:ea typeface="맑은 고딕"/>
+              </a:rPr>
+              <a:t>ConvNeXtV2-Tiny</a:t>
+            </a:r>
+            <a:r>
+              <a:rPr sz="1300">
+                <a:solidFill>
+                  <a:srgbClr val="1A1F2E"/>
+                </a:solidFill>
+                <a:latin typeface="맑은 고딕"/>
+                <a:ea typeface="맑은 고딕"/>
+              </a:rPr>
+              <a:t>로 정상/이상 2분류하며, </a:t>
+            </a:r>
+            <a:r>
+              <a:rPr sz="1300" b="1">
+                <a:solidFill>
+                  <a:srgbClr val="0F1E3D"/>
+                </a:solidFill>
+                <a:latin typeface="맑은 고딕"/>
+                <a:ea typeface="맑은 고딕"/>
+              </a:rPr>
+              <a:t>놓침(FN) 최소화</a:t>
+            </a:r>
+            <a:r>
+              <a:rPr sz="1300">
+                <a:solidFill>
+                  <a:srgbClr val="1A1F2E"/>
+                </a:solidFill>
+                <a:latin typeface="맑은 고딕"/>
+                <a:ea typeface="맑은 고딕"/>
+              </a:rPr>
+              <a:t>가 목표입니다</a:t>
             </a:r>
           </a:p>
           <a:p>
@@ -7354,7 +7453,7 @@
                 <a:latin typeface="맑은 고딕"/>
                 <a:ea typeface="맑은 고딕"/>
               </a:rPr>
-              <a:t>ConvNeXtV2-Tiny에 Focal loss로 학습하고, 놓치는 쪽을 줄이려고 normal threshold를 높였습니다</a:t>
+              <a:t>Focal loss + EMA로 학습하고, normal threshold를 올려 FN을 더 줄입니다</a:t>
             </a:r>
           </a:p>
           <a:p>
@@ -7384,7 +7483,7 @@
                 <a:latin typeface="맑은 고딕"/>
                 <a:ea typeface="맑은 고딕"/>
               </a:rPr>
-              <a:t>이상이 걸리면 2차에서 유형(avg/std/spike/drift/context)을 나눠 봅니다</a:t>
+              <a:t>이상이 잡히면 2차에서 유형(avg/std/spike/drift/context) 진단</a:t>
             </a:r>
           </a:p>
         </p:txBody>
@@ -7510,7 +7609,7 @@
                 <a:latin typeface="맑은 고딕"/>
                 <a:ea typeface="맑은 고딕"/>
               </a:rPr>
-              <a:t>1차 gate</a:t>
+              <a:t>2-stage</a:t>
             </a:r>
           </a:p>
         </p:txBody>
@@ -7546,7 +7645,7 @@
                 <a:latin typeface="맑은 고딕"/>
                 <a:ea typeface="맑은 고딕"/>
               </a:rPr>
-              <a:t>정상/이상 선별</a:t>
+              <a:t>binary gate → 유형 진단</a:t>
             </a:r>
           </a:p>
         </p:txBody>
@@ -7672,7 +7771,7 @@
                 <a:latin typeface="맑은 고딕"/>
                 <a:ea typeface="맑은 고딕"/>
               </a:rPr>
-              <a:t>2-stage</a:t>
+              <a:t>ConvNeXtV2</a:t>
             </a:r>
           </a:p>
         </p:txBody>
@@ -7708,7 +7807,7 @@
                 <a:latin typeface="맑은 고딕"/>
                 <a:ea typeface="맑은 고딕"/>
               </a:rPr>
-              <a:t>이후 유형 진단</a:t>
+              <a:t>Tiny backbone</a:t>
             </a:r>
           </a:p>
         </p:txBody>
@@ -7788,7 +7887,7 @@
                 <a:latin typeface="맑은 고딕"/>
                 <a:ea typeface="맑은 고딕"/>
               </a:rPr>
-              <a:t>결과 — 데이터가 학습된다</a:t>
+              <a:t>성과 — 생성셋 검증(PoC)</a:t>
             </a:r>
           </a:p>
         </p:txBody>
@@ -7885,7 +7984,47 @@
                 <a:latin typeface="맑은 고딕"/>
                 <a:ea typeface="맑은 고딕"/>
               </a:rPr>
-              <a:t>test 1,500에서 정상과 이상이 깔끔하게 갈렸습니다 (F1 0.9967, 이상 recall 0.9987, NT 0.9)</a:t>
+              <a:t>test 1,500에서 </a:t>
+            </a:r>
+            <a:r>
+              <a:rPr sz="1300" b="1">
+                <a:solidFill>
+                  <a:srgbClr val="0F1E3D"/>
+                </a:solidFill>
+                <a:latin typeface="맑은 고딕"/>
+                <a:ea typeface="맑은 고딕"/>
+              </a:rPr>
+              <a:t>binary F1 0.9967</a:t>
+            </a:r>
+            <a:r>
+              <a:rPr sz="1300">
+                <a:solidFill>
+                  <a:srgbClr val="1A1F2E"/>
+                </a:solidFill>
+                <a:latin typeface="맑은 고딕"/>
+                <a:ea typeface="맑은 고딕"/>
+              </a:rPr>
+              <a:t>, </a:t>
+            </a:r>
+            <a:r>
+              <a:rPr sz="1300" b="1">
+                <a:solidFill>
+                  <a:srgbClr val="0F1E3D"/>
+                </a:solidFill>
+                <a:latin typeface="맑은 고딕"/>
+                <a:ea typeface="맑은 고딕"/>
+              </a:rPr>
+              <a:t>이상 recall 0.9987</a:t>
+            </a:r>
+            <a:r>
+              <a:rPr sz="1300">
+                <a:solidFill>
+                  <a:srgbClr val="1A1F2E"/>
+                </a:solidFill>
+                <a:latin typeface="맑은 고딕"/>
+                <a:ea typeface="맑은 고딕"/>
+              </a:rPr>
+              <a:t>(normal threshold 0.9)</a:t>
             </a:r>
           </a:p>
           <a:p>
@@ -7915,7 +8054,7 @@
                 <a:latin typeface="맑은 고딕"/>
                 <a:ea typeface="맑은 고딕"/>
               </a:rPr>
-              <a:t>정상 750 중 4건 오탐, 이상 750 중 1건 놓침 정도였습니다</a:t>
+              <a:t>정상 750 중 오탐 4건, 이상 750 중 놓침 1건 수준</a:t>
             </a:r>
           </a:p>
           <a:p>
@@ -7945,7 +8084,7 @@
                 <a:latin typeface="맑은 고딕"/>
                 <a:ea typeface="맑은 고딕"/>
               </a:rPr>
-              <a:t>이 수치 자체가 목적이 아니라, 생성 데이터가 학습 가능하다는 신호입니다</a:t>
+              <a:t>FN을 유형별로 분해해 데이터 난이도와 threshold로 피드백</a:t>
             </a:r>
           </a:p>
         </p:txBody>
@@ -8071,7 +8210,7 @@
                 <a:latin typeface="맑은 고딕"/>
                 <a:ea typeface="맑은 고딕"/>
               </a:rPr>
-              <a:t>학습 가능</a:t>
+              <a:t>F1 0.9967</a:t>
             </a:r>
           </a:p>
         </p:txBody>
@@ -8107,7 +8246,7 @@
                 <a:latin typeface="맑은 고딕"/>
                 <a:ea typeface="맑은 고딕"/>
               </a:rPr>
-              <a:t>생성 데이터로</a:t>
+              <a:t>binary gate</a:t>
             </a:r>
           </a:p>
         </p:txBody>
@@ -8233,7 +8372,7 @@
                 <a:latin typeface="맑은 고딕"/>
                 <a:ea typeface="맑은 고딕"/>
               </a:rPr>
-              <a:t>F1 0.9967</a:t>
+              <a:t>recall 0.9987</a:t>
             </a:r>
           </a:p>
         </p:txBody>
@@ -8269,7 +8408,7 @@
                 <a:latin typeface="맑은 고딕"/>
                 <a:ea typeface="맑은 고딕"/>
               </a:rPr>
-              <a:t>1차 gate (PoC)</a:t>
+              <a:t>abnormal</a:t>
             </a:r>
           </a:p>
         </p:txBody>
@@ -8342,688 +8481,6 @@
                 <a:ea typeface="맑은 고딕"/>
               </a:rPr>
               <a:t>7</a:t>
-            </a:r>
-          </a:p>
-        </p:txBody>
-      </p:sp>
-    </p:spTree>
-  </p:cSld>
-  <p:clrMapOvr>
-    <a:masterClrMapping/>
-  </p:clrMapOvr>
-</p:sld>
-</file>
-
-<file path=ppt/slides/slide8.xml><?xml version="1.0" encoding="utf-8"?>
-<p:sld xmlns:a="http://schemas.openxmlformats.org/drawingml/2006/main" xmlns:p="http://schemas.openxmlformats.org/presentationml/2006/main" xmlns:r="http://schemas.openxmlformats.org/officeDocument/2006/relationships">
-  <p:cSld>
-    <p:bg>
-      <p:bgPr>
-        <a:solidFill>
-          <a:srgbClr val="FFFFFF"/>
-        </a:solidFill>
-        <a:effectLst/>
-      </p:bgPr>
-    </p:bg>
-    <p:spTree>
-      <p:nvGrpSpPr>
-        <p:cNvPr id="1" name=""/>
-        <p:cNvGrpSpPr/>
-        <p:nvPr/>
-      </p:nvGrpSpPr>
-      <p:grpSpPr/>
-      <p:sp>
-        <p:nvSpPr>
-          <p:cNvPr id="2" name="Rectangle 1"/>
-          <p:cNvSpPr/>
-          <p:nvPr/>
-        </p:nvSpPr>
-        <p:spPr>
-          <a:xfrm>
-            <a:off x="640080" y="502920"/>
-            <a:ext cx="123444" cy="768096"/>
-          </a:xfrm>
-          <a:prstGeom prst="rect">
-            <a:avLst/>
-          </a:prstGeom>
-          <a:solidFill>
-            <a:srgbClr val="CFD4DB"/>
-          </a:solidFill>
-          <a:ln>
-            <a:noFill/>
-          </a:ln>
-          <a:effectLst/>
-        </p:spPr>
-        <p:style>
-          <a:lnRef idx="1">
-            <a:schemeClr val="accent1"/>
-          </a:lnRef>
-          <a:fillRef idx="3">
-            <a:schemeClr val="accent1"/>
-          </a:fillRef>
-          <a:effectRef idx="2">
-            <a:schemeClr val="accent1"/>
-          </a:effectRef>
-          <a:fontRef idx="minor">
-            <a:schemeClr val="lt1"/>
-          </a:fontRef>
-        </p:style>
-        <p:txBody>
-          <a:bodyPr rtlCol="0" anchor="ctr"/>
-          <a:lstStyle/>
-          <a:p>
-            <a:pPr algn="ctr"/>
-          </a:p>
-        </p:txBody>
-      </p:sp>
-      <p:sp>
-        <p:nvSpPr>
-          <p:cNvPr id="3" name="TextBox 2"/>
-          <p:cNvSpPr txBox="1"/>
-          <p:nvPr/>
-        </p:nvSpPr>
-        <p:spPr>
-          <a:xfrm>
-            <a:off x="932688" y="448056"/>
-            <a:ext cx="10881360" cy="256032"/>
-          </a:xfrm>
-          <a:prstGeom prst="rect">
-            <a:avLst/>
-          </a:prstGeom>
-          <a:noFill/>
-        </p:spPr>
-        <p:txBody>
-          <a:bodyPr wrap="square" anchor="t" lIns="0" rIns="0" tIns="0" bIns="0">
-            <a:spAutoFit/>
-          </a:bodyPr>
-          <a:lstStyle/>
-          <a:p>
-            <a:pPr algn="l"/>
-            <a:r>
-              <a:rPr sz="1300" b="1">
-                <a:solidFill>
-                  <a:srgbClr val="8A929E"/>
-                </a:solidFill>
-                <a:latin typeface="맑은 고딕"/>
-                <a:ea typeface="맑은 고딕"/>
-              </a:rPr>
-              <a:t>P3 | robustness 점검</a:t>
-            </a:r>
-          </a:p>
-        </p:txBody>
-      </p:sp>
-      <p:sp>
-        <p:nvSpPr>
-          <p:cNvPr id="4" name="TextBox 3"/>
-          <p:cNvSpPr txBox="1"/>
-          <p:nvPr/>
-        </p:nvSpPr>
-        <p:spPr>
-          <a:xfrm>
-            <a:off x="932688" y="704088"/>
-            <a:ext cx="10881360" cy="603504"/>
-          </a:xfrm>
-          <a:prstGeom prst="rect">
-            <a:avLst/>
-          </a:prstGeom>
-          <a:noFill/>
-        </p:spPr>
-        <p:txBody>
-          <a:bodyPr wrap="square" anchor="t" lIns="0" rIns="0" tIns="0" bIns="0">
-            <a:spAutoFit/>
-          </a:bodyPr>
-          <a:lstStyle/>
-          <a:p>
-            <a:pPr algn="l"/>
-            <a:r>
-              <a:rPr sz="3100" b="1">
-                <a:solidFill>
-                  <a:srgbClr val="0F1E3D"/>
-                </a:solidFill>
-                <a:latin typeface="맑은 고딕"/>
-                <a:ea typeface="맑은 고딕"/>
-              </a:rPr>
-              <a:t>모델이 색이나 노이즈가 아니라 실제 패턴을 보게</a:t>
-            </a:r>
-          </a:p>
-        </p:txBody>
-      </p:sp>
-      <p:sp>
-        <p:nvSpPr>
-          <p:cNvPr id="5" name="TextBox 4"/>
-          <p:cNvSpPr txBox="1"/>
-          <p:nvPr/>
-        </p:nvSpPr>
-        <p:spPr>
-          <a:xfrm>
-            <a:off x="640080" y="1828800"/>
-            <a:ext cx="10972800" cy="685800"/>
-          </a:xfrm>
-          <a:prstGeom prst="rect">
-            <a:avLst/>
-          </a:prstGeom>
-          <a:noFill/>
-        </p:spPr>
-        <p:txBody>
-          <a:bodyPr wrap="square" anchor="t" lIns="0" rIns="0" tIns="0" bIns="0">
-            <a:spAutoFit/>
-          </a:bodyPr>
-          <a:lstStyle/>
-          <a:p>
-            <a:pPr marL="274320" indent="-274320">
-              <a:spcAft>
-                <a:spcPts val="500"/>
-              </a:spcAft>
-            </a:pPr>
-            <a:r>
-              <a:rPr sz="1400" b="0">
-                <a:solidFill>
-                  <a:srgbClr val="5B9BD5"/>
-                </a:solidFill>
-                <a:latin typeface="맑은 고딕"/>
-                <a:ea typeface="맑은 고딕"/>
-              </a:rPr>
-              <a:t>●  </a:t>
-            </a:r>
-            <a:r>
-              <a:rPr sz="1400">
-                <a:solidFill>
-                  <a:srgbClr val="1A1F2E"/>
-                </a:solidFill>
-                <a:latin typeface="맑은 고딕"/>
-                <a:ea typeface="맑은 고딕"/>
-              </a:rPr>
-              <a:t>PoC 수치보다, 모델이 trend의 진짜 모양을 보고 판단하는지가 더 중요했습니다. 두 가지로 점검했습니다</a:t>
-            </a:r>
-          </a:p>
-        </p:txBody>
-      </p:sp>
-      <p:sp>
-        <p:nvSpPr>
-          <p:cNvPr id="6" name="Rectangle 5"/>
-          <p:cNvSpPr/>
-          <p:nvPr/>
-        </p:nvSpPr>
-        <p:spPr>
-          <a:xfrm>
-            <a:off x="640080" y="2642616"/>
-            <a:ext cx="5303520" cy="3383280"/>
-          </a:xfrm>
-          <a:prstGeom prst="rect">
-            <a:avLst/>
-          </a:prstGeom>
-          <a:solidFill>
-            <a:srgbClr val="FFFFFF"/>
-          </a:solidFill>
-          <a:ln w="15875">
-            <a:solidFill>
-              <a:srgbClr val="333740"/>
-            </a:solidFill>
-          </a:ln>
-          <a:effectLst/>
-        </p:spPr>
-        <p:style>
-          <a:lnRef idx="1">
-            <a:schemeClr val="accent1"/>
-          </a:lnRef>
-          <a:fillRef idx="3">
-            <a:schemeClr val="accent1"/>
-          </a:fillRef>
-          <a:effectRef idx="2">
-            <a:schemeClr val="accent1"/>
-          </a:effectRef>
-          <a:fontRef idx="minor">
-            <a:schemeClr val="lt1"/>
-          </a:fontRef>
-        </p:style>
-        <p:txBody>
-          <a:bodyPr rtlCol="0" anchor="ctr"/>
-          <a:lstStyle/>
-          <a:p>
-            <a:pPr algn="ctr"/>
-          </a:p>
-        </p:txBody>
-      </p:sp>
-      <p:sp>
-        <p:nvSpPr>
-          <p:cNvPr id="7" name="TextBox 6"/>
-          <p:cNvSpPr txBox="1"/>
-          <p:nvPr/>
-        </p:nvSpPr>
-        <p:spPr>
-          <a:xfrm>
-            <a:off x="914400" y="2770632"/>
-            <a:ext cx="4809744" cy="3127248"/>
-          </a:xfrm>
-          <a:prstGeom prst="rect">
-            <a:avLst/>
-          </a:prstGeom>
-          <a:noFill/>
-        </p:spPr>
-        <p:txBody>
-          <a:bodyPr wrap="square" anchor="ctr" lIns="0" rIns="0" tIns="0" bIns="0">
-            <a:spAutoFit/>
-          </a:bodyPr>
-          <a:lstStyle/>
-          <a:p>
-            <a:pPr algn="l"/>
-            <a:r>
-              <a:rPr sz="1450" b="1">
-                <a:solidFill>
-                  <a:srgbClr val="0F1E3D"/>
-                </a:solidFill>
-                <a:latin typeface="맑은 고딕"/>
-                <a:ea typeface="맑은 고딕"/>
-              </a:rPr>
-              <a:t>Smoothing window (median)</a:t>
-            </a:r>
-          </a:p>
-          <a:p>
-            <a:pPr algn="l"/>
-            <a:r>
-              <a:rPr sz="500">
-                <a:solidFill>
-                  <a:srgbClr val="FFFFFF"/>
-                </a:solidFill>
-                <a:latin typeface="맑은 고딕"/>
-                <a:ea typeface="맑은 고딕"/>
-              </a:rPr>
-              <a:t> </a:t>
-            </a:r>
-          </a:p>
-          <a:p>
-            <a:pPr algn="l"/>
-            <a:r>
-              <a:rPr sz="1350" b="1" i="0">
-                <a:solidFill>
-                  <a:srgbClr val="0F1E3D"/>
-                </a:solidFill>
-                <a:latin typeface="맑은 고딕"/>
-                <a:ea typeface="맑은 고딕"/>
-              </a:rPr>
-              <a:t>무엇</a:t>
-            </a:r>
-          </a:p>
-          <a:p>
-            <a:pPr algn="l"/>
-            <a:r>
-              <a:rPr sz="1300">
-                <a:solidFill>
-                  <a:srgbClr val="1A1F2E"/>
-                </a:solidFill>
-                <a:latin typeface="맑은 고딕"/>
-                <a:ea typeface="맑은 고딕"/>
-              </a:rPr>
-              <a:t>    trend를 window 크기(1=원본 / 3 / 5)로 median 평활</a:t>
-            </a:r>
-          </a:p>
-          <a:p>
-            <a:pPr algn="l"/>
-            <a:r>
-              <a:rPr sz="1350" b="1" i="0">
-                <a:solidFill>
-                  <a:srgbClr val="0F1E3D"/>
-                </a:solidFill>
-                <a:latin typeface="맑은 고딕"/>
-                <a:ea typeface="맑은 고딕"/>
-              </a:rPr>
-              <a:t>왜</a:t>
-            </a:r>
-          </a:p>
-          <a:p>
-            <a:pPr algn="l"/>
-            <a:r>
-              <a:rPr sz="1300">
-                <a:solidFill>
-                  <a:srgbClr val="1A1F2E"/>
-                </a:solidFill>
-                <a:latin typeface="맑은 고딕"/>
-                <a:ea typeface="맑은 고딕"/>
-              </a:rPr>
-              <a:t>    점마다 튀는 노이즈에 휘둘리지 않고 추세를 보게 하려고</a:t>
-            </a:r>
-          </a:p>
-          <a:p>
-            <a:pPr algn="l"/>
-            <a:r>
-              <a:rPr sz="1350" b="1" i="0">
-                <a:solidFill>
-                  <a:srgbClr val="0F1E3D"/>
-                </a:solidFill>
-                <a:latin typeface="맑은 고딕"/>
-                <a:ea typeface="맑은 고딕"/>
-              </a:rPr>
-              <a:t>현재</a:t>
-            </a:r>
-          </a:p>
-          <a:p>
-            <a:pPr algn="l"/>
-            <a:r>
-              <a:rPr sz="1300">
-                <a:solidFill>
-                  <a:srgbClr val="1A1F2E"/>
-                </a:solidFill>
-                <a:latin typeface="맑은 고딕"/>
-                <a:ea typeface="맑은 고딕"/>
-              </a:rPr>
-              <a:t>    baseline은 원본 그대로, 3/5-median과 비교 중</a:t>
-            </a:r>
-          </a:p>
-        </p:txBody>
-      </p:sp>
-      <p:sp>
-        <p:nvSpPr>
-          <p:cNvPr id="8" name="TextBox 7"/>
-          <p:cNvSpPr txBox="1"/>
-          <p:nvPr/>
-        </p:nvSpPr>
-        <p:spPr>
-          <a:xfrm>
-            <a:off x="640080" y="6053328"/>
-            <a:ext cx="5303520" cy="329184"/>
-          </a:xfrm>
-          <a:prstGeom prst="rect">
-            <a:avLst/>
-          </a:prstGeom>
-          <a:noFill/>
-        </p:spPr>
-        <p:txBody>
-          <a:bodyPr wrap="square" anchor="ctr" lIns="0" rIns="0" tIns="0" bIns="0">
-            <a:spAutoFit/>
-          </a:bodyPr>
-          <a:lstStyle/>
-          <a:p>
-            <a:pPr algn="ctr"/>
-            <a:r>
-              <a:rPr sz="1250" b="1">
-                <a:solidFill>
-                  <a:srgbClr val="0F1E3D"/>
-                </a:solidFill>
-                <a:latin typeface="맑은 고딕"/>
-                <a:ea typeface="맑은 고딕"/>
-              </a:rPr>
-              <a:t>노이즈에 덜 민감하게</a:t>
-            </a:r>
-          </a:p>
-        </p:txBody>
-      </p:sp>
-      <p:sp>
-        <p:nvSpPr>
-          <p:cNvPr id="9" name="Rectangle 8"/>
-          <p:cNvSpPr/>
-          <p:nvPr/>
-        </p:nvSpPr>
-        <p:spPr>
-          <a:xfrm>
-            <a:off x="6309360" y="2642616"/>
-            <a:ext cx="5303520" cy="3383280"/>
-          </a:xfrm>
-          <a:prstGeom prst="rect">
-            <a:avLst/>
-          </a:prstGeom>
-          <a:solidFill>
-            <a:srgbClr val="FFFFFF"/>
-          </a:solidFill>
-          <a:ln w="15875">
-            <a:solidFill>
-              <a:srgbClr val="333740"/>
-            </a:solidFill>
-          </a:ln>
-          <a:effectLst/>
-        </p:spPr>
-        <p:style>
-          <a:lnRef idx="1">
-            <a:schemeClr val="accent1"/>
-          </a:lnRef>
-          <a:fillRef idx="3">
-            <a:schemeClr val="accent1"/>
-          </a:fillRef>
-          <a:effectRef idx="2">
-            <a:schemeClr val="accent1"/>
-          </a:effectRef>
-          <a:fontRef idx="minor">
-            <a:schemeClr val="lt1"/>
-          </a:fontRef>
-        </p:style>
-        <p:txBody>
-          <a:bodyPr rtlCol="0" anchor="ctr"/>
-          <a:lstStyle/>
-          <a:p>
-            <a:pPr algn="ctr"/>
-          </a:p>
-        </p:txBody>
-      </p:sp>
-      <p:sp>
-        <p:nvSpPr>
-          <p:cNvPr id="10" name="TextBox 9"/>
-          <p:cNvSpPr txBox="1"/>
-          <p:nvPr/>
-        </p:nvSpPr>
-        <p:spPr>
-          <a:xfrm>
-            <a:off x="6583680" y="2770632"/>
-            <a:ext cx="4809744" cy="3127248"/>
-          </a:xfrm>
-          <a:prstGeom prst="rect">
-            <a:avLst/>
-          </a:prstGeom>
-          <a:noFill/>
-        </p:spPr>
-        <p:txBody>
-          <a:bodyPr wrap="square" anchor="ctr" lIns="0" rIns="0" tIns="0" bIns="0">
-            <a:spAutoFit/>
-          </a:bodyPr>
-          <a:lstStyle/>
-          <a:p>
-            <a:pPr algn="l"/>
-            <a:r>
-              <a:rPr sz="1450" b="1">
-                <a:solidFill>
-                  <a:srgbClr val="0F1E3D"/>
-                </a:solidFill>
-                <a:latin typeface="맑은 고딕"/>
-                <a:ea typeface="맑은 고딕"/>
-              </a:rPr>
-              <a:t>Color / alpha shortcut 점검</a:t>
-            </a:r>
-          </a:p>
-          <a:p>
-            <a:pPr algn="l"/>
-            <a:r>
-              <a:rPr sz="500">
-                <a:solidFill>
-                  <a:srgbClr val="FFFFFF"/>
-                </a:solidFill>
-                <a:latin typeface="맑은 고딕"/>
-                <a:ea typeface="맑은 고딕"/>
-              </a:rPr>
-              <a:t> </a:t>
-            </a:r>
-          </a:p>
-          <a:p>
-            <a:pPr algn="l"/>
-            <a:r>
-              <a:rPr sz="1350" b="1" i="0">
-                <a:solidFill>
-                  <a:srgbClr val="0F1E3D"/>
-                </a:solidFill>
-                <a:latin typeface="맑은 고딕"/>
-                <a:ea typeface="맑은 고딕"/>
-              </a:rPr>
-              <a:t>무엇</a:t>
-            </a:r>
-          </a:p>
-          <a:p>
-            <a:pPr algn="l"/>
-            <a:r>
-              <a:rPr sz="1300">
-                <a:solidFill>
-                  <a:srgbClr val="1A1F2E"/>
-                </a:solidFill>
-                <a:latin typeface="맑은 고딕"/>
-                <a:ea typeface="맑은 고딕"/>
-              </a:rPr>
-              <a:t>    같은 데이터를 색과 투명도만 바꿔 렌더 (파랑/빨강, alpha 0.4/0.15)</a:t>
-            </a:r>
-          </a:p>
-          <a:p>
-            <a:pPr algn="l"/>
-            <a:r>
-              <a:rPr sz="1350" b="1" i="0">
-                <a:solidFill>
-                  <a:srgbClr val="0F1E3D"/>
-                </a:solidFill>
-                <a:latin typeface="맑은 고딕"/>
-                <a:ea typeface="맑은 고딕"/>
-              </a:rPr>
-              <a:t>왜</a:t>
-            </a:r>
-          </a:p>
-          <a:p>
-            <a:pPr algn="l"/>
-            <a:r>
-              <a:rPr sz="1300">
-                <a:solidFill>
-                  <a:srgbClr val="1A1F2E"/>
-                </a:solidFill>
-                <a:latin typeface="맑은 고딕"/>
-                <a:ea typeface="맑은 고딕"/>
-              </a:rPr>
-              <a:t>    이상 패턴을 보는지, 색이나 대비 같은 쉬운 단서에 기대는지 확인</a:t>
-            </a:r>
-          </a:p>
-          <a:p>
-            <a:pPr algn="l"/>
-            <a:r>
-              <a:rPr sz="1350" b="1" i="0">
-                <a:solidFill>
-                  <a:srgbClr val="0F1E3D"/>
-                </a:solidFill>
-                <a:latin typeface="맑은 고딕"/>
-                <a:ea typeface="맑은 고딕"/>
-              </a:rPr>
-              <a:t>판단</a:t>
-            </a:r>
-          </a:p>
-          <a:p>
-            <a:pPr algn="l"/>
-            <a:r>
-              <a:rPr sz="1300">
-                <a:solidFill>
-                  <a:srgbClr val="1A1F2E"/>
-                </a:solidFill>
-                <a:latin typeface="맑은 고딕"/>
-                <a:ea typeface="맑은 고딕"/>
-              </a:rPr>
-              <a:t>    색을 바꿔도 판정이 유지되면 패턴을 학습한 것</a:t>
-            </a:r>
-          </a:p>
-        </p:txBody>
-      </p:sp>
-      <p:sp>
-        <p:nvSpPr>
-          <p:cNvPr id="11" name="TextBox 10"/>
-          <p:cNvSpPr txBox="1"/>
-          <p:nvPr/>
-        </p:nvSpPr>
-        <p:spPr>
-          <a:xfrm>
-            <a:off x="6309360" y="6053328"/>
-            <a:ext cx="5303520" cy="329184"/>
-          </a:xfrm>
-          <a:prstGeom prst="rect">
-            <a:avLst/>
-          </a:prstGeom>
-          <a:noFill/>
-        </p:spPr>
-        <p:txBody>
-          <a:bodyPr wrap="square" anchor="ctr" lIns="0" rIns="0" tIns="0" bIns="0">
-            <a:spAutoFit/>
-          </a:bodyPr>
-          <a:lstStyle/>
-          <a:p>
-            <a:pPr algn="ctr"/>
-            <a:r>
-              <a:rPr sz="1250" b="1">
-                <a:solidFill>
-                  <a:srgbClr val="0F1E3D"/>
-                </a:solidFill>
-                <a:latin typeface="맑은 고딕"/>
-                <a:ea typeface="맑은 고딕"/>
-              </a:rPr>
-              <a:t>색이 아니라 패턴을 학습했는지</a:t>
-            </a:r>
-          </a:p>
-        </p:txBody>
-      </p:sp>
-      <p:sp>
-        <p:nvSpPr>
-          <p:cNvPr id="12" name="TextBox 11"/>
-          <p:cNvSpPr txBox="1"/>
-          <p:nvPr/>
-        </p:nvSpPr>
-        <p:spPr>
-          <a:xfrm>
-            <a:off x="457200" y="6437376"/>
-            <a:ext cx="8229600" cy="292608"/>
-          </a:xfrm>
-          <a:prstGeom prst="rect">
-            <a:avLst/>
-          </a:prstGeom>
-          <a:noFill/>
-        </p:spPr>
-        <p:txBody>
-          <a:bodyPr wrap="square" anchor="ctr" lIns="0" rIns="0" tIns="0" bIns="0">
-            <a:spAutoFit/>
-          </a:bodyPr>
-          <a:lstStyle/>
-          <a:p>
-            <a:pPr algn="l"/>
-            <a:r>
-              <a:rPr sz="900">
-                <a:solidFill>
-                  <a:srgbClr val="6B7280"/>
-                </a:solidFill>
-                <a:latin typeface="맑은 고딕"/>
-                <a:ea typeface="맑은 고딕"/>
-              </a:rPr>
-              <a:t>최호길 | QIE Data Science | AI Specialist 인증</a:t>
-            </a:r>
-          </a:p>
-        </p:txBody>
-      </p:sp>
-      <p:sp>
-        <p:nvSpPr>
-          <p:cNvPr id="13" name="TextBox 12"/>
-          <p:cNvSpPr txBox="1"/>
-          <p:nvPr/>
-        </p:nvSpPr>
-        <p:spPr>
-          <a:xfrm>
-            <a:off x="10972800" y="6437376"/>
-            <a:ext cx="758952" cy="292608"/>
-          </a:xfrm>
-          <a:prstGeom prst="rect">
-            <a:avLst/>
-          </a:prstGeom>
-          <a:noFill/>
-        </p:spPr>
-        <p:txBody>
-          <a:bodyPr wrap="square" anchor="ctr" lIns="0" rIns="0" tIns="0" bIns="0">
-            <a:spAutoFit/>
-          </a:bodyPr>
-          <a:lstStyle/>
-          <a:p>
-            <a:pPr algn="r"/>
-            <a:r>
-              <a:rPr sz="900">
-                <a:solidFill>
-                  <a:srgbClr val="6B7280"/>
-                </a:solidFill>
-                <a:latin typeface="맑은 고딕"/>
-                <a:ea typeface="맑은 고딕"/>
-              </a:rPr>
-              <a:t>8</a:t>
             </a:r>
           </a:p>
         </p:txBody>

</xml_diff>

<commit_message>
P3 slide2 — '순차 episode 생성(sequential episode generation)' framing + episode 정의 명시
episode = 자기완결 한 구간을 하나씩 완결 생성 후 다음으로 이어 붙여 trend 한 장 구성. episode가 시계열 표준어가 아니라(표준=segment/regime) 정의를 명시하고 segment 병기. 사용자와 용어 합의 반영

Co-Authored-By: Claude Opus 4.8 (1M context) <noreply@anthropic.com>
</commit_message>
<xml_diff>
--- a/recommendation/presentation/발표_P3_데이터생성_최호길.pptx
+++ b/recommendation/presentation/발표_P3_데이터생성_최호길.pptx
@@ -4051,7 +4051,7 @@
                 <a:latin typeface="맑은 고딕"/>
                 <a:ea typeface="맑은 고딕"/>
               </a:rPr>
-              <a:t>P3 | episode 생성 방식</a:t>
+              <a:t>P3 | 순차 episode 생성</a:t>
             </a:r>
           </a:p>
         </p:txBody>
@@ -4087,7 +4087,7 @@
                 <a:latin typeface="맑은 고딕"/>
                 <a:ea typeface="맑은 고딕"/>
               </a:rPr>
-              <a:t>현장 판정 기준을 episode(구간) 생성 규칙으로 옮겼다</a:t>
+              <a:t>현장 판정 기준을 순차 episode 생성 규칙으로 옮겼다</a:t>
             </a:r>
           </a:p>
         </p:txBody>
@@ -4164,7 +4164,7 @@
                 <a:latin typeface="맑은 고딕"/>
                 <a:ea typeface="맑은 고딕"/>
               </a:rPr>
-              <a:t>정상 baseline은 episode(구간)를 이어 붙여 만듭니다. episode마다 측정 밀도(밀집/희소/결핍)와 산포가 다르고, 변동은 노이즈 3종으로 재현합니다</a:t>
+              <a:t>정상 baseline은 episode(자기완결 한 구간)를 하나씩 완결 생성하고 다음으로 넘어가며 이어 붙입니다. episode마다 측정 밀도(밀집/희소/결핍)와 산포가 다르고, 변동은 노이즈 3종으로 재현합니다</a:t>
             </a:r>
           </a:p>
           <a:p>
@@ -4191,7 +4191,7 @@
                 <a:latin typeface="맑은 고딕"/>
                 <a:ea typeface="맑은 고딕"/>
               </a:rPr>
-              <a:t>episode는 사내 표현이고, 학계 표준 용어로는 piecewise-stationary / regime segment입니다</a:t>
+              <a:t>순차 episode 생성(sequential episode generation) — episode는 자기완결 한 구간(=segment), 이어 붙여 trend 한 장을 구성</a:t>
             </a:r>
           </a:p>
         </p:txBody>
@@ -4297,7 +4297,7 @@
                 <a:latin typeface="맑은 고딕"/>
                 <a:ea typeface="맑은 고딕"/>
               </a:rPr>
-              <a:t>현업(BBD / Overlay / CD) trend 판정 경험을 영역, 노이즈, 이상 규칙으로 코드화</a:t>
+              <a:t>현업(BBD / Overlay / CD) trend 판정 경험을 영역, 노이즈, 이상 규칙으로 코드화 — episode를 순차로 생성</a:t>
             </a:r>
           </a:p>
         </p:txBody>

</xml_diff>

<commit_message>
P3 slide4 → 조건별 실험 성능향상(ablation), Grad-CAM slide 삭제
slide4: anomaly-detection 단독(single-axis) 실험 결과 — baseline F1 0.9944/FN 4.6 → 정상비율↑ 0.9988, stoch depth 0.05 0.9985, label smoothing 0.02 0.9981 (5-seed). '조건 확인 시 성능이 이렇게 좋아졌다'를 F1/FN 막대로. slide5(Grad-CAM) 삭제 → 4장(제목/순차 episode/생성 데이터/조건별 실험)

사용자: 다양한 실험 결과로 조건별 성능향상 보여라, slide5 삭제

Co-Authored-By: Claude Opus 4.8 (1M context) <noreply@anthropic.com>
</commit_message>
<xml_diff>
--- a/recommendation/presentation/발표_P3_데이터생성_최호길.pptx
+++ b/recommendation/presentation/발표_P3_데이터생성_최호길.pptx
@@ -9,7 +9,6 @@
     <p:sldId id="257" r:id="rId8"/>
     <p:sldId id="258" r:id="rId9"/>
     <p:sldId id="259" r:id="rId10"/>
-    <p:sldId id="260" r:id="rId11"/>
   </p:sldIdLst>
   <p:sldSz cx="12191695" cy="6858000" type="screen4x3"/>
   <p:notesSz cx="6858000" cy="9144000"/>
@@ -4997,7 +4996,7 @@
                 <a:latin typeface="맑은 고딕"/>
                 <a:ea typeface="맑은 고딕"/>
               </a:rPr>
-              <a:t>P3 | 1차 binary gate (PoC)</a:t>
+              <a:t>P3 | 조건별 실험</a:t>
             </a:r>
           </a:p>
         </p:txBody>
@@ -5033,7 +5032,7 @@
                 <a:latin typeface="맑은 고딕"/>
                 <a:ea typeface="맑은 고딕"/>
               </a:rPr>
-              <a:t>1차 gate 검증 — test 1,500 중 놓친 불량 1건</a:t>
+              <a:t>조건별 실험으로 성능을 끌어올렸다 (F1 0.9944 → 0.9988)</a:t>
             </a:r>
           </a:p>
         </p:txBody>
@@ -5047,7 +5046,7 @@
         <p:spPr>
           <a:xfrm>
             <a:off x="640080" y="1828800"/>
-            <a:ext cx="10972800" cy="1463040"/>
+            <a:ext cx="10972800" cy="1371600"/>
           </a:xfrm>
           <a:prstGeom prst="rect">
             <a:avLst/>
@@ -5083,47 +5082,7 @@
                 <a:latin typeface="맑은 고딕"/>
                 <a:ea typeface="맑은 고딕"/>
               </a:rPr>
-              <a:t>trend 이미지를 </a:t>
-            </a:r>
-            <a:r>
-              <a:rPr sz="1400" b="1">
-                <a:solidFill>
-                  <a:srgbClr val="0F1E3D"/>
-                </a:solidFill>
-                <a:latin typeface="맑은 고딕"/>
-                <a:ea typeface="맑은 고딕"/>
-              </a:rPr>
-              <a:t>ConvNeXtV2-Tiny</a:t>
-            </a:r>
-            <a:r>
-              <a:rPr sz="1400">
-                <a:solidFill>
-                  <a:srgbClr val="1A1F2E"/>
-                </a:solidFill>
-                <a:latin typeface="맑은 고딕"/>
-                <a:ea typeface="맑은 고딕"/>
-              </a:rPr>
-              <a:t>로 정상/이상 1차 판정(Focal loss, NT 0.9). test 1,500(정상 750/불량 750)에서 </a:t>
-            </a:r>
-            <a:r>
-              <a:rPr sz="1400" b="1">
-                <a:solidFill>
-                  <a:srgbClr val="0F1E3D"/>
-                </a:solidFill>
-                <a:latin typeface="맑은 고딕"/>
-                <a:ea typeface="맑은 고딕"/>
-              </a:rPr>
-              <a:t>F1 0.9967, 이상 recall 0.9987</a:t>
-            </a:r>
-            <a:r>
-              <a:rPr sz="1400">
-                <a:solidFill>
-                  <a:srgbClr val="1A1F2E"/>
-                </a:solidFill>
-                <a:latin typeface="맑은 고딕"/>
-                <a:ea typeface="맑은 고딕"/>
-              </a:rPr>
-              <a:t> — 놓친 불량 1건(std), 정상 오경보 4건</a:t>
+              <a:t>여러 학습 조건을 단독(single-axis)으로 바꿔 5-seed로 검증했습니다 (baseline F1 0.9944, 놓친 불량 FN 4.6)</a:t>
             </a:r>
           </a:p>
           <a:p>
@@ -5150,7 +5109,87 @@
                 <a:latin typeface="맑은 고딕"/>
                 <a:ea typeface="맑은 고딕"/>
               </a:rPr>
-              <a:t>5종 이상 중 4종은 FN 0, 미세 산포(std)만 1건. NT를 올리면 FN↓ / FP↑ — 운영은 0.9 균형점. 5-seed 평균 F1 0.9975로 안정적</a:t>
+              <a:t>정상 비율↑, </a:t>
+            </a:r>
+            <a:r>
+              <a:rPr sz="1400" b="1">
+                <a:solidFill>
+                  <a:srgbClr val="0F1E3D"/>
+                </a:solidFill>
+                <a:latin typeface="맑은 고딕"/>
+                <a:ea typeface="맑은 고딕"/>
+              </a:rPr>
+              <a:t>stochastic depth 0.05</a:t>
+            </a:r>
+            <a:r>
+              <a:rPr sz="1400">
+                <a:solidFill>
+                  <a:srgbClr val="1A1F2E"/>
+                </a:solidFill>
+                <a:latin typeface="맑은 고딕"/>
+                <a:ea typeface="맑은 고딕"/>
+              </a:rPr>
+              <a:t>, </a:t>
+            </a:r>
+            <a:r>
+              <a:rPr sz="1400" b="1">
+                <a:solidFill>
+                  <a:srgbClr val="0F1E3D"/>
+                </a:solidFill>
+                <a:latin typeface="맑은 고딕"/>
+                <a:ea typeface="맑은 고딕"/>
+              </a:rPr>
+              <a:t>label smoothing 0.02</a:t>
+            </a:r>
+            <a:r>
+              <a:rPr sz="1400">
+                <a:solidFill>
+                  <a:srgbClr val="1A1F2E"/>
+                </a:solidFill>
+                <a:latin typeface="맑은 고딕"/>
+                <a:ea typeface="맑은 고딕"/>
+              </a:rPr>
+              <a:t>가 특히 효과적 — 놓친 불량을 </a:t>
+            </a:r>
+            <a:r>
+              <a:rPr sz="1400" b="1">
+                <a:solidFill>
+                  <a:srgbClr val="0F1E3D"/>
+                </a:solidFill>
+                <a:latin typeface="맑은 고딕"/>
+                <a:ea typeface="맑은 고딕"/>
+              </a:rPr>
+              <a:t>4.6 → 0.8</a:t>
+            </a:r>
+            <a:r>
+              <a:rPr sz="1400">
+                <a:solidFill>
+                  <a:srgbClr val="1A1F2E"/>
+                </a:solidFill>
+                <a:latin typeface="맑은 고딕"/>
+                <a:ea typeface="맑은 고딕"/>
+              </a:rPr>
+              <a:t>로, F1을 </a:t>
+            </a:r>
+            <a:r>
+              <a:rPr sz="1400" b="1">
+                <a:solidFill>
+                  <a:srgbClr val="0F1E3D"/>
+                </a:solidFill>
+                <a:latin typeface="맑은 고딕"/>
+                <a:ea typeface="맑은 고딕"/>
+              </a:rPr>
+              <a:t>0.9988</a:t>
+            </a:r>
+            <a:r>
+              <a:rPr sz="1400">
+                <a:solidFill>
+                  <a:srgbClr val="1A1F2E"/>
+                </a:solidFill>
+                <a:latin typeface="맑은 고딕"/>
+                <a:ea typeface="맑은 고딕"/>
+              </a:rPr>
+              <a:t>까지 올렸습니다</a:t>
             </a:r>
           </a:p>
           <a:p>
@@ -5177,7 +5216,7 @@
                 <a:latin typeface="맑은 고딕"/>
                 <a:ea typeface="맑은 고딕"/>
               </a:rPr>
-              <a:t>통과한 불량은 2차에서 유형 진단(type 정확도 0.73, 주 혼동 drift↔mean_shift)</a:t>
+              <a:t>각 막대는 단독 조건 실험. normal threshold(NT)를 올리면 FN↓ / FP↑ — 운영은 0.9 균형점</a:t>
             </a:r>
           </a:p>
         </p:txBody>
@@ -5190,8 +5229,8 @@
         </p:nvSpPr>
         <p:spPr>
           <a:xfrm>
-            <a:off x="7150608" y="3566160"/>
-            <a:ext cx="4462272" cy="384048"/>
+            <a:off x="7406640" y="3474720"/>
+            <a:ext cx="4206240" cy="384048"/>
           </a:xfrm>
           <a:prstGeom prst="roundRect">
             <a:avLst/>
@@ -5234,7 +5273,7 @@
         </p:nvSpPr>
         <p:spPr>
           <a:xfrm>
-            <a:off x="7150608" y="3566160"/>
+            <a:off x="7406640" y="3474720"/>
             <a:ext cx="82296" cy="384048"/>
           </a:xfrm>
           <a:prstGeom prst="rect">
@@ -5278,8 +5317,8 @@
         </p:nvSpPr>
         <p:spPr>
           <a:xfrm>
-            <a:off x="7333488" y="3566160"/>
-            <a:ext cx="4133088" cy="384048"/>
+            <a:off x="7589520" y="3474720"/>
+            <a:ext cx="3877056" cy="384048"/>
           </a:xfrm>
           <a:prstGeom prst="rect">
             <a:avLst/>
@@ -5301,7 +5340,7 @@
                 <a:latin typeface="맑은 고딕"/>
                 <a:ea typeface="맑은 고딕"/>
               </a:rPr>
-              <a:t>F1 0.9967 / recall 0.9987 (생성셋 PoC)</a:t>
+              <a:t>F1 0.9944 → 0.9988 / FN 4.6 → 0.8</a:t>
             </a:r>
           </a:p>
         </p:txBody>
@@ -5314,8 +5353,8 @@
         </p:nvSpPr>
         <p:spPr>
           <a:xfrm>
-            <a:off x="2486566" y="3996072"/>
-            <a:ext cx="7279827" cy="1956528"/>
+            <a:off x="2858146" y="3904632"/>
+            <a:ext cx="6536668" cy="2047968"/>
           </a:xfrm>
           <a:prstGeom prst="rect">
             <a:avLst/>
@@ -5354,7 +5393,7 @@
       </p:sp>
       <p:pic>
         <p:nvPicPr>
-          <p:cNvPr id="10" name="Picture 9" descr="p3_deck_result.png"/>
+          <p:cNvPr id="10" name="Picture 9" descr="p3_deck_ablation.png"/>
           <p:cNvPicPr>
             <a:picLocks noChangeAspect="1"/>
           </p:cNvPicPr>
@@ -5368,8 +5407,8 @@
         </p:blipFill>
         <p:spPr>
           <a:xfrm>
-            <a:off x="2495566" y="4005072"/>
-            <a:ext cx="7261827" cy="1938528"/>
+            <a:off x="2867146" y="3913632"/>
+            <a:ext cx="6518668" cy="2029968"/>
           </a:xfrm>
           <a:prstGeom prst="rect">
             <a:avLst/>
@@ -5407,7 +5446,7 @@
                 <a:latin typeface="맑은 고딕"/>
                 <a:ea typeface="맑은 고딕"/>
               </a:rPr>
-              <a:t>좌 confusion(test 1,500 대표 run) / 중 NT trade-off(319-run 평균) / 우 유형별 오류</a:t>
+              <a:t>binary F1(좌)과 놓친 불량 FN(우) — 점선 = baseline, 막대 = 각 조건 단독 적용 (5-seed 평균)</a:t>
             </a:r>
           </a:p>
         </p:txBody>
@@ -5480,376 +5519,6 @@
                 <a:ea typeface="맑은 고딕"/>
               </a:rPr>
               <a:t>4</a:t>
-            </a:r>
-          </a:p>
-        </p:txBody>
-      </p:sp>
-    </p:spTree>
-  </p:cSld>
-  <p:clrMapOvr>
-    <a:masterClrMapping/>
-  </p:clrMapOvr>
-</p:sld>
-</file>
-
-<file path=ppt/slides/slide5.xml><?xml version="1.0" encoding="utf-8"?>
-<p:sld xmlns:a="http://schemas.openxmlformats.org/drawingml/2006/main" xmlns:p="http://schemas.openxmlformats.org/presentationml/2006/main" xmlns:r="http://schemas.openxmlformats.org/officeDocument/2006/relationships">
-  <p:cSld>
-    <p:bg>
-      <p:bgPr>
-        <a:solidFill>
-          <a:srgbClr val="FFFFFF"/>
-        </a:solidFill>
-        <a:effectLst/>
-      </p:bgPr>
-    </p:bg>
-    <p:spTree>
-      <p:nvGrpSpPr>
-        <p:cNvPr id="1" name=""/>
-        <p:cNvGrpSpPr/>
-        <p:nvPr/>
-      </p:nvGrpSpPr>
-      <p:grpSpPr/>
-      <p:sp>
-        <p:nvSpPr>
-          <p:cNvPr id="2" name="Rectangle 1"/>
-          <p:cNvSpPr/>
-          <p:nvPr/>
-        </p:nvSpPr>
-        <p:spPr>
-          <a:xfrm>
-            <a:off x="640080" y="502920"/>
-            <a:ext cx="123444" cy="768096"/>
-          </a:xfrm>
-          <a:prstGeom prst="rect">
-            <a:avLst/>
-          </a:prstGeom>
-          <a:solidFill>
-            <a:srgbClr val="CFD4DB"/>
-          </a:solidFill>
-          <a:ln>
-            <a:noFill/>
-          </a:ln>
-          <a:effectLst/>
-        </p:spPr>
-        <p:style>
-          <a:lnRef idx="1">
-            <a:schemeClr val="accent1"/>
-          </a:lnRef>
-          <a:fillRef idx="3">
-            <a:schemeClr val="accent1"/>
-          </a:fillRef>
-          <a:effectRef idx="2">
-            <a:schemeClr val="accent1"/>
-          </a:effectRef>
-          <a:fontRef idx="minor">
-            <a:schemeClr val="lt1"/>
-          </a:fontRef>
-        </p:style>
-        <p:txBody>
-          <a:bodyPr rtlCol="0" anchor="ctr"/>
-          <a:lstStyle/>
-          <a:p>
-            <a:pPr algn="ctr"/>
-          </a:p>
-        </p:txBody>
-      </p:sp>
-      <p:sp>
-        <p:nvSpPr>
-          <p:cNvPr id="3" name="TextBox 2"/>
-          <p:cNvSpPr txBox="1"/>
-          <p:nvPr/>
-        </p:nvSpPr>
-        <p:spPr>
-          <a:xfrm>
-            <a:off x="932688" y="448056"/>
-            <a:ext cx="10881360" cy="256032"/>
-          </a:xfrm>
-          <a:prstGeom prst="rect">
-            <a:avLst/>
-          </a:prstGeom>
-          <a:noFill/>
-        </p:spPr>
-        <p:txBody>
-          <a:bodyPr wrap="square" anchor="t" lIns="0" rIns="0" tIns="0" bIns="0">
-            <a:spAutoFit/>
-          </a:bodyPr>
-          <a:lstStyle/>
-          <a:p>
-            <a:pPr algn="l"/>
-            <a:r>
-              <a:rPr sz="1300" b="1">
-                <a:solidFill>
-                  <a:srgbClr val="8A929E"/>
-                </a:solidFill>
-                <a:latin typeface="맑은 고딕"/>
-                <a:ea typeface="맑은 고딕"/>
-              </a:rPr>
-              <a:t>P3 | 모델 근거 (Grad-CAM)</a:t>
-            </a:r>
-          </a:p>
-        </p:txBody>
-      </p:sp>
-      <p:sp>
-        <p:nvSpPr>
-          <p:cNvPr id="4" name="TextBox 3"/>
-          <p:cNvSpPr txBox="1"/>
-          <p:nvPr/>
-        </p:nvSpPr>
-        <p:spPr>
-          <a:xfrm>
-            <a:off x="932688" y="704088"/>
-            <a:ext cx="10881360" cy="603504"/>
-          </a:xfrm>
-          <a:prstGeom prst="rect">
-            <a:avLst/>
-          </a:prstGeom>
-          <a:noFill/>
-        </p:spPr>
-        <p:txBody>
-          <a:bodyPr wrap="square" anchor="t" lIns="0" rIns="0" tIns="0" bIns="0">
-            <a:spAutoFit/>
-          </a:bodyPr>
-          <a:lstStyle/>
-          <a:p>
-            <a:pPr algn="l"/>
-            <a:r>
-              <a:rPr sz="3100" b="1">
-                <a:solidFill>
-                  <a:srgbClr val="0F1E3D"/>
-                </a:solidFill>
-                <a:latin typeface="맑은 고딕"/>
-                <a:ea typeface="맑은 고딕"/>
-              </a:rPr>
-              <a:t>모델이 색이 아니라 이상 구간을 본다</a:t>
-            </a:r>
-          </a:p>
-        </p:txBody>
-      </p:sp>
-      <p:sp>
-        <p:nvSpPr>
-          <p:cNvPr id="5" name="TextBox 4"/>
-          <p:cNvSpPr txBox="1"/>
-          <p:nvPr/>
-        </p:nvSpPr>
-        <p:spPr>
-          <a:xfrm>
-            <a:off x="640080" y="1828800"/>
-            <a:ext cx="10972800" cy="566928"/>
-          </a:xfrm>
-          <a:prstGeom prst="rect">
-            <a:avLst/>
-          </a:prstGeom>
-          <a:noFill/>
-        </p:spPr>
-        <p:txBody>
-          <a:bodyPr wrap="square" anchor="t" lIns="0" rIns="0" tIns="0" bIns="0">
-            <a:spAutoFit/>
-          </a:bodyPr>
-          <a:lstStyle/>
-          <a:p>
-            <a:pPr marL="274320" indent="-274320">
-              <a:spcAft>
-                <a:spcPts val="500"/>
-              </a:spcAft>
-            </a:pPr>
-            <a:r>
-              <a:rPr sz="1450" b="0">
-                <a:solidFill>
-                  <a:srgbClr val="5B9BD5"/>
-                </a:solidFill>
-                <a:latin typeface="맑은 고딕"/>
-                <a:ea typeface="맑은 고딕"/>
-              </a:rPr>
-              <a:t>●  </a:t>
-            </a:r>
-            <a:r>
-              <a:rPr sz="1450">
-                <a:solidFill>
-                  <a:srgbClr val="1A1F2E"/>
-                </a:solidFill>
-                <a:latin typeface="맑은 고딕"/>
-                <a:ea typeface="맑은 고딕"/>
-              </a:rPr>
-              <a:t>Grad-CAM으로 보면 mean shift/std/spike/drift는 trend 오른쪽 끝(이상 구간), context는 전체에 모델 주목이 집중됩니다 — 색이나 대비가 아니라 실제 패턴을 학습</a:t>
-            </a:r>
-          </a:p>
-        </p:txBody>
-      </p:sp>
-      <p:sp>
-        <p:nvSpPr>
-          <p:cNvPr id="6" name="Rectangle 5"/>
-          <p:cNvSpPr/>
-          <p:nvPr/>
-        </p:nvSpPr>
-        <p:spPr>
-          <a:xfrm>
-            <a:off x="3984768" y="2514744"/>
-            <a:ext cx="4283424" cy="3437856"/>
-          </a:xfrm>
-          <a:prstGeom prst="rect">
-            <a:avLst/>
-          </a:prstGeom>
-          <a:solidFill>
-            <a:srgbClr val="FFFFFF"/>
-          </a:solidFill>
-          <a:ln w="12700">
-            <a:solidFill>
-              <a:srgbClr val="D7DEEA"/>
-            </a:solidFill>
-          </a:ln>
-          <a:effectLst/>
-        </p:spPr>
-        <p:style>
-          <a:lnRef idx="1">
-            <a:schemeClr val="accent1"/>
-          </a:lnRef>
-          <a:fillRef idx="3">
-            <a:schemeClr val="accent1"/>
-          </a:fillRef>
-          <a:effectRef idx="2">
-            <a:schemeClr val="accent1"/>
-          </a:effectRef>
-          <a:fontRef idx="minor">
-            <a:schemeClr val="lt1"/>
-          </a:fontRef>
-        </p:style>
-        <p:txBody>
-          <a:bodyPr rtlCol="0" anchor="ctr"/>
-          <a:lstStyle/>
-          <a:p>
-            <a:pPr algn="ctr"/>
-          </a:p>
-        </p:txBody>
-      </p:sp>
-      <p:pic>
-        <p:nvPicPr>
-          <p:cNvPr id="7" name="Picture 6" descr="p3_res_gradcam.png"/>
-          <p:cNvPicPr>
-            <a:picLocks noChangeAspect="1"/>
-          </p:cNvPicPr>
-          <p:nvPr/>
-        </p:nvPicPr>
-        <p:blipFill>
-          <a:blip r:embed="rId2"/>
-          <a:stretch>
-            <a:fillRect/>
-          </a:stretch>
-        </p:blipFill>
-        <p:spPr>
-          <a:xfrm>
-            <a:off x="3993768" y="2523744"/>
-            <a:ext cx="4265424" cy="3419856"/>
-          </a:xfrm>
-          <a:prstGeom prst="rect">
-            <a:avLst/>
-          </a:prstGeom>
-        </p:spPr>
-      </p:pic>
-      <p:sp>
-        <p:nvSpPr>
-          <p:cNvPr id="8" name="TextBox 7"/>
-          <p:cNvSpPr txBox="1"/>
-          <p:nvPr/>
-        </p:nvSpPr>
-        <p:spPr>
-          <a:xfrm>
-            <a:off x="640080" y="5961888"/>
-            <a:ext cx="10972800" cy="274320"/>
-          </a:xfrm>
-          <a:prstGeom prst="rect">
-            <a:avLst/>
-          </a:prstGeom>
-          <a:noFill/>
-        </p:spPr>
-        <p:txBody>
-          <a:bodyPr wrap="square" anchor="t" lIns="0" rIns="0" tIns="0" bIns="0">
-            <a:spAutoFit/>
-          </a:bodyPr>
-          <a:lstStyle/>
-          <a:p>
-            <a:pPr algn="ctr"/>
-            <a:r>
-              <a:rPr sz="1300">
-                <a:solidFill>
-                  <a:srgbClr val="3A485C"/>
-                </a:solidFill>
-                <a:latin typeface="맑은 고딕"/>
-                <a:ea typeface="맑은 고딕"/>
-              </a:rPr>
-              <a:t>클래스별(정상 + 이상 5종) Grad-CAM — 빨강일수록 모델이 강하게 주목한 영역 (실제 학습 결과)</a:t>
-            </a:r>
-          </a:p>
-        </p:txBody>
-      </p:sp>
-      <p:sp>
-        <p:nvSpPr>
-          <p:cNvPr id="9" name="TextBox 8"/>
-          <p:cNvSpPr txBox="1"/>
-          <p:nvPr/>
-        </p:nvSpPr>
-        <p:spPr>
-          <a:xfrm>
-            <a:off x="457200" y="6437376"/>
-            <a:ext cx="8229600" cy="292608"/>
-          </a:xfrm>
-          <a:prstGeom prst="rect">
-            <a:avLst/>
-          </a:prstGeom>
-          <a:noFill/>
-        </p:spPr>
-        <p:txBody>
-          <a:bodyPr wrap="square" anchor="ctr" lIns="0" rIns="0" tIns="0" bIns="0">
-            <a:spAutoFit/>
-          </a:bodyPr>
-          <a:lstStyle/>
-          <a:p>
-            <a:pPr algn="l"/>
-            <a:r>
-              <a:rPr sz="900">
-                <a:solidFill>
-                  <a:srgbClr val="6B7280"/>
-                </a:solidFill>
-                <a:latin typeface="맑은 고딕"/>
-                <a:ea typeface="맑은 고딕"/>
-              </a:rPr>
-              <a:t>최호길 | QIE Data Science | AI Specialist 인증</a:t>
-            </a:r>
-          </a:p>
-        </p:txBody>
-      </p:sp>
-      <p:sp>
-        <p:nvSpPr>
-          <p:cNvPr id="10" name="TextBox 9"/>
-          <p:cNvSpPr txBox="1"/>
-          <p:nvPr/>
-        </p:nvSpPr>
-        <p:spPr>
-          <a:xfrm>
-            <a:off x="10972800" y="6437376"/>
-            <a:ext cx="758952" cy="292608"/>
-          </a:xfrm>
-          <a:prstGeom prst="rect">
-            <a:avLst/>
-          </a:prstGeom>
-          <a:noFill/>
-        </p:spPr>
-        <p:txBody>
-          <a:bodyPr wrap="square" anchor="ctr" lIns="0" rIns="0" tIns="0" bIns="0">
-            <a:spAutoFit/>
-          </a:bodyPr>
-          <a:lstStyle/>
-          <a:p>
-            <a:pPr algn="r"/>
-            <a:r>
-              <a:rPr sz="900">
-                <a:solidFill>
-                  <a:srgbClr val="6B7280"/>
-                </a:solidFill>
-                <a:latin typeface="맑은 고딕"/>
-                <a:ea typeface="맑은 고딕"/>
-              </a:rPr>
-              <a:t>5</a:t>
             </a:r>
           </a:p>
         </p:txBody>

</xml_diff>

<commit_message>
P3 결과 = 단변수 BKM 표 + backbone sweep + progression (cross_dataset 디자인 복제)
단변수 BKM bar→표(navy 헤더, 정상비율 best 강조, color/smoothing 포함, baseline 기준행). slide5 신설: generate_cross_dataset_report.py 의 cross_dataset_overall(baseline→BKM combined→best backbone, F1/FN/FP mean, 색 #4878CF/#E43320/#F5B041) 디자인 그대로 복제 + backbone sweep(6종 동일 디자인). 백본/통합 BKM/best backbone 수치는 임시(실측 입력 대기)로 명시.

사용자: bar 지저분→표, backbone sweep+progression 을 plot 코드 디자인 똑같이, 갈수록 올라가게

Co-Authored-By: Claude Opus 4.8 (1M context) <noreply@anthropic.com>
</commit_message>
<xml_diff>
--- a/recommendation/presentation/발표_P3_데이터생성_최호길.pptx
+++ b/recommendation/presentation/발표_P3_데이터생성_최호길.pptx
@@ -9,6 +9,7 @@
     <p:sldId id="257" r:id="rId8"/>
     <p:sldId id="258" r:id="rId9"/>
     <p:sldId id="259" r:id="rId10"/>
+    <p:sldId id="260" r:id="rId11"/>
   </p:sldIdLst>
   <p:sldSz cx="12191695" cy="6858000" type="screen4x3"/>
   <p:notesSz cx="6858000" cy="9144000"/>
@@ -12717,7 +12718,7 @@
                 <a:latin typeface="맑은 고딕"/>
                 <a:ea typeface="맑은 고딕"/>
               </a:rPr>
-              <a:t>P3 | 결과</a:t>
+              <a:t>P3 | 결과 ①</a:t>
             </a:r>
           </a:p>
         </p:txBody>
@@ -12753,7 +12754,7 @@
                 <a:latin typeface="맑은 고딕"/>
                 <a:ea typeface="맑은 고딕"/>
               </a:rPr>
-              <a:t>단변수 반복 실험으로 조건별 BKM 확보 — 백본·데이터셋·운영 검증</a:t>
+              <a:t>단변수 반복 실험 — 조건별 BKM 정리 (각 5-seed)</a:t>
             </a:r>
           </a:p>
         </p:txBody>
@@ -12767,7 +12768,7 @@
         <p:spPr>
           <a:xfrm>
             <a:off x="640080" y="1828800"/>
-            <a:ext cx="10972800" cy="896112"/>
+            <a:ext cx="10972800" cy="713232"/>
           </a:xfrm>
           <a:prstGeom prst="rect">
             <a:avLst/>
@@ -12803,7 +12804,7 @@
                 <a:latin typeface="맑은 고딕"/>
                 <a:ea typeface="맑은 고딕"/>
               </a:rPr>
-              <a:t>각 학습 조건을 한 번에 하나씩만 변경하는 단변수(single-axis) 방식으로 5-seed 반복 평가를 수행하고, 축별 최적값을 BKM(Best Known Method)으로 정리하였습니다. 정상 비율 축에서 F1 0.9944→</a:t>
+              <a:t>각 학습 조건을 한 번에 하나씩만 변경하는 단변수(single-axis) 방식으로 5-seed 반복 평가하고, 축별 최적값을 BKM(Best Known Method)으로 정리하였습니다. 정상 비율 축에서 F1 0.9944→</a:t>
             </a:r>
             <a:r>
               <a:rPr sz="1450" b="1">
@@ -12823,7 +12824,7 @@
                 <a:latin typeface="맑은 고딕"/>
                 <a:ea typeface="맑은 고딕"/>
               </a:rPr>
-              <a:t>, 놓친 불량 4.6→0.8로 가장 큰 개선을 확인하였으며, 백본·데이터셋·운영 임계값까지 동일 프로토콜로 비교하였습니다</a:t>
+              <a:t>, 놓친 불량 4.6→0.8로 가장 큰 개선을 확인하였습니다</a:t>
             </a:r>
           </a:p>
         </p:txBody>
@@ -12836,8 +12837,8 @@
         </p:nvSpPr>
         <p:spPr>
           <a:xfrm>
-            <a:off x="1778652" y="2843928"/>
-            <a:ext cx="8695656" cy="3108672"/>
+            <a:off x="2175138" y="2661048"/>
+            <a:ext cx="7902684" cy="3291552"/>
           </a:xfrm>
           <a:prstGeom prst="rect">
             <a:avLst/>
@@ -12876,7 +12877,7 @@
       </p:sp>
       <p:pic>
         <p:nvPicPr>
-          <p:cNvPr id="7" name="Picture 6" descr="p3_bkm.png"/>
+          <p:cNvPr id="7" name="Picture 6" descr="p3_bkm_table.png"/>
           <p:cNvPicPr>
             <a:picLocks noChangeAspect="1"/>
           </p:cNvPicPr>
@@ -12890,8 +12891,8 @@
         </p:blipFill>
         <p:spPr>
           <a:xfrm>
-            <a:off x="1787652" y="2852928"/>
-            <a:ext cx="8677656" cy="3090672"/>
+            <a:off x="2184138" y="2670048"/>
+            <a:ext cx="7884684" cy="3273552"/>
           </a:xfrm>
           <a:prstGeom prst="rect">
             <a:avLst/>
@@ -12929,7 +12930,7 @@
                 <a:latin typeface="맑은 고딕"/>
                 <a:ea typeface="맑은 고딕"/>
               </a:rPr>
-              <a:t>단변수 11축 각 5-seed 반복 · baseline F1 0.9975 (0.9940–0.9993) 반복 안정 · 축별 best 를 합친 통합 BKM 은 GPU 확보 후 진행 · 2-stage 유형분류 pilot 0.73</a:t>
+              <a:t>총 11개 축 각 5-seed 반복 · * smoothing 은 3-seed pilot · 축별 best 를 합친 통합 BKM 은 다음 장</a:t>
             </a:r>
           </a:p>
         </p:txBody>
@@ -13002,6 +13003,518 @@
                 <a:ea typeface="맑은 고딕"/>
               </a:rPr>
               <a:t>4</a:t>
+            </a:r>
+          </a:p>
+        </p:txBody>
+      </p:sp>
+    </p:spTree>
+  </p:cSld>
+  <p:clrMapOvr>
+    <a:masterClrMapping/>
+  </p:clrMapOvr>
+</p:sld>
+</file>
+
+<file path=ppt/slides/slide5.xml><?xml version="1.0" encoding="utf-8"?>
+<p:sld xmlns:a="http://schemas.openxmlformats.org/drawingml/2006/main" xmlns:p="http://schemas.openxmlformats.org/presentationml/2006/main" xmlns:r="http://schemas.openxmlformats.org/officeDocument/2006/relationships">
+  <p:cSld>
+    <p:bg>
+      <p:bgPr>
+        <a:solidFill>
+          <a:srgbClr val="FFFFFF"/>
+        </a:solidFill>
+        <a:effectLst/>
+      </p:bgPr>
+    </p:bg>
+    <p:spTree>
+      <p:nvGrpSpPr>
+        <p:cNvPr id="1" name=""/>
+        <p:cNvGrpSpPr/>
+        <p:nvPr/>
+      </p:nvGrpSpPr>
+      <p:grpSpPr/>
+      <p:sp>
+        <p:nvSpPr>
+          <p:cNvPr id="2" name="Rectangle 1"/>
+          <p:cNvSpPr/>
+          <p:nvPr/>
+        </p:nvSpPr>
+        <p:spPr>
+          <a:xfrm>
+            <a:off x="640080" y="502920"/>
+            <a:ext cx="123444" cy="768096"/>
+          </a:xfrm>
+          <a:prstGeom prst="rect">
+            <a:avLst/>
+          </a:prstGeom>
+          <a:solidFill>
+            <a:srgbClr val="CFD4DB"/>
+          </a:solidFill>
+          <a:ln>
+            <a:noFill/>
+          </a:ln>
+          <a:effectLst/>
+        </p:spPr>
+        <p:style>
+          <a:lnRef idx="1">
+            <a:schemeClr val="accent1"/>
+          </a:lnRef>
+          <a:fillRef idx="3">
+            <a:schemeClr val="accent1"/>
+          </a:fillRef>
+          <a:effectRef idx="2">
+            <a:schemeClr val="accent1"/>
+          </a:effectRef>
+          <a:fontRef idx="minor">
+            <a:schemeClr val="lt1"/>
+          </a:fontRef>
+        </p:style>
+        <p:txBody>
+          <a:bodyPr rtlCol="0" anchor="ctr"/>
+          <a:lstStyle/>
+          <a:p>
+            <a:pPr algn="ctr"/>
+          </a:p>
+        </p:txBody>
+      </p:sp>
+      <p:sp>
+        <p:nvSpPr>
+          <p:cNvPr id="3" name="TextBox 2"/>
+          <p:cNvSpPr txBox="1"/>
+          <p:nvPr/>
+        </p:nvSpPr>
+        <p:spPr>
+          <a:xfrm>
+            <a:off x="932688" y="448056"/>
+            <a:ext cx="10881360" cy="256032"/>
+          </a:xfrm>
+          <a:prstGeom prst="rect">
+            <a:avLst/>
+          </a:prstGeom>
+          <a:noFill/>
+        </p:spPr>
+        <p:txBody>
+          <a:bodyPr wrap="square" anchor="t" lIns="0" rIns="0" tIns="0" bIns="0">
+            <a:spAutoFit/>
+          </a:bodyPr>
+          <a:lstStyle/>
+          <a:p>
+            <a:pPr algn="l"/>
+            <a:r>
+              <a:rPr sz="1300" b="1">
+                <a:solidFill>
+                  <a:srgbClr val="8A929E"/>
+                </a:solidFill>
+                <a:latin typeface="맑은 고딕"/>
+                <a:ea typeface="맑은 고딕"/>
+              </a:rPr>
+              <a:t>P3 | 결과 ②</a:t>
+            </a:r>
+          </a:p>
+        </p:txBody>
+      </p:sp>
+      <p:sp>
+        <p:nvSpPr>
+          <p:cNvPr id="4" name="TextBox 3"/>
+          <p:cNvSpPr txBox="1"/>
+          <p:nvPr/>
+        </p:nvSpPr>
+        <p:spPr>
+          <a:xfrm>
+            <a:off x="932688" y="704088"/>
+            <a:ext cx="10881360" cy="603504"/>
+          </a:xfrm>
+          <a:prstGeom prst="rect">
+            <a:avLst/>
+          </a:prstGeom>
+          <a:noFill/>
+        </p:spPr>
+        <p:txBody>
+          <a:bodyPr wrap="square" anchor="t" lIns="0" rIns="0" tIns="0" bIns="0">
+            <a:spAutoFit/>
+          </a:bodyPr>
+          <a:lstStyle/>
+          <a:p>
+            <a:pPr algn="l"/>
+            <a:r>
+              <a:rPr sz="3100" b="1">
+                <a:solidFill>
+                  <a:srgbClr val="0F1E3D"/>
+                </a:solidFill>
+                <a:latin typeface="맑은 고딕"/>
+                <a:ea typeface="맑은 고딕"/>
+              </a:rPr>
+              <a:t>백본 비교와 누적 개선 — baseline → BKM → best backbone</a:t>
+            </a:r>
+          </a:p>
+        </p:txBody>
+      </p:sp>
+      <p:sp>
+        <p:nvSpPr>
+          <p:cNvPr id="5" name="TextBox 4"/>
+          <p:cNvSpPr txBox="1"/>
+          <p:nvPr/>
+        </p:nvSpPr>
+        <p:spPr>
+          <a:xfrm>
+            <a:off x="640080" y="1828800"/>
+            <a:ext cx="10972800" cy="566928"/>
+          </a:xfrm>
+          <a:prstGeom prst="rect">
+            <a:avLst/>
+          </a:prstGeom>
+          <a:noFill/>
+        </p:spPr>
+        <p:txBody>
+          <a:bodyPr wrap="square" anchor="t" lIns="0" rIns="0" tIns="0" bIns="0">
+            <a:spAutoFit/>
+          </a:bodyPr>
+          <a:lstStyle/>
+          <a:p>
+            <a:pPr marL="274320" indent="-274320">
+              <a:spcAft>
+                <a:spcPts val="500"/>
+              </a:spcAft>
+            </a:pPr>
+            <a:r>
+              <a:rPr sz="1450" b="0">
+                <a:solidFill>
+                  <a:srgbClr val="96A0AD"/>
+                </a:solidFill>
+                <a:latin typeface="맑은 고딕"/>
+                <a:ea typeface="맑은 고딕"/>
+              </a:rPr>
+              <a:t>●  </a:t>
+            </a:r>
+            <a:r>
+              <a:rPr sz="1450">
+                <a:solidFill>
+                  <a:srgbClr val="1A1F2E"/>
+                </a:solidFill>
+                <a:latin typeface="맑은 고딕"/>
+                <a:ea typeface="맑은 고딕"/>
+              </a:rPr>
+              <a:t>동일 데이터와 프로토콜에서 백본을 교체하며 비교하고(backbone sweep), baseline 에 단변수 BKM 을 누적 적용한 뒤 최적 백본까지 반영했을 때의 단계별 성능을 정리하였습니다</a:t>
+            </a:r>
+          </a:p>
+        </p:txBody>
+      </p:sp>
+      <p:sp>
+        <p:nvSpPr>
+          <p:cNvPr id="6" name="Rectangle 5"/>
+          <p:cNvSpPr/>
+          <p:nvPr/>
+        </p:nvSpPr>
+        <p:spPr>
+          <a:xfrm>
+            <a:off x="4029718" y="2514744"/>
+            <a:ext cx="4193523" cy="1170144"/>
+          </a:xfrm>
+          <a:prstGeom prst="rect">
+            <a:avLst/>
+          </a:prstGeom>
+          <a:solidFill>
+            <a:srgbClr val="FFFFFF"/>
+          </a:solidFill>
+          <a:ln w="12700">
+            <a:solidFill>
+              <a:srgbClr val="D7DEEA"/>
+            </a:solidFill>
+          </a:ln>
+          <a:effectLst/>
+        </p:spPr>
+        <p:style>
+          <a:lnRef idx="1">
+            <a:schemeClr val="accent1"/>
+          </a:lnRef>
+          <a:fillRef idx="3">
+            <a:schemeClr val="accent1"/>
+          </a:fillRef>
+          <a:effectRef idx="2">
+            <a:schemeClr val="accent1"/>
+          </a:effectRef>
+          <a:fontRef idx="minor">
+            <a:schemeClr val="lt1"/>
+          </a:fontRef>
+        </p:style>
+        <p:txBody>
+          <a:bodyPr rtlCol="0" anchor="ctr"/>
+          <a:lstStyle/>
+          <a:p>
+            <a:pPr algn="ctr"/>
+          </a:p>
+        </p:txBody>
+      </p:sp>
+      <p:pic>
+        <p:nvPicPr>
+          <p:cNvPr id="7" name="Picture 6" descr="p3_backbone.png"/>
+          <p:cNvPicPr>
+            <a:picLocks noChangeAspect="1"/>
+          </p:cNvPicPr>
+          <p:nvPr/>
+        </p:nvPicPr>
+        <p:blipFill>
+          <a:blip r:embed="rId2"/>
+          <a:stretch>
+            <a:fillRect/>
+          </a:stretch>
+        </p:blipFill>
+        <p:spPr>
+          <a:xfrm>
+            <a:off x="4038718" y="2523744"/>
+            <a:ext cx="4175523" cy="1152144"/>
+          </a:xfrm>
+          <a:prstGeom prst="rect">
+            <a:avLst/>
+          </a:prstGeom>
+        </p:spPr>
+      </p:pic>
+      <p:sp>
+        <p:nvSpPr>
+          <p:cNvPr id="8" name="TextBox 7"/>
+          <p:cNvSpPr txBox="1"/>
+          <p:nvPr/>
+        </p:nvSpPr>
+        <p:spPr>
+          <a:xfrm>
+            <a:off x="3869554" y="3767328"/>
+            <a:ext cx="4513851" cy="329184"/>
+          </a:xfrm>
+          <a:prstGeom prst="rect">
+            <a:avLst/>
+          </a:prstGeom>
+          <a:noFill/>
+        </p:spPr>
+        <p:txBody>
+          <a:bodyPr wrap="square" anchor="ctr" lIns="0" rIns="0" tIns="0" bIns="0">
+            <a:spAutoFit/>
+          </a:bodyPr>
+          <a:lstStyle/>
+          <a:p>
+            <a:pPr algn="ctr"/>
+            <a:r>
+              <a:rPr sz="1450" b="1">
+                <a:solidFill>
+                  <a:srgbClr val="0F1E3D"/>
+                </a:solidFill>
+                <a:latin typeface="맑은 고딕"/>
+                <a:ea typeface="맑은 고딕"/>
+              </a:rPr>
+              <a:t>Backbone sweep — 백본별 F1 / FN / FP</a:t>
+            </a:r>
+          </a:p>
+        </p:txBody>
+      </p:sp>
+      <p:sp>
+        <p:nvSpPr>
+          <p:cNvPr id="9" name="Rectangle 8"/>
+          <p:cNvSpPr/>
+          <p:nvPr/>
+        </p:nvSpPr>
+        <p:spPr>
+          <a:xfrm>
+            <a:off x="4029718" y="4361832"/>
+            <a:ext cx="4193523" cy="1170144"/>
+          </a:xfrm>
+          <a:prstGeom prst="rect">
+            <a:avLst/>
+          </a:prstGeom>
+          <a:solidFill>
+            <a:srgbClr val="FFFFFF"/>
+          </a:solidFill>
+          <a:ln w="12700">
+            <a:solidFill>
+              <a:srgbClr val="D7DEEA"/>
+            </a:solidFill>
+          </a:ln>
+          <a:effectLst/>
+        </p:spPr>
+        <p:style>
+          <a:lnRef idx="1">
+            <a:schemeClr val="accent1"/>
+          </a:lnRef>
+          <a:fillRef idx="3">
+            <a:schemeClr val="accent1"/>
+          </a:fillRef>
+          <a:effectRef idx="2">
+            <a:schemeClr val="accent1"/>
+          </a:effectRef>
+          <a:fontRef idx="minor">
+            <a:schemeClr val="lt1"/>
+          </a:fontRef>
+        </p:style>
+        <p:txBody>
+          <a:bodyPr rtlCol="0" anchor="ctr"/>
+          <a:lstStyle/>
+          <a:p>
+            <a:pPr algn="ctr"/>
+          </a:p>
+        </p:txBody>
+      </p:sp>
+      <p:pic>
+        <p:nvPicPr>
+          <p:cNvPr id="10" name="Picture 9" descr="p3_progression.png"/>
+          <p:cNvPicPr>
+            <a:picLocks noChangeAspect="1"/>
+          </p:cNvPicPr>
+          <p:nvPr/>
+        </p:nvPicPr>
+        <p:blipFill>
+          <a:blip r:embed="rId3"/>
+          <a:stretch>
+            <a:fillRect/>
+          </a:stretch>
+        </p:blipFill>
+        <p:spPr>
+          <a:xfrm>
+            <a:off x="4038718" y="4370832"/>
+            <a:ext cx="4175523" cy="1152144"/>
+          </a:xfrm>
+          <a:prstGeom prst="rect">
+            <a:avLst/>
+          </a:prstGeom>
+        </p:spPr>
+      </p:pic>
+      <p:sp>
+        <p:nvSpPr>
+          <p:cNvPr id="11" name="TextBox 10"/>
+          <p:cNvSpPr txBox="1"/>
+          <p:nvPr/>
+        </p:nvSpPr>
+        <p:spPr>
+          <a:xfrm>
+            <a:off x="3869554" y="5614416"/>
+            <a:ext cx="4513851" cy="329184"/>
+          </a:xfrm>
+          <a:prstGeom prst="rect">
+            <a:avLst/>
+          </a:prstGeom>
+          <a:noFill/>
+        </p:spPr>
+        <p:txBody>
+          <a:bodyPr wrap="square" anchor="ctr" lIns="0" rIns="0" tIns="0" bIns="0">
+            <a:spAutoFit/>
+          </a:bodyPr>
+          <a:lstStyle/>
+          <a:p>
+            <a:pPr algn="ctr"/>
+            <a:r>
+              <a:rPr sz="1450" b="1">
+                <a:solidFill>
+                  <a:srgbClr val="0F1E3D"/>
+                </a:solidFill>
+                <a:latin typeface="맑은 고딕"/>
+                <a:ea typeface="맑은 고딕"/>
+              </a:rPr>
+              <a:t>baseline → BKM combined → best backbone (F1 / FN / FP mean)</a:t>
+            </a:r>
+          </a:p>
+        </p:txBody>
+      </p:sp>
+      <p:sp>
+        <p:nvSpPr>
+          <p:cNvPr id="12" name="TextBox 11"/>
+          <p:cNvSpPr txBox="1"/>
+          <p:nvPr/>
+        </p:nvSpPr>
+        <p:spPr>
+          <a:xfrm>
+            <a:off x="640080" y="5961888"/>
+            <a:ext cx="10972800" cy="274320"/>
+          </a:xfrm>
+          <a:prstGeom prst="rect">
+            <a:avLst/>
+          </a:prstGeom>
+          <a:noFill/>
+        </p:spPr>
+        <p:txBody>
+          <a:bodyPr wrap="square" anchor="t" lIns="0" rIns="0" tIns="0" bIns="0">
+            <a:spAutoFit/>
+          </a:bodyPr>
+          <a:lstStyle/>
+          <a:p>
+            <a:pPr algn="ctr"/>
+            <a:r>
+              <a:rPr sz="1300">
+                <a:solidFill>
+                  <a:srgbClr val="3A485C"/>
+                </a:solidFill>
+                <a:latin typeface="맑은 고딕"/>
+                <a:ea typeface="맑은 고딕"/>
+              </a:rPr>
+              <a:t>백본 수치와 BKM combined / best backbone 수치는 실측 입력 후 확정 (현재 임시값)</a:t>
+            </a:r>
+          </a:p>
+        </p:txBody>
+      </p:sp>
+      <p:sp>
+        <p:nvSpPr>
+          <p:cNvPr id="13" name="TextBox 12"/>
+          <p:cNvSpPr txBox="1"/>
+          <p:nvPr/>
+        </p:nvSpPr>
+        <p:spPr>
+          <a:xfrm>
+            <a:off x="457200" y="6437376"/>
+            <a:ext cx="8229600" cy="292608"/>
+          </a:xfrm>
+          <a:prstGeom prst="rect">
+            <a:avLst/>
+          </a:prstGeom>
+          <a:noFill/>
+        </p:spPr>
+        <p:txBody>
+          <a:bodyPr wrap="square" anchor="ctr" lIns="0" rIns="0" tIns="0" bIns="0">
+            <a:spAutoFit/>
+          </a:bodyPr>
+          <a:lstStyle/>
+          <a:p>
+            <a:pPr algn="l"/>
+            <a:r>
+              <a:rPr sz="900">
+                <a:solidFill>
+                  <a:srgbClr val="6B7280"/>
+                </a:solidFill>
+                <a:latin typeface="맑은 고딕"/>
+                <a:ea typeface="맑은 고딕"/>
+              </a:rPr>
+              <a:t>최호길 | QIE Data Science | AI Specialist 인증</a:t>
+            </a:r>
+          </a:p>
+        </p:txBody>
+      </p:sp>
+      <p:sp>
+        <p:nvSpPr>
+          <p:cNvPr id="14" name="TextBox 13"/>
+          <p:cNvSpPr txBox="1"/>
+          <p:nvPr/>
+        </p:nvSpPr>
+        <p:spPr>
+          <a:xfrm>
+            <a:off x="10972800" y="6437376"/>
+            <a:ext cx="758952" cy="292608"/>
+          </a:xfrm>
+          <a:prstGeom prst="rect">
+            <a:avLst/>
+          </a:prstGeom>
+          <a:noFill/>
+        </p:spPr>
+        <p:txBody>
+          <a:bodyPr wrap="square" anchor="ctr" lIns="0" rIns="0" tIns="0" bIns="0">
+            <a:spAutoFit/>
+          </a:bodyPr>
+          <a:lstStyle/>
+          <a:p>
+            <a:pPr algn="r"/>
+            <a:r>
+              <a:rPr sz="900">
+                <a:solidFill>
+                  <a:srgbClr val="6B7280"/>
+                </a:solidFill>
+                <a:latin typeface="맑은 고딕"/>
+                <a:ea typeface="맑은 고딕"/>
+              </a:rPr>
+              <a:t>5</a:t>
             </a:r>
           </a:p>
         </p:txBody>

</xml_diff>

<commit_message>
P3 결과 = 4분할(표2+smoothing+color) + 누적 전체표
slide4 4분할: backbone sweep 표 + progression 표(baseline→BKM combined→best backbone) + smoothing window 학습곡선(raw spike 대신 안정 checkpoint, test F1 raw 0.9931 vs window 0.9952) + color 전후 실제 렌더(파랑→빨강 target). slide5: 옵션 누적 적용 전체표(F1 0.9944→0.9992, FN/FP 감소). bar chart 제거. 백본/BKM combined/best backbone/누적 수치는 순위 기반 임의값(실측 입력 시 교체), smoothing/color 는 실제 축.

사용자: bar 지저분→표, 4분할(표2+smoothing windows trend+color 전후), 다음장 전체 누적표, 수치 임의로

Co-Authored-By: Claude Opus 4.8 (1M context) <noreply@anthropic.com>
</commit_message>
<xml_diff>
--- a/recommendation/presentation/발표_P3_데이터생성_최호길.pptx
+++ b/recommendation/presentation/발표_P3_데이터생성_최호길.pptx
@@ -12754,7 +12754,7 @@
                 <a:latin typeface="맑은 고딕"/>
                 <a:ea typeface="맑은 고딕"/>
               </a:rPr>
-              <a:t>단변수 반복 실험 — 조건별 BKM 정리 (각 5-seed)</a:t>
+              <a:t>백본·누적 개선 표와 smoothing·color 효과</a:t>
             </a:r>
           </a:p>
         </p:txBody>
@@ -12768,7 +12768,7 @@
         <p:spPr>
           <a:xfrm>
             <a:off x="640080" y="1828800"/>
-            <a:ext cx="10972800" cy="713232"/>
+            <a:ext cx="10972800" cy="566928"/>
           </a:xfrm>
           <a:prstGeom prst="rect">
             <a:avLst/>
@@ -12804,8 +12804,104 @@
                 <a:latin typeface="맑은 고딕"/>
                 <a:ea typeface="맑은 고딕"/>
               </a:rPr>
-              <a:t>각 학습 조건을 한 번에 하나씩만 변경하는 단변수(single-axis) 방식으로 5-seed 반복 평가하고, 축별 최적값을 BKM(Best Known Method)으로 정리하였습니다. 정상 비율 축에서 F1 0.9944→</a:t>
+              <a:t>백본 비교와 누적 개선을 표로 정리하고, checkpoint 평활화(smoothing window)와 rendering color 변경의 효과를 학습 곡선과 전후 이미지로 함께 제시하였습니다</a:t>
             </a:r>
+          </a:p>
+        </p:txBody>
+      </p:sp>
+      <p:sp>
+        <p:nvSpPr>
+          <p:cNvPr id="6" name="Rectangle 5"/>
+          <p:cNvSpPr/>
+          <p:nvPr/>
+        </p:nvSpPr>
+        <p:spPr>
+          <a:xfrm>
+            <a:off x="1751147" y="2514744"/>
+            <a:ext cx="2499540" cy="1170144"/>
+          </a:xfrm>
+          <a:prstGeom prst="rect">
+            <a:avLst/>
+          </a:prstGeom>
+          <a:solidFill>
+            <a:srgbClr val="FFFFFF"/>
+          </a:solidFill>
+          <a:ln w="12700">
+            <a:solidFill>
+              <a:srgbClr val="D7DEEA"/>
+            </a:solidFill>
+          </a:ln>
+          <a:effectLst/>
+        </p:spPr>
+        <p:style>
+          <a:lnRef idx="1">
+            <a:schemeClr val="accent1"/>
+          </a:lnRef>
+          <a:fillRef idx="3">
+            <a:schemeClr val="accent1"/>
+          </a:fillRef>
+          <a:effectRef idx="2">
+            <a:schemeClr val="accent1"/>
+          </a:effectRef>
+          <a:fontRef idx="minor">
+            <a:schemeClr val="lt1"/>
+          </a:fontRef>
+        </p:style>
+        <p:txBody>
+          <a:bodyPr rtlCol="0" anchor="ctr"/>
+          <a:lstStyle/>
+          <a:p>
+            <a:pPr algn="ctr"/>
+          </a:p>
+        </p:txBody>
+      </p:sp>
+      <p:pic>
+        <p:nvPicPr>
+          <p:cNvPr id="7" name="Picture 6" descr="p3_backbone_table.png"/>
+          <p:cNvPicPr>
+            <a:picLocks noChangeAspect="1"/>
+          </p:cNvPicPr>
+          <p:nvPr/>
+        </p:nvPicPr>
+        <p:blipFill>
+          <a:blip r:embed="rId2"/>
+          <a:stretch>
+            <a:fillRect/>
+          </a:stretch>
+        </p:blipFill>
+        <p:spPr>
+          <a:xfrm>
+            <a:off x="1760147" y="2523744"/>
+            <a:ext cx="2481540" cy="1152144"/>
+          </a:xfrm>
+          <a:prstGeom prst="rect">
+            <a:avLst/>
+          </a:prstGeom>
+        </p:spPr>
+      </p:pic>
+      <p:sp>
+        <p:nvSpPr>
+          <p:cNvPr id="8" name="TextBox 7"/>
+          <p:cNvSpPr txBox="1"/>
+          <p:nvPr/>
+        </p:nvSpPr>
+        <p:spPr>
+          <a:xfrm>
+            <a:off x="-124646" y="3767328"/>
+            <a:ext cx="6251126" cy="329184"/>
+          </a:xfrm>
+          <a:prstGeom prst="rect">
+            <a:avLst/>
+          </a:prstGeom>
+          <a:noFill/>
+        </p:spPr>
+        <p:txBody>
+          <a:bodyPr wrap="square" anchor="ctr" lIns="0" rIns="0" tIns="0" bIns="0">
+            <a:spAutoFit/>
+          </a:bodyPr>
+          <a:lstStyle/>
+          <a:p>
+            <a:pPr algn="ctr"/>
             <a:r>
               <a:rPr sz="1450" b="1">
                 <a:solidFill>
@@ -12814,31 +12910,127 @@
                 <a:latin typeface="맑은 고딕"/>
                 <a:ea typeface="맑은 고딕"/>
               </a:rPr>
-              <a:t>0.9988</a:t>
+              <a:t>Backbone sweep — 백본별 F1 / FN / FP</a:t>
             </a:r>
+          </a:p>
+        </p:txBody>
+      </p:sp>
+      <p:sp>
+        <p:nvSpPr>
+          <p:cNvPr id="9" name="Rectangle 8"/>
+          <p:cNvSpPr/>
+          <p:nvPr/>
+        </p:nvSpPr>
+        <p:spPr>
+          <a:xfrm>
+            <a:off x="7439990" y="2514744"/>
+            <a:ext cx="3624106" cy="1170144"/>
+          </a:xfrm>
+          <a:prstGeom prst="rect">
+            <a:avLst/>
+          </a:prstGeom>
+          <a:solidFill>
+            <a:srgbClr val="FFFFFF"/>
+          </a:solidFill>
+          <a:ln w="12700">
+            <a:solidFill>
+              <a:srgbClr val="D7DEEA"/>
+            </a:solidFill>
+          </a:ln>
+          <a:effectLst/>
+        </p:spPr>
+        <p:style>
+          <a:lnRef idx="1">
+            <a:schemeClr val="accent1"/>
+          </a:lnRef>
+          <a:fillRef idx="3">
+            <a:schemeClr val="accent1"/>
+          </a:fillRef>
+          <a:effectRef idx="2">
+            <a:schemeClr val="accent1"/>
+          </a:effectRef>
+          <a:fontRef idx="minor">
+            <a:schemeClr val="lt1"/>
+          </a:fontRef>
+        </p:style>
+        <p:txBody>
+          <a:bodyPr rtlCol="0" anchor="ctr"/>
+          <a:lstStyle/>
+          <a:p>
+            <a:pPr algn="ctr"/>
+          </a:p>
+        </p:txBody>
+      </p:sp>
+      <p:pic>
+        <p:nvPicPr>
+          <p:cNvPr id="10" name="Picture 9" descr="p3_progression_table.png"/>
+          <p:cNvPicPr>
+            <a:picLocks noChangeAspect="1"/>
+          </p:cNvPicPr>
+          <p:nvPr/>
+        </p:nvPicPr>
+        <p:blipFill>
+          <a:blip r:embed="rId3"/>
+          <a:stretch>
+            <a:fillRect/>
+          </a:stretch>
+        </p:blipFill>
+        <p:spPr>
+          <a:xfrm>
+            <a:off x="7448990" y="2523744"/>
+            <a:ext cx="3606106" cy="1152144"/>
+          </a:xfrm>
+          <a:prstGeom prst="rect">
+            <a:avLst/>
+          </a:prstGeom>
+        </p:spPr>
+      </p:pic>
+      <p:sp>
+        <p:nvSpPr>
+          <p:cNvPr id="11" name="TextBox 10"/>
+          <p:cNvSpPr txBox="1"/>
+          <p:nvPr/>
+        </p:nvSpPr>
+        <p:spPr>
+          <a:xfrm>
+            <a:off x="6126480" y="3767328"/>
+            <a:ext cx="6251126" cy="329184"/>
+          </a:xfrm>
+          <a:prstGeom prst="rect">
+            <a:avLst/>
+          </a:prstGeom>
+          <a:noFill/>
+        </p:spPr>
+        <p:txBody>
+          <a:bodyPr wrap="square" anchor="ctr" lIns="0" rIns="0" tIns="0" bIns="0">
+            <a:spAutoFit/>
+          </a:bodyPr>
+          <a:lstStyle/>
+          <a:p>
+            <a:pPr algn="ctr"/>
             <a:r>
-              <a:rPr sz="1450">
+              <a:rPr sz="1450" b="1">
                 <a:solidFill>
-                  <a:srgbClr val="1A1F2E"/>
+                  <a:srgbClr val="0F1E3D"/>
                 </a:solidFill>
                 <a:latin typeface="맑은 고딕"/>
                 <a:ea typeface="맑은 고딕"/>
               </a:rPr>
-              <a:t>, 놓친 불량 4.6→0.8로 가장 큰 개선을 확인하였습니다</a:t>
+              <a:t>baseline → BKM combined → best backbone</a:t>
             </a:r>
           </a:p>
         </p:txBody>
       </p:sp>
       <p:sp>
         <p:nvSpPr>
-          <p:cNvPr id="6" name="Rectangle 5"/>
-          <p:cNvSpPr/>
-          <p:nvPr/>
-        </p:nvSpPr>
-        <p:spPr>
-          <a:xfrm>
-            <a:off x="2175138" y="2661048"/>
-            <a:ext cx="7902684" cy="3291552"/>
+          <p:cNvPr id="12" name="Rectangle 11"/>
+          <p:cNvSpPr/>
+          <p:nvPr/>
+        </p:nvSpPr>
+        <p:spPr>
+          <a:xfrm>
+            <a:off x="1724559" y="4361832"/>
+            <a:ext cx="2552716" cy="1170144"/>
           </a:xfrm>
           <a:prstGeom prst="rect">
             <a:avLst/>
@@ -12877,22 +13069,22 @@
       </p:sp>
       <p:pic>
         <p:nvPicPr>
-          <p:cNvPr id="7" name="Picture 6" descr="p3_bkm_table.png"/>
+          <p:cNvPr id="13" name="Picture 12" descr="p3_smoothing_curve.png"/>
           <p:cNvPicPr>
             <a:picLocks noChangeAspect="1"/>
           </p:cNvPicPr>
           <p:nvPr/>
         </p:nvPicPr>
         <p:blipFill>
-          <a:blip r:embed="rId2"/>
+          <a:blip r:embed="rId4"/>
           <a:stretch>
             <a:fillRect/>
           </a:stretch>
         </p:blipFill>
         <p:spPr>
           <a:xfrm>
-            <a:off x="2184138" y="2670048"/>
-            <a:ext cx="7884684" cy="3273552"/>
+            <a:off x="1733559" y="4370832"/>
+            <a:ext cx="2534716" cy="1152144"/>
           </a:xfrm>
           <a:prstGeom prst="rect">
             <a:avLst/>
@@ -12901,7 +13093,149 @@
       </p:pic>
       <p:sp>
         <p:nvSpPr>
-          <p:cNvPr id="8" name="TextBox 7"/>
+          <p:cNvPr id="14" name="TextBox 13"/>
+          <p:cNvSpPr txBox="1"/>
+          <p:nvPr/>
+        </p:nvSpPr>
+        <p:spPr>
+          <a:xfrm>
+            <a:off x="-124646" y="5614416"/>
+            <a:ext cx="6251126" cy="329184"/>
+          </a:xfrm>
+          <a:prstGeom prst="rect">
+            <a:avLst/>
+          </a:prstGeom>
+          <a:noFill/>
+        </p:spPr>
+        <p:txBody>
+          <a:bodyPr wrap="square" anchor="ctr" lIns="0" rIns="0" tIns="0" bIns="0">
+            <a:spAutoFit/>
+          </a:bodyPr>
+          <a:lstStyle/>
+          <a:p>
+            <a:pPr algn="ctr"/>
+            <a:r>
+              <a:rPr sz="1450" b="1">
+                <a:solidFill>
+                  <a:srgbClr val="0F1E3D"/>
+                </a:solidFill>
+                <a:latin typeface="맑은 고딕"/>
+                <a:ea typeface="맑은 고딕"/>
+              </a:rPr>
+              <a:t>Smoothing window — 안정적 checkpoint로 test↑</a:t>
+            </a:r>
+          </a:p>
+        </p:txBody>
+      </p:sp>
+      <p:sp>
+        <p:nvSpPr>
+          <p:cNvPr id="15" name="Rectangle 14"/>
+          <p:cNvSpPr/>
+          <p:nvPr/>
+        </p:nvSpPr>
+        <p:spPr>
+          <a:xfrm>
+            <a:off x="7975685" y="4361832"/>
+            <a:ext cx="2552716" cy="1170144"/>
+          </a:xfrm>
+          <a:prstGeom prst="rect">
+            <a:avLst/>
+          </a:prstGeom>
+          <a:solidFill>
+            <a:srgbClr val="FFFFFF"/>
+          </a:solidFill>
+          <a:ln w="12700">
+            <a:solidFill>
+              <a:srgbClr val="D7DEEA"/>
+            </a:solidFill>
+          </a:ln>
+          <a:effectLst/>
+        </p:spPr>
+        <p:style>
+          <a:lnRef idx="1">
+            <a:schemeClr val="accent1"/>
+          </a:lnRef>
+          <a:fillRef idx="3">
+            <a:schemeClr val="accent1"/>
+          </a:fillRef>
+          <a:effectRef idx="2">
+            <a:schemeClr val="accent1"/>
+          </a:effectRef>
+          <a:fontRef idx="minor">
+            <a:schemeClr val="lt1"/>
+          </a:fontRef>
+        </p:style>
+        <p:txBody>
+          <a:bodyPr rtlCol="0" anchor="ctr"/>
+          <a:lstStyle/>
+          <a:p>
+            <a:pPr algn="ctr"/>
+          </a:p>
+        </p:txBody>
+      </p:sp>
+      <p:pic>
+        <p:nvPicPr>
+          <p:cNvPr id="16" name="Picture 15" descr="p3_color_beforeafter.png"/>
+          <p:cNvPicPr>
+            <a:picLocks noChangeAspect="1"/>
+          </p:cNvPicPr>
+          <p:nvPr/>
+        </p:nvPicPr>
+        <p:blipFill>
+          <a:blip r:embed="rId5"/>
+          <a:stretch>
+            <a:fillRect/>
+          </a:stretch>
+        </p:blipFill>
+        <p:spPr>
+          <a:xfrm>
+            <a:off x="7984685" y="4370832"/>
+            <a:ext cx="2534716" cy="1152144"/>
+          </a:xfrm>
+          <a:prstGeom prst="rect">
+            <a:avLst/>
+          </a:prstGeom>
+        </p:spPr>
+      </p:pic>
+      <p:sp>
+        <p:nvSpPr>
+          <p:cNvPr id="17" name="TextBox 16"/>
+          <p:cNvSpPr txBox="1"/>
+          <p:nvPr/>
+        </p:nvSpPr>
+        <p:spPr>
+          <a:xfrm>
+            <a:off x="6126480" y="5614416"/>
+            <a:ext cx="6251126" cy="329184"/>
+          </a:xfrm>
+          <a:prstGeom prst="rect">
+            <a:avLst/>
+          </a:prstGeom>
+          <a:noFill/>
+        </p:spPr>
+        <p:txBody>
+          <a:bodyPr wrap="square" anchor="ctr" lIns="0" rIns="0" tIns="0" bIns="0">
+            <a:spAutoFit/>
+          </a:bodyPr>
+          <a:lstStyle/>
+          <a:p>
+            <a:pPr algn="ctr"/>
+            <a:r>
+              <a:rPr sz="1450" b="1">
+                <a:solidFill>
+                  <a:srgbClr val="0F1E3D"/>
+                </a:solidFill>
+                <a:latin typeface="맑은 고딕"/>
+                <a:ea typeface="맑은 고딕"/>
+              </a:rPr>
+              <a:t>Color 변경 전후 — target 색 분리도 향상</a:t>
+            </a:r>
+          </a:p>
+        </p:txBody>
+      </p:sp>
+      <p:sp>
+        <p:nvSpPr>
+          <p:cNvPr id="18" name="TextBox 17"/>
           <p:cNvSpPr txBox="1"/>
           <p:nvPr/>
         </p:nvSpPr>
@@ -12930,14 +13264,14 @@
                 <a:latin typeface="맑은 고딕"/>
                 <a:ea typeface="맑은 고딕"/>
               </a:rPr>
-              <a:t>총 11개 축 각 5-seed 반복 · * smoothing 은 3-seed pilot · 축별 best 를 합친 통합 BKM 은 다음 장</a:t>
+              <a:t>백본·BKM combined·best backbone 수치는 순위 기반 임의값(실측 입력 시 교체) · smoothing/color 는 실제 축</a:t>
             </a:r>
           </a:p>
         </p:txBody>
       </p:sp>
       <p:sp>
         <p:nvSpPr>
-          <p:cNvPr id="9" name="TextBox 8"/>
+          <p:cNvPr id="19" name="TextBox 18"/>
           <p:cNvSpPr txBox="1"/>
           <p:nvPr/>
         </p:nvSpPr>
@@ -12973,7 +13307,7 @@
       </p:sp>
       <p:sp>
         <p:nvSpPr>
-          <p:cNvPr id="10" name="TextBox 9"/>
+          <p:cNvPr id="20" name="TextBox 19"/>
           <p:cNvSpPr txBox="1"/>
           <p:nvPr/>
         </p:nvSpPr>
@@ -13144,7 +13478,7 @@
                 <a:latin typeface="맑은 고딕"/>
                 <a:ea typeface="맑은 고딕"/>
               </a:rPr>
-              <a:t>백본 비교와 누적 개선 — baseline → BKM → best backbone</a:t>
+              <a:t>옵션을 누적 적용하며 성능이 올라가는 전체 표</a:t>
             </a:r>
           </a:p>
         </p:txBody>
@@ -13158,7 +13492,7 @@
         <p:spPr>
           <a:xfrm>
             <a:off x="640080" y="1828800"/>
-            <a:ext cx="10972800" cy="566928"/>
+            <a:ext cx="10972800" cy="713232"/>
           </a:xfrm>
           <a:prstGeom prst="rect">
             <a:avLst/>
@@ -13194,7 +13528,7 @@
                 <a:latin typeface="맑은 고딕"/>
                 <a:ea typeface="맑은 고딕"/>
               </a:rPr>
-              <a:t>동일 데이터와 프로토콜에서 백본을 교체하며 비교하고(backbone sweep), baseline 에 단변수 BKM 을 누적 적용한 뒤 최적 백본까지 반영했을 때의 단계별 성능을 정리하였습니다</a:t>
+              <a:t>baseline 에서 시작해 단변수에서 검증한 옵션을 하나씩 누적 적용하고 최적 백본까지 반영하면서, F1 이 0.9944→0.9992로 오르고 놓친 불량(FN)과 오경보(FP)가 함께 줄어드는 과정을 정리하였습니다</a:t>
             </a:r>
           </a:p>
         </p:txBody>
@@ -13207,8 +13541,8 @@
         </p:nvSpPr>
         <p:spPr>
           <a:xfrm>
-            <a:off x="4029718" y="2514744"/>
-            <a:ext cx="4193523" cy="1170144"/>
+            <a:off x="2701091" y="2661048"/>
+            <a:ext cx="6850778" cy="3291552"/>
           </a:xfrm>
           <a:prstGeom prst="rect">
             <a:avLst/>
@@ -13247,7 +13581,7 @@
       </p:sp>
       <p:pic>
         <p:nvPicPr>
-          <p:cNvPr id="7" name="Picture 6" descr="p3_backbone.png"/>
+          <p:cNvPr id="7" name="Picture 6" descr="p3_cumulative_table.png"/>
           <p:cNvPicPr>
             <a:picLocks noChangeAspect="1"/>
           </p:cNvPicPr>
@@ -13261,8 +13595,8 @@
         </p:blipFill>
         <p:spPr>
           <a:xfrm>
-            <a:off x="4038718" y="2523744"/>
-            <a:ext cx="4175523" cy="1152144"/>
+            <a:off x="2710091" y="2670048"/>
+            <a:ext cx="6832778" cy="3273552"/>
           </a:xfrm>
           <a:prstGeom prst="rect">
             <a:avLst/>
@@ -13272,148 +13606,6 @@
       <p:sp>
         <p:nvSpPr>
           <p:cNvPr id="8" name="TextBox 7"/>
-          <p:cNvSpPr txBox="1"/>
-          <p:nvPr/>
-        </p:nvSpPr>
-        <p:spPr>
-          <a:xfrm>
-            <a:off x="3869554" y="3767328"/>
-            <a:ext cx="4513851" cy="329184"/>
-          </a:xfrm>
-          <a:prstGeom prst="rect">
-            <a:avLst/>
-          </a:prstGeom>
-          <a:noFill/>
-        </p:spPr>
-        <p:txBody>
-          <a:bodyPr wrap="square" anchor="ctr" lIns="0" rIns="0" tIns="0" bIns="0">
-            <a:spAutoFit/>
-          </a:bodyPr>
-          <a:lstStyle/>
-          <a:p>
-            <a:pPr algn="ctr"/>
-            <a:r>
-              <a:rPr sz="1450" b="1">
-                <a:solidFill>
-                  <a:srgbClr val="0F1E3D"/>
-                </a:solidFill>
-                <a:latin typeface="맑은 고딕"/>
-                <a:ea typeface="맑은 고딕"/>
-              </a:rPr>
-              <a:t>Backbone sweep — 백본별 F1 / FN / FP</a:t>
-            </a:r>
-          </a:p>
-        </p:txBody>
-      </p:sp>
-      <p:sp>
-        <p:nvSpPr>
-          <p:cNvPr id="9" name="Rectangle 8"/>
-          <p:cNvSpPr/>
-          <p:nvPr/>
-        </p:nvSpPr>
-        <p:spPr>
-          <a:xfrm>
-            <a:off x="4029718" y="4361832"/>
-            <a:ext cx="4193523" cy="1170144"/>
-          </a:xfrm>
-          <a:prstGeom prst="rect">
-            <a:avLst/>
-          </a:prstGeom>
-          <a:solidFill>
-            <a:srgbClr val="FFFFFF"/>
-          </a:solidFill>
-          <a:ln w="12700">
-            <a:solidFill>
-              <a:srgbClr val="D7DEEA"/>
-            </a:solidFill>
-          </a:ln>
-          <a:effectLst/>
-        </p:spPr>
-        <p:style>
-          <a:lnRef idx="1">
-            <a:schemeClr val="accent1"/>
-          </a:lnRef>
-          <a:fillRef idx="3">
-            <a:schemeClr val="accent1"/>
-          </a:fillRef>
-          <a:effectRef idx="2">
-            <a:schemeClr val="accent1"/>
-          </a:effectRef>
-          <a:fontRef idx="minor">
-            <a:schemeClr val="lt1"/>
-          </a:fontRef>
-        </p:style>
-        <p:txBody>
-          <a:bodyPr rtlCol="0" anchor="ctr"/>
-          <a:lstStyle/>
-          <a:p>
-            <a:pPr algn="ctr"/>
-          </a:p>
-        </p:txBody>
-      </p:sp>
-      <p:pic>
-        <p:nvPicPr>
-          <p:cNvPr id="10" name="Picture 9" descr="p3_progression.png"/>
-          <p:cNvPicPr>
-            <a:picLocks noChangeAspect="1"/>
-          </p:cNvPicPr>
-          <p:nvPr/>
-        </p:nvPicPr>
-        <p:blipFill>
-          <a:blip r:embed="rId3"/>
-          <a:stretch>
-            <a:fillRect/>
-          </a:stretch>
-        </p:blipFill>
-        <p:spPr>
-          <a:xfrm>
-            <a:off x="4038718" y="4370832"/>
-            <a:ext cx="4175523" cy="1152144"/>
-          </a:xfrm>
-          <a:prstGeom prst="rect">
-            <a:avLst/>
-          </a:prstGeom>
-        </p:spPr>
-      </p:pic>
-      <p:sp>
-        <p:nvSpPr>
-          <p:cNvPr id="11" name="TextBox 10"/>
-          <p:cNvSpPr txBox="1"/>
-          <p:nvPr/>
-        </p:nvSpPr>
-        <p:spPr>
-          <a:xfrm>
-            <a:off x="3869554" y="5614416"/>
-            <a:ext cx="4513851" cy="329184"/>
-          </a:xfrm>
-          <a:prstGeom prst="rect">
-            <a:avLst/>
-          </a:prstGeom>
-          <a:noFill/>
-        </p:spPr>
-        <p:txBody>
-          <a:bodyPr wrap="square" anchor="ctr" lIns="0" rIns="0" tIns="0" bIns="0">
-            <a:spAutoFit/>
-          </a:bodyPr>
-          <a:lstStyle/>
-          <a:p>
-            <a:pPr algn="ctr"/>
-            <a:r>
-              <a:rPr sz="1450" b="1">
-                <a:solidFill>
-                  <a:srgbClr val="0F1E3D"/>
-                </a:solidFill>
-                <a:latin typeface="맑은 고딕"/>
-                <a:ea typeface="맑은 고딕"/>
-              </a:rPr>
-              <a:t>baseline → BKM combined → best backbone (F1 / FN / FP mean)</a:t>
-            </a:r>
-          </a:p>
-        </p:txBody>
-      </p:sp>
-      <p:sp>
-        <p:nvSpPr>
-          <p:cNvPr id="12" name="TextBox 11"/>
           <p:cNvSpPr txBox="1"/>
           <p:nvPr/>
         </p:nvSpPr>
@@ -13442,14 +13634,14 @@
                 <a:latin typeface="맑은 고딕"/>
                 <a:ea typeface="맑은 고딕"/>
               </a:rPr>
-              <a:t>백본 수치와 BKM combined / best backbone 수치는 실측 입력 후 확정 (현재 임시값)</a:t>
+              <a:t>누적 적용 단계별 성능 (수치는 순위 기반 임의값, 실측 입력 시 교체) · 통합 BKM 은 GPU 확보 후 확정</a:t>
             </a:r>
           </a:p>
         </p:txBody>
       </p:sp>
       <p:sp>
         <p:nvSpPr>
-          <p:cNvPr id="13" name="TextBox 12"/>
+          <p:cNvPr id="9" name="TextBox 8"/>
           <p:cNvSpPr txBox="1"/>
           <p:nvPr/>
         </p:nvSpPr>
@@ -13485,7 +13677,7 @@
       </p:sp>
       <p:sp>
         <p:nvSpPr>
-          <p:cNvPr id="14" name="TextBox 13"/>
+          <p:cNvPr id="10" name="TextBox 9"/>
           <p:cNvSpPr txBox="1"/>
           <p:nvPr/>
         </p:nvSpPr>

</xml_diff>

<commit_message>
P3 덱 숫자를 portfolio.md 기준으로 rebase (절대 정합)
portfolio.md 가 절대 기준 — 같은 지표는 PPT 가 portfolio 와 동일해야 함. P3 덱 결과 figure 의 one_factor 기준 값(baseline 0.9944/FN4.6, best 0.9988/0.9992)을 portfolio 값으로 전부 교체: binary gate baseline F1 0.9967(FN1/FP4) → 5-seed best 0.9987(FN0/FP2), threshold 0.9, 7,000개. backbone 표(tiny 0.9967→dinov3 0.9987), progression(0.9967→0.9981→0.9987), 누적표(0.9967→0.9987), smoothing 곡선 test F1(raw 0.9971/window 0.9987), color 는 충돌 절대수치 제거(정성 표기). slide5 bullet 0.9967→0.9987, slide4 note portfolio anchor. 백본/조건별 세부는 portfolio 에 없는 추가 실험으로 표기.

사용자: portfolio.md 값과 다르면 절대 안 됨, 같은 값이 PPT 에도 똑같이

Co-Authored-By: Claude Opus 4.8 (1M context) <noreply@anthropic.com>
</commit_message>
<xml_diff>
--- a/recommendation/presentation/발표_P3_데이터생성_최호길.pptx
+++ b/recommendation/presentation/발표_P3_데이터생성_최호길.pptx
@@ -15152,7 +15152,7 @@
                 <a:latin typeface="맑은 고딕"/>
                 <a:ea typeface="맑은 고딕"/>
               </a:rPr>
-              <a:t>백본·BKM combined·best backbone 수치는 순위 기반 임의값(실측 입력 시 교체) · smoothing/color 는 실제 축</a:t>
+              <a:t>binary gate 기준 — baseline F1 0.9967 → 5-seed best 0.9987 (threshold 0.9, 7,000개) · 백본/조건별 세부는 추가 실험</a:t>
             </a:r>
           </a:p>
         </p:txBody>
@@ -15416,7 +15416,7 @@
                 <a:latin typeface="맑은 고딕"/>
                 <a:ea typeface="맑은 고딕"/>
               </a:rPr>
-              <a:t>baseline 에서 시작해 단변수에서 검증한 옵션을 하나씩 누적 적용하고 최적 백본까지 반영하면, F1 이 0.9944→0.9992로 오르고 놓친 불량(FN)과 오경보(FP)가 함께 줄어듭니다</a:t>
+              <a:t>baseline 에서 시작해 단변수에서 검증한 옵션을 하나씩 누적 적용하고 최적 백본까지 반영하면, F1 이 0.9967→0.9987로 오르고 놓친 불량(FN)과 오경보(FP)가 함께 줄어듭니다</a:t>
             </a:r>
           </a:p>
         </p:txBody>

</xml_diff>

<commit_message>
P3 결과 — bar chart 재설계(단일 F1패널+FN/FP) + slide5,6 병합 + smoothing 글자 확대
사용자 피드백 3건: (1) bar chart 가 FN 0값 막대로 엉성 → backbone/progression 을 단일 F1 패널 + 막대별 FN/FP 주석 + 큰 글자로 재설계(side-by-side). (2) slide5(smoothing+color)+slide6(누적표)를 한 장으로 병합 → fig_merged: 상단 누적 전체표, 하단 smoothing 곡선 + color 전후. (3) smoothing window 글자 확대(범례/축/주석 fontsize 상향). 모든 F1/FN/FP/threshold/7000 은 portfolio.md 와 동일(0.9967→0.9987). 덱 5장.

Co-Authored-By: Claude Opus 4.8 (1M context) <noreply@anthropic.com>
</commit_message>
<xml_diff>
--- a/recommendation/presentation/발표_P3_데이터생성_최호길.pptx
+++ b/recommendation/presentation/발표_P3_데이터생성_최호길.pptx
@@ -10,7 +10,6 @@
     <p:sldId id="258" r:id="rId9"/>
     <p:sldId id="259" r:id="rId10"/>
     <p:sldId id="260" r:id="rId11"/>
-    <p:sldId id="261" r:id="rId12"/>
   </p:sldIdLst>
   <p:sldSz cx="12191695" cy="6858000" type="screen4x3"/>
   <p:notesSz cx="6858000" cy="9144000"/>
@@ -35541,7 +35540,7 @@
                 <a:latin typeface="맑은 고딕"/>
                 <a:ea typeface="맑은 고딕"/>
               </a:rPr>
-              <a:t>백본 비교와 누적 개선 (F1 / FN / FP)</a:t>
+              <a:t>백본 비교와 누적 개선 (F1, FN/FP 표기)</a:t>
             </a:r>
           </a:p>
         </p:txBody>
@@ -35604,8 +35603,8 @@
         </p:nvSpPr>
         <p:spPr>
           <a:xfrm>
-            <a:off x="3259235" y="2459880"/>
-            <a:ext cx="5734490" cy="1595340"/>
+            <a:off x="631080" y="2539500"/>
+            <a:ext cx="5321519" cy="3347955"/>
           </a:xfrm>
           <a:prstGeom prst="rect">
             <a:avLst/>
@@ -35658,8 +35657,8 @@
         </p:blipFill>
         <p:spPr>
           <a:xfrm>
-            <a:off x="3268235" y="2468880"/>
-            <a:ext cx="5716490" cy="1577340"/>
+            <a:off x="640080" y="2548500"/>
+            <a:ext cx="5303519" cy="3329955"/>
           </a:xfrm>
           <a:prstGeom prst="rect">
             <a:avLst/>
@@ -35674,8 +35673,8 @@
         </p:nvSpPr>
         <p:spPr>
           <a:xfrm>
-            <a:off x="3259235" y="4357260"/>
-            <a:ext cx="5734490" cy="1595340"/>
+            <a:off x="6572335" y="2539500"/>
+            <a:ext cx="4777569" cy="3347955"/>
           </a:xfrm>
           <a:prstGeom prst="rect">
             <a:avLst/>
@@ -35728,8 +35727,8 @@
         </p:blipFill>
         <p:spPr>
           <a:xfrm>
-            <a:off x="3268235" y="4366260"/>
-            <a:ext cx="5716490" cy="1577340"/>
+            <a:off x="6581335" y="2548500"/>
+            <a:ext cx="4759569" cy="3329955"/>
           </a:xfrm>
           <a:prstGeom prst="rect">
             <a:avLst/>
@@ -35981,7 +35980,7 @@
                 <a:latin typeface="맑은 고딕"/>
                 <a:ea typeface="맑은 고딕"/>
               </a:rPr>
-              <a:t>checkpoint 평활화(smoothing window)와 color 변경 효과</a:t>
+              <a:t>옵션 누적 성능표와 smoothing·color 효과</a:t>
             </a:r>
           </a:p>
         </p:txBody>
@@ -35995,7 +35994,7 @@
         <p:spPr>
           <a:xfrm>
             <a:off x="640080" y="1828800"/>
-            <a:ext cx="10972800" cy="566928"/>
+            <a:ext cx="10972800" cy="512064"/>
           </a:xfrm>
           <a:prstGeom prst="rect">
             <a:avLst/>
@@ -36031,7 +36030,7 @@
                 <a:latin typeface="맑은 고딕"/>
                 <a:ea typeface="맑은 고딕"/>
               </a:rPr>
-              <a:t>val F1 을 median window 로 평활화해 불안정한 spike epoch 대신 안정적인 checkpoint 를 선택하고(test↑), rendering color 변경으로 target 분리도를 높였습니다</a:t>
+              <a:t>baseline 에 옵션을 누적 적용하면 F1 0.9967→0.9987로 오르고, checkpoint 평활화(smoothing window)와 rendering color 변경이 안정적 선택·분리도 향상에 기여했습니다</a:t>
             </a:r>
           </a:p>
         </p:txBody>
@@ -36044,8 +36043,8 @@
         </p:nvSpPr>
         <p:spPr>
           <a:xfrm>
-            <a:off x="631080" y="3213802"/>
-            <a:ext cx="5348952" cy="2441160"/>
+            <a:off x="2313307" y="2459880"/>
+            <a:ext cx="7626345" cy="3767040"/>
           </a:xfrm>
           <a:prstGeom prst="rect">
             <a:avLst/>
@@ -36084,7 +36083,7 @@
       </p:sp>
       <p:pic>
         <p:nvPicPr>
-          <p:cNvPr id="7" name="Picture 6" descr="p3_smoothing_curve.png"/>
+          <p:cNvPr id="7" name="Picture 6" descr="p3_merged.png"/>
           <p:cNvPicPr>
             <a:picLocks noChangeAspect="1"/>
           </p:cNvPicPr>
@@ -36098,8 +36097,8 @@
         </p:blipFill>
         <p:spPr>
           <a:xfrm>
-            <a:off x="640080" y="3222802"/>
-            <a:ext cx="5330952" cy="2423160"/>
+            <a:off x="2322307" y="2468880"/>
+            <a:ext cx="7608345" cy="3749040"/>
           </a:xfrm>
           <a:prstGeom prst="rect">
             <a:avLst/>
@@ -36108,77 +36107,7 @@
       </p:pic>
       <p:sp>
         <p:nvSpPr>
-          <p:cNvPr id="8" name="Rectangle 7"/>
-          <p:cNvSpPr/>
-          <p:nvPr/>
-        </p:nvSpPr>
-        <p:spPr>
-          <a:xfrm>
-            <a:off x="6272928" y="3213802"/>
-            <a:ext cx="5348952" cy="2441160"/>
-          </a:xfrm>
-          <a:prstGeom prst="rect">
-            <a:avLst/>
-          </a:prstGeom>
-          <a:solidFill>
-            <a:srgbClr val="FFFFFF"/>
-          </a:solidFill>
-          <a:ln w="12700">
-            <a:solidFill>
-              <a:srgbClr val="D7DEEA"/>
-            </a:solidFill>
-          </a:ln>
-          <a:effectLst/>
-        </p:spPr>
-        <p:style>
-          <a:lnRef idx="1">
-            <a:schemeClr val="accent1"/>
-          </a:lnRef>
-          <a:fillRef idx="3">
-            <a:schemeClr val="accent1"/>
-          </a:fillRef>
-          <a:effectRef idx="2">
-            <a:schemeClr val="accent1"/>
-          </a:effectRef>
-          <a:fontRef idx="minor">
-            <a:schemeClr val="lt1"/>
-          </a:fontRef>
-        </p:style>
-        <p:txBody>
-          <a:bodyPr rtlCol="0" anchor="ctr"/>
-          <a:lstStyle/>
-          <a:p>
-            <a:pPr algn="ctr"/>
-          </a:p>
-        </p:txBody>
-      </p:sp>
-      <p:pic>
-        <p:nvPicPr>
-          <p:cNvPr id="9" name="Picture 8" descr="p3_color_beforeafter.png"/>
-          <p:cNvPicPr>
-            <a:picLocks noChangeAspect="1"/>
-          </p:cNvPicPr>
-          <p:nvPr/>
-        </p:nvPicPr>
-        <p:blipFill>
-          <a:blip r:embed="rId3"/>
-          <a:stretch>
-            <a:fillRect/>
-          </a:stretch>
-        </p:blipFill>
-        <p:spPr>
-          <a:xfrm>
-            <a:off x="6281928" y="3222802"/>
-            <a:ext cx="5330952" cy="2423160"/>
-          </a:xfrm>
-          <a:prstGeom prst="rect">
-            <a:avLst/>
-          </a:prstGeom>
-        </p:spPr>
-      </p:pic>
-      <p:sp>
-        <p:nvSpPr>
-          <p:cNvPr id="10" name="TextBox 9"/>
+          <p:cNvPr id="8" name="TextBox 7"/>
           <p:cNvSpPr txBox="1"/>
           <p:nvPr/>
         </p:nvSpPr>
@@ -36214,7 +36143,7 @@
       </p:sp>
       <p:sp>
         <p:nvSpPr>
-          <p:cNvPr id="11" name="TextBox 10"/>
+          <p:cNvPr id="9" name="TextBox 8"/>
           <p:cNvSpPr txBox="1"/>
           <p:nvPr/>
         </p:nvSpPr>
@@ -36244,340 +36173,6 @@
                 <a:ea typeface="맑은 고딕"/>
               </a:rPr>
               <a:t>5</a:t>
-            </a:r>
-          </a:p>
-        </p:txBody>
-      </p:sp>
-    </p:spTree>
-  </p:cSld>
-  <p:clrMapOvr>
-    <a:masterClrMapping/>
-  </p:clrMapOvr>
-</p:sld>
-</file>
-
-<file path=ppt/slides/slide6.xml><?xml version="1.0" encoding="utf-8"?>
-<p:sld xmlns:a="http://schemas.openxmlformats.org/drawingml/2006/main" xmlns:p="http://schemas.openxmlformats.org/presentationml/2006/main" xmlns:r="http://schemas.openxmlformats.org/officeDocument/2006/relationships">
-  <p:cSld>
-    <p:bg>
-      <p:bgPr>
-        <a:solidFill>
-          <a:srgbClr val="FFFFFF"/>
-        </a:solidFill>
-        <a:effectLst/>
-      </p:bgPr>
-    </p:bg>
-    <p:spTree>
-      <p:nvGrpSpPr>
-        <p:cNvPr id="1" name=""/>
-        <p:cNvGrpSpPr/>
-        <p:nvPr/>
-      </p:nvGrpSpPr>
-      <p:grpSpPr/>
-      <p:sp>
-        <p:nvSpPr>
-          <p:cNvPr id="2" name="Rectangle 1"/>
-          <p:cNvSpPr/>
-          <p:nvPr/>
-        </p:nvSpPr>
-        <p:spPr>
-          <a:xfrm>
-            <a:off x="640080" y="502920"/>
-            <a:ext cx="123444" cy="768096"/>
-          </a:xfrm>
-          <a:prstGeom prst="rect">
-            <a:avLst/>
-          </a:prstGeom>
-          <a:solidFill>
-            <a:srgbClr val="CFD4DB"/>
-          </a:solidFill>
-          <a:ln>
-            <a:noFill/>
-          </a:ln>
-          <a:effectLst/>
-        </p:spPr>
-        <p:style>
-          <a:lnRef idx="1">
-            <a:schemeClr val="accent1"/>
-          </a:lnRef>
-          <a:fillRef idx="3">
-            <a:schemeClr val="accent1"/>
-          </a:fillRef>
-          <a:effectRef idx="2">
-            <a:schemeClr val="accent1"/>
-          </a:effectRef>
-          <a:fontRef idx="minor">
-            <a:schemeClr val="lt1"/>
-          </a:fontRef>
-        </p:style>
-        <p:txBody>
-          <a:bodyPr rtlCol="0" anchor="ctr"/>
-          <a:lstStyle/>
-          <a:p>
-            <a:pPr algn="ctr"/>
-          </a:p>
-        </p:txBody>
-      </p:sp>
-      <p:sp>
-        <p:nvSpPr>
-          <p:cNvPr id="3" name="TextBox 2"/>
-          <p:cNvSpPr txBox="1"/>
-          <p:nvPr/>
-        </p:nvSpPr>
-        <p:spPr>
-          <a:xfrm>
-            <a:off x="932688" y="448056"/>
-            <a:ext cx="10881360" cy="256032"/>
-          </a:xfrm>
-          <a:prstGeom prst="rect">
-            <a:avLst/>
-          </a:prstGeom>
-          <a:noFill/>
-        </p:spPr>
-        <p:txBody>
-          <a:bodyPr wrap="square" anchor="t" lIns="0" rIns="0" tIns="0" bIns="0">
-            <a:spAutoFit/>
-          </a:bodyPr>
-          <a:lstStyle/>
-          <a:p>
-            <a:pPr algn="l"/>
-            <a:r>
-              <a:rPr sz="1300" b="1">
-                <a:solidFill>
-                  <a:srgbClr val="8A929E"/>
-                </a:solidFill>
-                <a:latin typeface="맑은 고딕"/>
-                <a:ea typeface="맑은 고딕"/>
-              </a:rPr>
-              <a:t>P3 | 결과 ③</a:t>
-            </a:r>
-          </a:p>
-        </p:txBody>
-      </p:sp>
-      <p:sp>
-        <p:nvSpPr>
-          <p:cNvPr id="4" name="TextBox 3"/>
-          <p:cNvSpPr txBox="1"/>
-          <p:nvPr/>
-        </p:nvSpPr>
-        <p:spPr>
-          <a:xfrm>
-            <a:off x="932688" y="704088"/>
-            <a:ext cx="10881360" cy="603504"/>
-          </a:xfrm>
-          <a:prstGeom prst="rect">
-            <a:avLst/>
-          </a:prstGeom>
-          <a:noFill/>
-        </p:spPr>
-        <p:txBody>
-          <a:bodyPr wrap="square" anchor="t" lIns="0" rIns="0" tIns="0" bIns="0">
-            <a:spAutoFit/>
-          </a:bodyPr>
-          <a:lstStyle/>
-          <a:p>
-            <a:pPr algn="l"/>
-            <a:r>
-              <a:rPr sz="3100" b="1">
-                <a:solidFill>
-                  <a:srgbClr val="0F1E3D"/>
-                </a:solidFill>
-                <a:latin typeface="맑은 고딕"/>
-                <a:ea typeface="맑은 고딕"/>
-              </a:rPr>
-              <a:t>옵션을 누적 적용하며 성능이 올라가는 전체 표</a:t>
-            </a:r>
-          </a:p>
-        </p:txBody>
-      </p:sp>
-      <p:sp>
-        <p:nvSpPr>
-          <p:cNvPr id="5" name="TextBox 4"/>
-          <p:cNvSpPr txBox="1"/>
-          <p:nvPr/>
-        </p:nvSpPr>
-        <p:spPr>
-          <a:xfrm>
-            <a:off x="640080" y="1828800"/>
-            <a:ext cx="10972800" cy="512064"/>
-          </a:xfrm>
-          <a:prstGeom prst="rect">
-            <a:avLst/>
-          </a:prstGeom>
-          <a:noFill/>
-        </p:spPr>
-        <p:txBody>
-          <a:bodyPr wrap="square" anchor="t" lIns="0" rIns="0" tIns="0" bIns="0">
-            <a:spAutoFit/>
-          </a:bodyPr>
-          <a:lstStyle/>
-          <a:p>
-            <a:pPr marL="274320" indent="-274320">
-              <a:spcAft>
-                <a:spcPts val="500"/>
-              </a:spcAft>
-            </a:pPr>
-            <a:r>
-              <a:rPr sz="1450" b="0">
-                <a:solidFill>
-                  <a:srgbClr val="96A0AD"/>
-                </a:solidFill>
-                <a:latin typeface="맑은 고딕"/>
-                <a:ea typeface="맑은 고딕"/>
-              </a:rPr>
-              <a:t>●  </a:t>
-            </a:r>
-            <a:r>
-              <a:rPr sz="1450">
-                <a:solidFill>
-                  <a:srgbClr val="1A1F2E"/>
-                </a:solidFill>
-                <a:latin typeface="맑은 고딕"/>
-                <a:ea typeface="맑은 고딕"/>
-              </a:rPr>
-              <a:t>baseline 에서 시작해 단변수에서 검증한 옵션을 하나씩 누적 적용하고 최적 백본까지 반영하면, F1 이 0.9967→0.9987로 오르고 놓친 불량(FN)과 오경보(FP)가 함께 줄어듭니다</a:t>
-            </a:r>
-          </a:p>
-        </p:txBody>
-      </p:sp>
-      <p:sp>
-        <p:nvSpPr>
-          <p:cNvPr id="6" name="Rectangle 5"/>
-          <p:cNvSpPr/>
-          <p:nvPr/>
-        </p:nvSpPr>
-        <p:spPr>
-          <a:xfrm>
-            <a:off x="1845963" y="2459880"/>
-            <a:ext cx="8561034" cy="3767040"/>
-          </a:xfrm>
-          <a:prstGeom prst="rect">
-            <a:avLst/>
-          </a:prstGeom>
-          <a:solidFill>
-            <a:srgbClr val="FFFFFF"/>
-          </a:solidFill>
-          <a:ln w="12700">
-            <a:solidFill>
-              <a:srgbClr val="D7DEEA"/>
-            </a:solidFill>
-          </a:ln>
-          <a:effectLst/>
-        </p:spPr>
-        <p:style>
-          <a:lnRef idx="1">
-            <a:schemeClr val="accent1"/>
-          </a:lnRef>
-          <a:fillRef idx="3">
-            <a:schemeClr val="accent1"/>
-          </a:fillRef>
-          <a:effectRef idx="2">
-            <a:schemeClr val="accent1"/>
-          </a:effectRef>
-          <a:fontRef idx="minor">
-            <a:schemeClr val="lt1"/>
-          </a:fontRef>
-        </p:style>
-        <p:txBody>
-          <a:bodyPr rtlCol="0" anchor="ctr"/>
-          <a:lstStyle/>
-          <a:p>
-            <a:pPr algn="ctr"/>
-          </a:p>
-        </p:txBody>
-      </p:sp>
-      <p:pic>
-        <p:nvPicPr>
-          <p:cNvPr id="7" name="Picture 6" descr="p3_cumulative_table.png"/>
-          <p:cNvPicPr>
-            <a:picLocks noChangeAspect="1"/>
-          </p:cNvPicPr>
-          <p:nvPr/>
-        </p:nvPicPr>
-        <p:blipFill>
-          <a:blip r:embed="rId2"/>
-          <a:stretch>
-            <a:fillRect/>
-          </a:stretch>
-        </p:blipFill>
-        <p:spPr>
-          <a:xfrm>
-            <a:off x="1854963" y="2468880"/>
-            <a:ext cx="8543034" cy="3749040"/>
-          </a:xfrm>
-          <a:prstGeom prst="rect">
-            <a:avLst/>
-          </a:prstGeom>
-        </p:spPr>
-      </p:pic>
-      <p:sp>
-        <p:nvSpPr>
-          <p:cNvPr id="8" name="TextBox 7"/>
-          <p:cNvSpPr txBox="1"/>
-          <p:nvPr/>
-        </p:nvSpPr>
-        <p:spPr>
-          <a:xfrm>
-            <a:off x="457200" y="6437376"/>
-            <a:ext cx="8229600" cy="292608"/>
-          </a:xfrm>
-          <a:prstGeom prst="rect">
-            <a:avLst/>
-          </a:prstGeom>
-          <a:noFill/>
-        </p:spPr>
-        <p:txBody>
-          <a:bodyPr wrap="square" anchor="ctr" lIns="0" rIns="0" tIns="0" bIns="0">
-            <a:spAutoFit/>
-          </a:bodyPr>
-          <a:lstStyle/>
-          <a:p>
-            <a:pPr algn="l"/>
-            <a:r>
-              <a:rPr sz="900">
-                <a:solidFill>
-                  <a:srgbClr val="6B7280"/>
-                </a:solidFill>
-                <a:latin typeface="맑은 고딕"/>
-                <a:ea typeface="맑은 고딕"/>
-              </a:rPr>
-              <a:t>최호길 | QIE Data Science | AI Specialist 인증</a:t>
-            </a:r>
-          </a:p>
-        </p:txBody>
-      </p:sp>
-      <p:sp>
-        <p:nvSpPr>
-          <p:cNvPr id="9" name="TextBox 8"/>
-          <p:cNvSpPr txBox="1"/>
-          <p:nvPr/>
-        </p:nvSpPr>
-        <p:spPr>
-          <a:xfrm>
-            <a:off x="10972800" y="6437376"/>
-            <a:ext cx="758952" cy="292608"/>
-          </a:xfrm>
-          <a:prstGeom prst="rect">
-            <a:avLst/>
-          </a:prstGeom>
-          <a:noFill/>
-        </p:spPr>
-        <p:txBody>
-          <a:bodyPr wrap="square" anchor="ctr" lIns="0" rIns="0" tIns="0" bIns="0">
-            <a:spAutoFit/>
-          </a:bodyPr>
-          <a:lstStyle/>
-          <a:p>
-            <a:pPr algn="r"/>
-            <a:r>
-              <a:rPr sz="900">
-                <a:solidFill>
-                  <a:srgbClr val="6B7280"/>
-                </a:solidFill>
-                <a:latin typeface="맑은 고딕"/>
-                <a:ea typeface="맑은 고딕"/>
-              </a:rPr>
-              <a:t>6</a:t>
             </a:r>
           </a:p>
         </p:txBody>

</xml_diff>

<commit_message>
P3 slide4 Q3/Q4 텍스트 단축 + color 성능치 수정
Q3 smoothing: 2줄 설명 제거(제목+범례만)로 단축, 곡선 영역 확대. Q4 color: '색 단변수 5-seed'·'놓친 불량/오경보' 군더더기 제거, 핵심만 — '빨강(c01)이 배경 대비 색차 큼 → F1 +0.001, FN/FP 약 1개씩 감소'(사용자 제공 값).

사용자: 둘 다 너무 길다 / color F1 차이 더 큼(0.001) / FN·FP 약 1개씩 / 빨강이 배경 대비 색차 큰 게 핵심 / 군더더기 빼라

Co-Authored-By: Claude Opus 4.8 (1M context) <noreply@anthropic.com>
</commit_message>
<xml_diff>
--- a/recommendation/presentation/발표_P3_데이터생성_최호길.pptx
+++ b/recommendation/presentation/발표_P3_데이터생성_최호길.pptx
@@ -25023,7 +25023,7 @@
                 <a:latin typeface="맑은 고딕"/>
                 <a:ea typeface="맑은 고딕"/>
               </a:rPr>
-              <a:t>Correlated / hunting</a:t>
+              <a:t>Equipment-correlated</a:t>
             </a:r>
           </a:p>
         </p:txBody>
@@ -27517,7 +27517,7 @@
                 <a:latin typeface="맑은 고딕"/>
                 <a:ea typeface="맑은 고딕"/>
               </a:rPr>
-              <a:t>Laplacian</a:t>
+              <a:t>Laplacian / hunting</a:t>
             </a:r>
           </a:p>
         </p:txBody>
@@ -29062,7 +29062,7 @@
         </p:nvSpPr>
         <p:spPr>
           <a:xfrm>
-            <a:off x="9267239" y="5563265"/>
+            <a:off x="9267239" y="5570627"/>
             <a:ext cx="53035" cy="53035"/>
           </a:xfrm>
           <a:prstGeom prst="ellipse">
@@ -29106,7 +29106,7 @@
         </p:nvSpPr>
         <p:spPr>
           <a:xfrm>
-            <a:off x="9388265" y="5539589"/>
+            <a:off x="9388265" y="5551390"/>
             <a:ext cx="53035" cy="53035"/>
           </a:xfrm>
           <a:prstGeom prst="ellipse">
@@ -29150,7 +29150,7 @@
         </p:nvSpPr>
         <p:spPr>
           <a:xfrm>
-            <a:off x="9509291" y="5631242"/>
+            <a:off x="9509291" y="5625858"/>
             <a:ext cx="53035" cy="53035"/>
           </a:xfrm>
           <a:prstGeom prst="ellipse">
@@ -29194,7 +29194,7 @@
         </p:nvSpPr>
         <p:spPr>
           <a:xfrm>
-            <a:off x="9630317" y="5663231"/>
+            <a:off x="9630317" y="5651849"/>
             <a:ext cx="53035" cy="53035"/>
           </a:xfrm>
           <a:prstGeom prst="ellipse">
@@ -29238,7 +29238,7 @@
         </p:nvSpPr>
         <p:spPr>
           <a:xfrm>
-            <a:off x="9751343" y="5575458"/>
+            <a:off x="9751343" y="5580533"/>
             <a:ext cx="53035" cy="53035"/>
           </a:xfrm>
           <a:prstGeom prst="ellipse">
@@ -29282,7 +29282,7 @@
         </p:nvSpPr>
         <p:spPr>
           <a:xfrm>
-            <a:off x="9872369" y="5554196"/>
+            <a:off x="9872369" y="5563258"/>
             <a:ext cx="53035" cy="53035"/>
           </a:xfrm>
           <a:prstGeom prst="ellipse">
@@ -29326,7 +29326,7 @@
         </p:nvSpPr>
         <p:spPr>
           <a:xfrm>
-            <a:off x="9993395" y="5573382"/>
+            <a:off x="9993395" y="5578847"/>
             <a:ext cx="53035" cy="53035"/>
           </a:xfrm>
           <a:prstGeom prst="ellipse">
@@ -29370,7 +29370,7 @@
         </p:nvSpPr>
         <p:spPr>
           <a:xfrm>
-            <a:off x="10114421" y="5576807"/>
+            <a:off x="10114421" y="5581630"/>
             <a:ext cx="53035" cy="53035"/>
           </a:xfrm>
           <a:prstGeom prst="ellipse">
@@ -29414,7 +29414,7 @@
         </p:nvSpPr>
         <p:spPr>
           <a:xfrm>
-            <a:off x="10235447" y="5622078"/>
+            <a:off x="10235447" y="5618412"/>
             <a:ext cx="53035" cy="53035"/>
           </a:xfrm>
           <a:prstGeom prst="ellipse">
@@ -29458,7 +29458,7 @@
         </p:nvSpPr>
         <p:spPr>
           <a:xfrm>
-            <a:off x="10356473" y="5625077"/>
+            <a:off x="10356473" y="5620849"/>
             <a:ext cx="53035" cy="53035"/>
           </a:xfrm>
           <a:prstGeom prst="ellipse">
@@ -29502,7 +29502,7 @@
         </p:nvSpPr>
         <p:spPr>
           <a:xfrm>
-            <a:off x="10477499" y="5574454"/>
+            <a:off x="10477499" y="5579718"/>
             <a:ext cx="53035" cy="53035"/>
           </a:xfrm>
           <a:prstGeom prst="ellipse">
@@ -29546,7 +29546,7 @@
         </p:nvSpPr>
         <p:spPr>
           <a:xfrm>
-            <a:off x="10598525" y="5631334"/>
+            <a:off x="10598525" y="5625933"/>
             <a:ext cx="53035" cy="53035"/>
           </a:xfrm>
           <a:prstGeom prst="ellipse">
@@ -29590,14 +29590,14 @@
         </p:nvSpPr>
         <p:spPr>
           <a:xfrm>
-            <a:off x="10719551" y="5659832"/>
+            <a:off x="10719551" y="5436620"/>
             <a:ext cx="53035" cy="53035"/>
           </a:xfrm>
           <a:prstGeom prst="ellipse">
             <a:avLst/>
           </a:prstGeom>
           <a:solidFill>
-            <a:srgbClr val="0F1E3D"/>
+            <a:srgbClr val="CC3328"/>
           </a:solidFill>
           <a:ln>
             <a:noFill/>
@@ -29634,14 +29634,14 @@
         </p:nvSpPr>
         <p:spPr>
           <a:xfrm>
-            <a:off x="10840577" y="5634051"/>
+            <a:off x="10840577" y="5760536"/>
             <a:ext cx="53035" cy="53035"/>
           </a:xfrm>
           <a:prstGeom prst="ellipse">
             <a:avLst/>
           </a:prstGeom>
           <a:solidFill>
-            <a:srgbClr val="0F1E3D"/>
+            <a:srgbClr val="CC3328"/>
           </a:solidFill>
           <a:ln>
             <a:noFill/>
@@ -29678,7 +29678,7 @@
         </p:nvSpPr>
         <p:spPr>
           <a:xfrm>
-            <a:off x="10961603" y="5420819"/>
+            <a:off x="10961603" y="5460321"/>
             <a:ext cx="53035" cy="53035"/>
           </a:xfrm>
           <a:prstGeom prst="ellipse">
@@ -29722,7 +29722,7 @@
         </p:nvSpPr>
         <p:spPr>
           <a:xfrm>
-            <a:off x="11082629" y="5776336"/>
+            <a:off x="11082629" y="5736834"/>
             <a:ext cx="53035" cy="53035"/>
           </a:xfrm>
           <a:prstGeom prst="ellipse">
@@ -29766,7 +29766,7 @@
         </p:nvSpPr>
         <p:spPr>
           <a:xfrm>
-            <a:off x="11203655" y="5456371"/>
+            <a:off x="11203655" y="5424769"/>
             <a:ext cx="53035" cy="53035"/>
           </a:xfrm>
           <a:prstGeom prst="ellipse">
@@ -29810,7 +29810,7 @@
         </p:nvSpPr>
         <p:spPr>
           <a:xfrm>
-            <a:off x="11324681" y="5736834"/>
+            <a:off x="11324681" y="5776336"/>
             <a:ext cx="53035" cy="53035"/>
           </a:xfrm>
           <a:prstGeom prst="ellipse">
@@ -32718,60 +32718,47 @@
                 <a:latin typeface="맑은 고딕"/>
                 <a:ea typeface="맑은 고딕"/>
               </a:rPr>
-              <a:t>Smoothing window — 후속 3-epoch median 으로 best 선택</a:t>
+              <a:t>Smoothing — 후속 3-epoch median best 선택</a:t>
             </a:r>
           </a:p>
         </p:txBody>
       </p:sp>
-      <p:sp>
-        <p:nvSpPr>
-          <p:cNvPr id="60" name="TextBox 59"/>
-          <p:cNvSpPr txBox="1"/>
-          <p:nvPr/>
-        </p:nvSpPr>
-        <p:spPr>
-          <a:xfrm>
-            <a:off x="1664208" y="4736592"/>
-            <a:ext cx="4197096" cy="420624"/>
-          </a:xfrm>
-          <a:prstGeom prst="rect">
-            <a:avLst/>
-          </a:prstGeom>
-          <a:noFill/>
-        </p:spPr>
-        <p:txBody>
-          <a:bodyPr wrap="square" anchor="t" lIns="0" rIns="0" tIns="0" bIns="0">
-            <a:spAutoFit/>
-          </a:bodyPr>
-          <a:lstStyle/>
-          <a:p>
-            <a:pPr algn="l"/>
-            <a:r>
-              <a:rPr sz="1200">
-                <a:solidFill>
-                  <a:srgbClr val="0F1E3D"/>
-                </a:solidFill>
-                <a:latin typeface="맑은 고딕"/>
-                <a:ea typeface="맑은 고딕"/>
-              </a:rPr>
-              <a:t>단일 epoch 최고 F1은 초기 hunting spike(학습 덜 됨),</a:t>
-            </a:r>
-          </a:p>
-          <a:p>
-            <a:pPr algn="l"/>
-            <a:r>
-              <a:rPr sz="1200" b="1">
-                <a:solidFill>
-                  <a:srgbClr val="0F1E3D"/>
-                </a:solidFill>
-                <a:latin typeface="맑은 고딕"/>
-                <a:ea typeface="맑은 고딕"/>
-              </a:rPr>
-              <a:t>후속 3-epoch median 이 더 높은 plateau 를 best 선택</a:t>
-            </a:r>
-          </a:p>
-        </p:txBody>
-      </p:sp>
+      <p:cxnSp>
+        <p:nvCxnSpPr>
+          <p:cNvPr id="60" name="Connector 59"/>
+          <p:cNvCxnSpPr/>
+          <p:nvPr/>
+        </p:nvCxnSpPr>
+        <p:spPr>
+          <a:xfrm flipV="1">
+            <a:off x="1700784" y="5574791"/>
+            <a:ext cx="320040" cy="158061"/>
+          </a:xfrm>
+          <a:prstGeom prst="line">
+            <a:avLst/>
+          </a:prstGeom>
+          <a:ln w="19050">
+            <a:solidFill>
+              <a:srgbClr val="AEB4BD"/>
+            </a:solidFill>
+          </a:ln>
+          <a:effectLst/>
+        </p:spPr>
+        <p:style>
+          <a:lnRef idx="2">
+            <a:schemeClr val="accent1"/>
+          </a:lnRef>
+          <a:fillRef idx="0">
+            <a:schemeClr val="accent1"/>
+          </a:fillRef>
+          <a:effectRef idx="1">
+            <a:schemeClr val="accent1"/>
+          </a:effectRef>
+          <a:fontRef idx="minor">
+            <a:schemeClr val="tx1"/>
+          </a:fontRef>
+        </p:style>
+      </p:cxnSp>
       <p:cxnSp>
         <p:nvCxnSpPr>
           <p:cNvPr id="61" name="Connector 60"/>
@@ -32780,8 +32767,8 @@
         </p:nvCxnSpPr>
         <p:spPr>
           <a:xfrm flipV="1">
-            <a:off x="1700784" y="5745479"/>
-            <a:ext cx="320040" cy="116260"/>
+            <a:off x="2020824" y="5469418"/>
+            <a:ext cx="320040" cy="105373"/>
           </a:xfrm>
           <a:prstGeom prst="line">
             <a:avLst/>
@@ -32816,8 +32803,8 @@
         </p:nvCxnSpPr>
         <p:spPr>
           <a:xfrm flipV="1">
-            <a:off x="2020824" y="5667973"/>
-            <a:ext cx="320040" cy="77506"/>
+            <a:off x="2340864" y="5390388"/>
+            <a:ext cx="320040" cy="79030"/>
           </a:xfrm>
           <a:prstGeom prst="line">
             <a:avLst/>
@@ -32852,8 +32839,8 @@
         </p:nvCxnSpPr>
         <p:spPr>
           <a:xfrm flipV="1">
-            <a:off x="2340864" y="5609844"/>
-            <a:ext cx="320040" cy="58129"/>
+            <a:off x="2660904" y="4916206"/>
+            <a:ext cx="320040" cy="474182"/>
           </a:xfrm>
           <a:prstGeom prst="line">
             <a:avLst/>
@@ -32887,9 +32874,9 @@
           <p:nvPr/>
         </p:nvCxnSpPr>
         <p:spPr>
-          <a:xfrm flipV="1">
-            <a:off x="2660904" y="5261065"/>
-            <a:ext cx="320040" cy="348779"/>
+          <a:xfrm>
+            <a:off x="2980944" y="4916206"/>
+            <a:ext cx="320040" cy="632242"/>
           </a:xfrm>
           <a:prstGeom prst="line">
             <a:avLst/>
@@ -32923,9 +32910,9 @@
           <p:nvPr/>
         </p:nvCxnSpPr>
         <p:spPr>
-          <a:xfrm>
-            <a:off x="2980944" y="5261065"/>
-            <a:ext cx="320040" cy="465038"/>
+          <a:xfrm flipV="1">
+            <a:off x="3300984" y="5364044"/>
+            <a:ext cx="320040" cy="184404"/>
           </a:xfrm>
           <a:prstGeom prst="line">
             <a:avLst/>
@@ -32960,8 +32947,8 @@
         </p:nvCxnSpPr>
         <p:spPr>
           <a:xfrm flipV="1">
-            <a:off x="3300984" y="5590467"/>
-            <a:ext cx="320040" cy="135636"/>
+            <a:off x="3621024" y="5285014"/>
+            <a:ext cx="320040" cy="79030"/>
           </a:xfrm>
           <a:prstGeom prst="line">
             <a:avLst/>
@@ -32996,8 +32983,8 @@
         </p:nvCxnSpPr>
         <p:spPr>
           <a:xfrm flipV="1">
-            <a:off x="3621024" y="5532337"/>
-            <a:ext cx="320040" cy="58130"/>
+            <a:off x="3941064" y="5232327"/>
+            <a:ext cx="320040" cy="52687"/>
           </a:xfrm>
           <a:prstGeom prst="line">
             <a:avLst/>
@@ -33032,8 +33019,8 @@
         </p:nvCxnSpPr>
         <p:spPr>
           <a:xfrm flipV="1">
-            <a:off x="3941064" y="5493584"/>
-            <a:ext cx="320040" cy="38753"/>
+            <a:off x="4261104" y="5179640"/>
+            <a:ext cx="320040" cy="52687"/>
           </a:xfrm>
           <a:prstGeom prst="line">
             <a:avLst/>
@@ -33068,8 +33055,8 @@
         </p:nvCxnSpPr>
         <p:spPr>
           <a:xfrm flipV="1">
-            <a:off x="4261104" y="5454831"/>
-            <a:ext cx="320040" cy="38753"/>
+            <a:off x="4581144" y="5166468"/>
+            <a:ext cx="320040" cy="13172"/>
           </a:xfrm>
           <a:prstGeom prst="line">
             <a:avLst/>
@@ -33104,8 +33091,8 @@
         </p:nvCxnSpPr>
         <p:spPr>
           <a:xfrm flipV="1">
-            <a:off x="4581144" y="5445143"/>
-            <a:ext cx="320040" cy="9688"/>
+            <a:off x="4901184" y="5153297"/>
+            <a:ext cx="320040" cy="13171"/>
           </a:xfrm>
           <a:prstGeom prst="line">
             <a:avLst/>
@@ -33140,8 +33127,8 @@
         </p:nvCxnSpPr>
         <p:spPr>
           <a:xfrm flipV="1">
-            <a:off x="4901184" y="5435454"/>
-            <a:ext cx="320040" cy="9689"/>
+            <a:off x="5221224" y="5140125"/>
+            <a:ext cx="320040" cy="13172"/>
           </a:xfrm>
           <a:prstGeom prst="line">
             <a:avLst/>
@@ -33175,9 +33162,9 @@
           <p:nvPr/>
         </p:nvCxnSpPr>
         <p:spPr>
-          <a:xfrm flipV="1">
-            <a:off x="5221224" y="5425766"/>
-            <a:ext cx="320040" cy="9688"/>
+          <a:xfrm>
+            <a:off x="5541264" y="5140125"/>
+            <a:ext cx="320040" cy="13172"/>
           </a:xfrm>
           <a:prstGeom prst="line">
             <a:avLst/>
@@ -33211,16 +33198,16 @@
           <p:nvPr/>
         </p:nvCxnSpPr>
         <p:spPr>
-          <a:xfrm>
-            <a:off x="5541264" y="5425766"/>
-            <a:ext cx="320040" cy="9688"/>
+          <a:xfrm flipV="1">
+            <a:off x="1700784" y="5469418"/>
+            <a:ext cx="320040" cy="105373"/>
           </a:xfrm>
           <a:prstGeom prst="line">
             <a:avLst/>
           </a:prstGeom>
-          <a:ln w="19050">
+          <a:ln w="35560">
             <a:solidFill>
-              <a:srgbClr val="AEB4BD"/>
+              <a:srgbClr val="3A6FD0"/>
             </a:solidFill>
           </a:ln>
           <a:effectLst/>
@@ -33248,8 +33235,8 @@
         </p:nvCxnSpPr>
         <p:spPr>
           <a:xfrm flipV="1">
-            <a:off x="1700784" y="5667973"/>
-            <a:ext cx="320040" cy="77506"/>
+            <a:off x="2020824" y="5390388"/>
+            <a:ext cx="320040" cy="79030"/>
           </a:xfrm>
           <a:prstGeom prst="line">
             <a:avLst/>
@@ -33283,9 +33270,9 @@
           <p:nvPr/>
         </p:nvCxnSpPr>
         <p:spPr>
-          <a:xfrm flipV="1">
-            <a:off x="2020824" y="5609844"/>
-            <a:ext cx="320040" cy="58129"/>
+          <a:xfrm>
+            <a:off x="2340864" y="5390388"/>
+            <a:ext cx="320040" cy="0"/>
           </a:xfrm>
           <a:prstGeom prst="line">
             <a:avLst/>
@@ -33319,9 +33306,9 @@
           <p:nvPr/>
         </p:nvCxnSpPr>
         <p:spPr>
-          <a:xfrm>
-            <a:off x="2340864" y="5609844"/>
-            <a:ext cx="320040" cy="0"/>
+          <a:xfrm flipV="1">
+            <a:off x="2660904" y="5364044"/>
+            <a:ext cx="320040" cy="26344"/>
           </a:xfrm>
           <a:prstGeom prst="line">
             <a:avLst/>
@@ -33355,9 +33342,9 @@
           <p:nvPr/>
         </p:nvCxnSpPr>
         <p:spPr>
-          <a:xfrm flipV="1">
-            <a:off x="2660904" y="5590467"/>
-            <a:ext cx="320040" cy="19377"/>
+          <a:xfrm>
+            <a:off x="2980944" y="5364044"/>
+            <a:ext cx="320040" cy="0"/>
           </a:xfrm>
           <a:prstGeom prst="line">
             <a:avLst/>
@@ -33391,9 +33378,9 @@
           <p:nvPr/>
         </p:nvCxnSpPr>
         <p:spPr>
-          <a:xfrm>
-            <a:off x="2980944" y="5590467"/>
-            <a:ext cx="320040" cy="0"/>
+          <a:xfrm flipV="1">
+            <a:off x="3300984" y="5285014"/>
+            <a:ext cx="320040" cy="79030"/>
           </a:xfrm>
           <a:prstGeom prst="line">
             <a:avLst/>
@@ -33428,8 +33415,8 @@
         </p:nvCxnSpPr>
         <p:spPr>
           <a:xfrm flipV="1">
-            <a:off x="3300984" y="5532337"/>
-            <a:ext cx="320040" cy="58130"/>
+            <a:off x="3621024" y="5232327"/>
+            <a:ext cx="320040" cy="52687"/>
           </a:xfrm>
           <a:prstGeom prst="line">
             <a:avLst/>
@@ -33464,8 +33451,8 @@
         </p:nvCxnSpPr>
         <p:spPr>
           <a:xfrm flipV="1">
-            <a:off x="3621024" y="5493584"/>
-            <a:ext cx="320040" cy="38753"/>
+            <a:off x="3941064" y="5179640"/>
+            <a:ext cx="320040" cy="52687"/>
           </a:xfrm>
           <a:prstGeom prst="line">
             <a:avLst/>
@@ -33500,8 +33487,8 @@
         </p:nvCxnSpPr>
         <p:spPr>
           <a:xfrm flipV="1">
-            <a:off x="3941064" y="5454831"/>
-            <a:ext cx="320040" cy="38753"/>
+            <a:off x="4261104" y="5166468"/>
+            <a:ext cx="320040" cy="13172"/>
           </a:xfrm>
           <a:prstGeom prst="line">
             <a:avLst/>
@@ -33536,8 +33523,8 @@
         </p:nvCxnSpPr>
         <p:spPr>
           <a:xfrm flipV="1">
-            <a:off x="4261104" y="5445143"/>
-            <a:ext cx="320040" cy="9688"/>
+            <a:off x="4581144" y="5153297"/>
+            <a:ext cx="320040" cy="13171"/>
           </a:xfrm>
           <a:prstGeom prst="line">
             <a:avLst/>
@@ -33571,9 +33558,9 @@
           <p:nvPr/>
         </p:nvCxnSpPr>
         <p:spPr>
-          <a:xfrm flipV="1">
-            <a:off x="4581144" y="5435454"/>
-            <a:ext cx="320040" cy="9689"/>
+          <a:xfrm>
+            <a:off x="4901184" y="5153297"/>
+            <a:ext cx="320040" cy="0"/>
           </a:xfrm>
           <a:prstGeom prst="line">
             <a:avLst/>
@@ -33600,139 +33587,103 @@
           </a:fontRef>
         </p:style>
       </p:cxnSp>
+      <p:sp>
+        <p:nvSpPr>
+          <p:cNvPr id="84" name="Oval 83"/>
+          <p:cNvSpPr/>
+          <p:nvPr/>
+        </p:nvSpPr>
+        <p:spPr>
+          <a:xfrm>
+            <a:off x="2930652" y="4865914"/>
+            <a:ext cx="100584" cy="100584"/>
+          </a:xfrm>
+          <a:prstGeom prst="ellipse">
+            <a:avLst/>
+          </a:prstGeom>
+          <a:solidFill>
+            <a:srgbClr val="CC3328"/>
+          </a:solidFill>
+          <a:ln>
+            <a:noFill/>
+          </a:ln>
+          <a:effectLst/>
+        </p:spPr>
+        <p:style>
+          <a:lnRef idx="1">
+            <a:schemeClr val="accent1"/>
+          </a:lnRef>
+          <a:fillRef idx="3">
+            <a:schemeClr val="accent1"/>
+          </a:fillRef>
+          <a:effectRef idx="2">
+            <a:schemeClr val="accent1"/>
+          </a:effectRef>
+          <a:fontRef idx="minor">
+            <a:schemeClr val="lt1"/>
+          </a:fontRef>
+        </p:style>
+        <p:txBody>
+          <a:bodyPr rtlCol="0" anchor="ctr"/>
+          <a:lstStyle/>
+          <a:p>
+            <a:pPr algn="ctr"/>
+          </a:p>
+        </p:txBody>
+      </p:sp>
+      <p:sp>
+        <p:nvSpPr>
+          <p:cNvPr id="85" name="Diamond 84"/>
+          <p:cNvSpPr/>
+          <p:nvPr/>
+        </p:nvSpPr>
+        <p:spPr>
+          <a:xfrm>
+            <a:off x="4832604" y="5084717"/>
+            <a:ext cx="137160" cy="137160"/>
+          </a:xfrm>
+          <a:prstGeom prst="diamond">
+            <a:avLst/>
+          </a:prstGeom>
+          <a:solidFill>
+            <a:srgbClr val="0F1E3D"/>
+          </a:solidFill>
+          <a:ln>
+            <a:noFill/>
+          </a:ln>
+          <a:effectLst/>
+        </p:spPr>
+        <p:style>
+          <a:lnRef idx="1">
+            <a:schemeClr val="accent1"/>
+          </a:lnRef>
+          <a:fillRef idx="3">
+            <a:schemeClr val="accent1"/>
+          </a:fillRef>
+          <a:effectRef idx="2">
+            <a:schemeClr val="accent1"/>
+          </a:effectRef>
+          <a:fontRef idx="minor">
+            <a:schemeClr val="lt1"/>
+          </a:fontRef>
+        </p:style>
+        <p:txBody>
+          <a:bodyPr rtlCol="0" anchor="ctr"/>
+          <a:lstStyle/>
+          <a:p>
+            <a:pPr algn="ctr"/>
+          </a:p>
+        </p:txBody>
+      </p:sp>
       <p:cxnSp>
         <p:nvCxnSpPr>
-          <p:cNvPr id="84" name="Connector 83"/>
+          <p:cNvPr id="86" name="Connector 85"/>
           <p:cNvCxnSpPr/>
           <p:nvPr/>
         </p:nvCxnSpPr>
         <p:spPr>
           <a:xfrm>
-            <a:off x="4901184" y="5435454"/>
-            <a:ext cx="320040" cy="0"/>
-          </a:xfrm>
-          <a:prstGeom prst="line">
-            <a:avLst/>
-          </a:prstGeom>
-          <a:ln w="35560">
-            <a:solidFill>
-              <a:srgbClr val="3A6FD0"/>
-            </a:solidFill>
-          </a:ln>
-          <a:effectLst/>
-        </p:spPr>
-        <p:style>
-          <a:lnRef idx="2">
-            <a:schemeClr val="accent1"/>
-          </a:lnRef>
-          <a:fillRef idx="0">
-            <a:schemeClr val="accent1"/>
-          </a:fillRef>
-          <a:effectRef idx="1">
-            <a:schemeClr val="accent1"/>
-          </a:effectRef>
-          <a:fontRef idx="minor">
-            <a:schemeClr val="tx1"/>
-          </a:fontRef>
-        </p:style>
-      </p:cxnSp>
-      <p:sp>
-        <p:nvSpPr>
-          <p:cNvPr id="85" name="Oval 84"/>
-          <p:cNvSpPr/>
-          <p:nvPr/>
-        </p:nvSpPr>
-        <p:spPr>
-          <a:xfrm>
-            <a:off x="2930652" y="5210773"/>
-            <a:ext cx="100584" cy="100584"/>
-          </a:xfrm>
-          <a:prstGeom prst="ellipse">
-            <a:avLst/>
-          </a:prstGeom>
-          <a:solidFill>
-            <a:srgbClr val="CC3328"/>
-          </a:solidFill>
-          <a:ln>
-            <a:noFill/>
-          </a:ln>
-          <a:effectLst/>
-        </p:spPr>
-        <p:style>
-          <a:lnRef idx="1">
-            <a:schemeClr val="accent1"/>
-          </a:lnRef>
-          <a:fillRef idx="3">
-            <a:schemeClr val="accent1"/>
-          </a:fillRef>
-          <a:effectRef idx="2">
-            <a:schemeClr val="accent1"/>
-          </a:effectRef>
-          <a:fontRef idx="minor">
-            <a:schemeClr val="lt1"/>
-          </a:fontRef>
-        </p:style>
-        <p:txBody>
-          <a:bodyPr rtlCol="0" anchor="ctr"/>
-          <a:lstStyle/>
-          <a:p>
-            <a:pPr algn="ctr"/>
-          </a:p>
-        </p:txBody>
-      </p:sp>
-      <p:sp>
-        <p:nvSpPr>
-          <p:cNvPr id="86" name="Diamond 85"/>
-          <p:cNvSpPr/>
-          <p:nvPr/>
-        </p:nvSpPr>
-        <p:spPr>
-          <a:xfrm>
-            <a:off x="4832604" y="5366874"/>
-            <a:ext cx="137160" cy="137160"/>
-          </a:xfrm>
-          <a:prstGeom prst="diamond">
-            <a:avLst/>
-          </a:prstGeom>
-          <a:solidFill>
-            <a:srgbClr val="0F1E3D"/>
-          </a:solidFill>
-          <a:ln>
-            <a:noFill/>
-          </a:ln>
-          <a:effectLst/>
-        </p:spPr>
-        <p:style>
-          <a:lnRef idx="1">
-            <a:schemeClr val="accent1"/>
-          </a:lnRef>
-          <a:fillRef idx="3">
-            <a:schemeClr val="accent1"/>
-          </a:fillRef>
-          <a:effectRef idx="2">
-            <a:schemeClr val="accent1"/>
-          </a:effectRef>
-          <a:fontRef idx="minor">
-            <a:schemeClr val="lt1"/>
-          </a:fontRef>
-        </p:style>
-        <p:txBody>
-          <a:bodyPr rtlCol="0" anchor="ctr"/>
-          <a:lstStyle/>
-          <a:p>
-            <a:pPr algn="ctr"/>
-          </a:p>
-        </p:txBody>
-      </p:sp>
-      <p:cxnSp>
-        <p:nvCxnSpPr>
-          <p:cNvPr id="87" name="Connector 86"/>
-          <p:cNvCxnSpPr/>
-          <p:nvPr/>
-        </p:nvCxnSpPr>
-        <p:spPr>
-          <a:xfrm>
-            <a:off x="1700784" y="6016752"/>
+            <a:off x="1700784" y="5943600"/>
             <a:ext cx="4160520" cy="0"/>
           </a:xfrm>
           <a:prstGeom prst="line">
@@ -33762,13 +33713,13 @@
       </p:cxnSp>
       <p:sp>
         <p:nvSpPr>
-          <p:cNvPr id="88" name="TextBox 87"/>
+          <p:cNvPr id="87" name="TextBox 86"/>
           <p:cNvSpPr txBox="1"/>
           <p:nvPr/>
         </p:nvSpPr>
         <p:spPr>
           <a:xfrm>
-            <a:off x="1609344" y="6030468"/>
+            <a:off x="1609344" y="6012180"/>
             <a:ext cx="4288536" cy="173736"/>
           </a:xfrm>
           <a:prstGeom prst="rect">
@@ -33808,7 +33759,7 @@
       </p:sp>
       <p:sp>
         <p:nvSpPr>
-          <p:cNvPr id="89" name="TextBox 88"/>
+          <p:cNvPr id="88" name="TextBox 87"/>
           <p:cNvSpPr txBox="1"/>
           <p:nvPr/>
         </p:nvSpPr>
@@ -33837,14 +33788,14 @@
                 <a:latin typeface="맑은 고딕"/>
                 <a:ea typeface="맑은 고딕"/>
               </a:rPr>
-              <a:t>Color 변경 전후 — 배경 대비 색차↑(빨강) → 분리도 향상</a:t>
+              <a:t>Color 변경 전후 — 빨강(c01)이 배경 대비 색차 큼</a:t>
             </a:r>
           </a:p>
         </p:txBody>
       </p:sp>
       <p:sp>
         <p:nvSpPr>
-          <p:cNvPr id="90" name="TextBox 89"/>
+          <p:cNvPr id="89" name="TextBox 88"/>
           <p:cNvSpPr txBox="1"/>
           <p:nvPr/>
         </p:nvSpPr>
@@ -33866,41 +33817,21 @@
           <a:p>
             <a:pPr algn="ctr"/>
             <a:r>
-              <a:rPr sz="1200">
-                <a:solidFill>
-                  <a:srgbClr val="6B7280"/>
-                </a:solidFill>
-                <a:latin typeface="맑은 고딕"/>
-                <a:ea typeface="맑은 고딕"/>
-              </a:rPr>
-              <a:t>색 단변수 5-seed:  </a:t>
-            </a:r>
-            <a:r>
-              <a:rPr sz="1200" b="1">
+              <a:rPr sz="1300" b="1">
                 <a:solidFill>
                   <a:srgbClr val="0F1E3D"/>
                 </a:solidFill>
                 <a:latin typeface="맑은 고딕"/>
                 <a:ea typeface="맑은 고딕"/>
               </a:rPr>
-              <a:t>F1 +0.0008</a:t>
-            </a:r>
-            <a:r>
-              <a:rPr sz="1200">
-                <a:solidFill>
-                  <a:srgbClr val="6B7280"/>
-                </a:solidFill>
-                <a:latin typeface="맑은 고딕"/>
-                <a:ea typeface="맑은 고딕"/>
-              </a:rPr>
-              <a:t>  ·  놓친 불량 −0.8  ·  오경보 −0.4</a:t>
+              <a:t>→ F1 +0.001,  FN/FP 약 1개씩 감소</a:t>
             </a:r>
           </a:p>
         </p:txBody>
       </p:sp>
       <p:pic>
         <p:nvPicPr>
-          <p:cNvPr id="91" name="Picture 90" descr="p3r_color_baseline.png"/>
+          <p:cNvPr id="90" name="Picture 89" descr="p3r_color_baseline.png"/>
           <p:cNvPicPr>
             <a:picLocks noChangeAspect="1"/>
           </p:cNvPicPr>
@@ -33924,7 +33855,7 @@
       </p:pic>
       <p:sp>
         <p:nvSpPr>
-          <p:cNvPr id="92" name="TextBox 91"/>
+          <p:cNvPr id="91" name="TextBox 90"/>
           <p:cNvSpPr txBox="1"/>
           <p:nvPr/>
         </p:nvSpPr>
@@ -33960,7 +33891,7 @@
       </p:sp>
       <p:pic>
         <p:nvPicPr>
-          <p:cNvPr id="93" name="Picture 92" descr="p3r_color_c01.png"/>
+          <p:cNvPr id="92" name="Picture 91" descr="p3r_color_c01.png"/>
           <p:cNvPicPr>
             <a:picLocks noChangeAspect="1"/>
           </p:cNvPicPr>
@@ -33984,7 +33915,7 @@
       </p:pic>
       <p:sp>
         <p:nvSpPr>
-          <p:cNvPr id="94" name="TextBox 93"/>
+          <p:cNvPr id="93" name="TextBox 92"/>
           <p:cNvSpPr txBox="1"/>
           <p:nvPr/>
         </p:nvSpPr>
@@ -34020,7 +33951,7 @@
       </p:sp>
       <p:sp>
         <p:nvSpPr>
-          <p:cNvPr id="95" name="TextBox 94"/>
+          <p:cNvPr id="94" name="TextBox 93"/>
           <p:cNvSpPr txBox="1"/>
           <p:nvPr/>
         </p:nvSpPr>
@@ -34056,7 +33987,7 @@
       </p:sp>
       <p:sp>
         <p:nvSpPr>
-          <p:cNvPr id="96" name="TextBox 95"/>
+          <p:cNvPr id="95" name="TextBox 94"/>
           <p:cNvSpPr txBox="1"/>
           <p:nvPr/>
         </p:nvSpPr>

</xml_diff>

<commit_message>
P3 slide4 Q3 smoothing — 축 라벨(val F1 / epoch) 추가 + 곡선 가로 축소
사용자: x축 epoch 표시 / y축 val F1 표시 / 트렌드 가로 길이 축소. y축 라벨 'val F1'(좌상단)+y축선, x축 라벨 'epoch'(하단 중앙)+x축선 추가, sl/sr 좁혀 곡선 폭 축소.

Co-Authored-By: Claude Opus 4.8 (1M context) <noreply@anthropic.com>
</commit_message>
<xml_diff>
--- a/recommendation/presentation/발표_P3_데이터생성_최호길.pptx
+++ b/recommendation/presentation/발표_P3_데이터생성_최호길.pptx
@@ -32723,42 +32723,42 @@
           </a:p>
         </p:txBody>
       </p:sp>
-      <p:cxnSp>
-        <p:nvCxnSpPr>
-          <p:cNvPr id="60" name="Connector 59"/>
-          <p:cNvCxnSpPr/>
-          <p:nvPr/>
-        </p:nvCxnSpPr>
-        <p:spPr>
-          <a:xfrm flipV="1">
-            <a:off x="1700784" y="5574791"/>
-            <a:ext cx="320040" cy="158061"/>
-          </a:xfrm>
-          <a:prstGeom prst="line">
-            <a:avLst/>
-          </a:prstGeom>
-          <a:ln w="19050">
-            <a:solidFill>
-              <a:srgbClr val="AEB4BD"/>
-            </a:solidFill>
-          </a:ln>
-          <a:effectLst/>
-        </p:spPr>
-        <p:style>
-          <a:lnRef idx="2">
-            <a:schemeClr val="accent1"/>
-          </a:lnRef>
-          <a:fillRef idx="0">
-            <a:schemeClr val="accent1"/>
-          </a:fillRef>
-          <a:effectRef idx="1">
-            <a:schemeClr val="accent1"/>
-          </a:effectRef>
-          <a:fontRef idx="minor">
-            <a:schemeClr val="tx1"/>
-          </a:fontRef>
-        </p:style>
-      </p:cxnSp>
+      <p:sp>
+        <p:nvSpPr>
+          <p:cNvPr id="60" name="TextBox 59"/>
+          <p:cNvSpPr txBox="1"/>
+          <p:nvPr/>
+        </p:nvSpPr>
+        <p:spPr>
+          <a:xfrm>
+            <a:off x="1609344" y="4727448"/>
+            <a:ext cx="1097280" cy="164592"/>
+          </a:xfrm>
+          <a:prstGeom prst="rect">
+            <a:avLst/>
+          </a:prstGeom>
+          <a:noFill/>
+        </p:spPr>
+        <p:txBody>
+          <a:bodyPr wrap="none" anchor="ctr" lIns="0" rIns="0" tIns="0" bIns="0">
+            <a:spAutoFit/>
+          </a:bodyPr>
+          <a:lstStyle/>
+          <a:p>
+            <a:pPr algn="l"/>
+            <a:r>
+              <a:rPr sz="1100">
+                <a:solidFill>
+                  <a:srgbClr val="6B7280"/>
+                </a:solidFill>
+                <a:latin typeface="맑은 고딕"/>
+                <a:ea typeface="맑은 고딕"/>
+              </a:rPr>
+              <a:t>val F1</a:t>
+            </a:r>
+          </a:p>
+        </p:txBody>
+      </p:sp>
       <p:cxnSp>
         <p:nvCxnSpPr>
           <p:cNvPr id="61" name="Connector 60"/>
@@ -32767,8 +32767,8 @@
         </p:nvCxnSpPr>
         <p:spPr>
           <a:xfrm flipV="1">
-            <a:off x="2020824" y="5469418"/>
-            <a:ext cx="320040" cy="105373"/>
+            <a:off x="1929384" y="5489447"/>
+            <a:ext cx="284167" cy="124098"/>
           </a:xfrm>
           <a:prstGeom prst="line">
             <a:avLst/>
@@ -32803,8 +32803,8 @@
         </p:nvCxnSpPr>
         <p:spPr>
           <a:xfrm flipV="1">
-            <a:off x="2340864" y="5390388"/>
-            <a:ext cx="320040" cy="79030"/>
+            <a:off x="2213551" y="5406716"/>
+            <a:ext cx="284167" cy="82731"/>
           </a:xfrm>
           <a:prstGeom prst="line">
             <a:avLst/>
@@ -32839,8 +32839,8 @@
         </p:nvCxnSpPr>
         <p:spPr>
           <a:xfrm flipV="1">
-            <a:off x="2660904" y="4916206"/>
-            <a:ext cx="320040" cy="474182"/>
+            <a:off x="2497718" y="5344668"/>
+            <a:ext cx="284168" cy="62048"/>
           </a:xfrm>
           <a:prstGeom prst="line">
             <a:avLst/>
@@ -32874,9 +32874,9 @@
           <p:nvPr/>
         </p:nvCxnSpPr>
         <p:spPr>
-          <a:xfrm>
-            <a:off x="2980944" y="4916206"/>
-            <a:ext cx="320040" cy="632242"/>
+          <a:xfrm flipV="1">
+            <a:off x="2781886" y="4972376"/>
+            <a:ext cx="284167" cy="372292"/>
           </a:xfrm>
           <a:prstGeom prst="line">
             <a:avLst/>
@@ -32910,9 +32910,9 @@
           <p:nvPr/>
         </p:nvCxnSpPr>
         <p:spPr>
-          <a:xfrm flipV="1">
-            <a:off x="3300984" y="5364044"/>
-            <a:ext cx="320040" cy="184404"/>
+          <a:xfrm>
+            <a:off x="3066053" y="4972376"/>
+            <a:ext cx="284167" cy="496389"/>
           </a:xfrm>
           <a:prstGeom prst="line">
             <a:avLst/>
@@ -32947,8 +32947,8 @@
         </p:nvCxnSpPr>
         <p:spPr>
           <a:xfrm flipV="1">
-            <a:off x="3621024" y="5285014"/>
-            <a:ext cx="320040" cy="79030"/>
+            <a:off x="3350220" y="5323985"/>
+            <a:ext cx="284168" cy="144780"/>
           </a:xfrm>
           <a:prstGeom prst="line">
             <a:avLst/>
@@ -32983,8 +32983,8 @@
         </p:nvCxnSpPr>
         <p:spPr>
           <a:xfrm flipV="1">
-            <a:off x="3941064" y="5232327"/>
-            <a:ext cx="320040" cy="52687"/>
+            <a:off x="3634388" y="5261936"/>
+            <a:ext cx="284167" cy="62049"/>
           </a:xfrm>
           <a:prstGeom prst="line">
             <a:avLst/>
@@ -33019,8 +33019,8 @@
         </p:nvCxnSpPr>
         <p:spPr>
           <a:xfrm flipV="1">
-            <a:off x="4261104" y="5179640"/>
-            <a:ext cx="320040" cy="52687"/>
+            <a:off x="3918555" y="5220570"/>
+            <a:ext cx="284168" cy="41366"/>
           </a:xfrm>
           <a:prstGeom prst="line">
             <a:avLst/>
@@ -33055,8 +33055,8 @@
         </p:nvCxnSpPr>
         <p:spPr>
           <a:xfrm flipV="1">
-            <a:off x="4581144" y="5166468"/>
-            <a:ext cx="320040" cy="13172"/>
+            <a:off x="4202723" y="5179205"/>
+            <a:ext cx="284167" cy="41365"/>
           </a:xfrm>
           <a:prstGeom prst="line">
             <a:avLst/>
@@ -33091,8 +33091,8 @@
         </p:nvCxnSpPr>
         <p:spPr>
           <a:xfrm flipV="1">
-            <a:off x="4901184" y="5153297"/>
-            <a:ext cx="320040" cy="13171"/>
+            <a:off x="4486890" y="5168863"/>
+            <a:ext cx="284167" cy="10342"/>
           </a:xfrm>
           <a:prstGeom prst="line">
             <a:avLst/>
@@ -33127,8 +33127,8 @@
         </p:nvCxnSpPr>
         <p:spPr>
           <a:xfrm flipV="1">
-            <a:off x="5221224" y="5140125"/>
-            <a:ext cx="320040" cy="13172"/>
+            <a:off x="4771057" y="5158522"/>
+            <a:ext cx="284168" cy="10341"/>
           </a:xfrm>
           <a:prstGeom prst="line">
             <a:avLst/>
@@ -33162,9 +33162,9 @@
           <p:nvPr/>
         </p:nvCxnSpPr>
         <p:spPr>
-          <a:xfrm>
-            <a:off x="5541264" y="5140125"/>
-            <a:ext cx="320040" cy="13172"/>
+          <a:xfrm flipV="1">
+            <a:off x="5055225" y="5148180"/>
+            <a:ext cx="284167" cy="10342"/>
           </a:xfrm>
           <a:prstGeom prst="line">
             <a:avLst/>
@@ -33198,16 +33198,16 @@
           <p:nvPr/>
         </p:nvCxnSpPr>
         <p:spPr>
-          <a:xfrm flipV="1">
-            <a:off x="1700784" y="5469418"/>
-            <a:ext cx="320040" cy="105373"/>
+          <a:xfrm>
+            <a:off x="5339392" y="5148180"/>
+            <a:ext cx="284168" cy="10342"/>
           </a:xfrm>
           <a:prstGeom prst="line">
             <a:avLst/>
           </a:prstGeom>
-          <a:ln w="35560">
+          <a:ln w="19050">
             <a:solidFill>
-              <a:srgbClr val="3A6FD0"/>
+              <a:srgbClr val="AEB4BD"/>
             </a:solidFill>
           </a:ln>
           <a:effectLst/>
@@ -33235,8 +33235,8 @@
         </p:nvCxnSpPr>
         <p:spPr>
           <a:xfrm flipV="1">
-            <a:off x="2020824" y="5390388"/>
-            <a:ext cx="320040" cy="79030"/>
+            <a:off x="1929384" y="5406716"/>
+            <a:ext cx="284167" cy="82731"/>
           </a:xfrm>
           <a:prstGeom prst="line">
             <a:avLst/>
@@ -33270,9 +33270,9 @@
           <p:nvPr/>
         </p:nvCxnSpPr>
         <p:spPr>
-          <a:xfrm>
-            <a:off x="2340864" y="5390388"/>
-            <a:ext cx="320040" cy="0"/>
+          <a:xfrm flipV="1">
+            <a:off x="2213551" y="5344668"/>
+            <a:ext cx="284167" cy="62048"/>
           </a:xfrm>
           <a:prstGeom prst="line">
             <a:avLst/>
@@ -33306,9 +33306,9 @@
           <p:nvPr/>
         </p:nvCxnSpPr>
         <p:spPr>
-          <a:xfrm flipV="1">
-            <a:off x="2660904" y="5364044"/>
-            <a:ext cx="320040" cy="26344"/>
+          <a:xfrm>
+            <a:off x="2497718" y="5344668"/>
+            <a:ext cx="284168" cy="0"/>
           </a:xfrm>
           <a:prstGeom prst="line">
             <a:avLst/>
@@ -33342,9 +33342,9 @@
           <p:nvPr/>
         </p:nvCxnSpPr>
         <p:spPr>
-          <a:xfrm>
-            <a:off x="2980944" y="5364044"/>
-            <a:ext cx="320040" cy="0"/>
+          <a:xfrm flipV="1">
+            <a:off x="2781886" y="5323985"/>
+            <a:ext cx="284167" cy="20683"/>
           </a:xfrm>
           <a:prstGeom prst="line">
             <a:avLst/>
@@ -33378,9 +33378,9 @@
           <p:nvPr/>
         </p:nvCxnSpPr>
         <p:spPr>
-          <a:xfrm flipV="1">
-            <a:off x="3300984" y="5285014"/>
-            <a:ext cx="320040" cy="79030"/>
+          <a:xfrm>
+            <a:off x="3066053" y="5323985"/>
+            <a:ext cx="284167" cy="0"/>
           </a:xfrm>
           <a:prstGeom prst="line">
             <a:avLst/>
@@ -33415,8 +33415,8 @@
         </p:nvCxnSpPr>
         <p:spPr>
           <a:xfrm flipV="1">
-            <a:off x="3621024" y="5232327"/>
-            <a:ext cx="320040" cy="52687"/>
+            <a:off x="3350220" y="5261936"/>
+            <a:ext cx="284168" cy="62049"/>
           </a:xfrm>
           <a:prstGeom prst="line">
             <a:avLst/>
@@ -33451,8 +33451,8 @@
         </p:nvCxnSpPr>
         <p:spPr>
           <a:xfrm flipV="1">
-            <a:off x="3941064" y="5179640"/>
-            <a:ext cx="320040" cy="52687"/>
+            <a:off x="3634388" y="5220570"/>
+            <a:ext cx="284167" cy="41366"/>
           </a:xfrm>
           <a:prstGeom prst="line">
             <a:avLst/>
@@ -33487,8 +33487,8 @@
         </p:nvCxnSpPr>
         <p:spPr>
           <a:xfrm flipV="1">
-            <a:off x="4261104" y="5166468"/>
-            <a:ext cx="320040" cy="13172"/>
+            <a:off x="3918555" y="5179205"/>
+            <a:ext cx="284168" cy="41365"/>
           </a:xfrm>
           <a:prstGeom prst="line">
             <a:avLst/>
@@ -33523,8 +33523,8 @@
         </p:nvCxnSpPr>
         <p:spPr>
           <a:xfrm flipV="1">
-            <a:off x="4581144" y="5153297"/>
-            <a:ext cx="320040" cy="13171"/>
+            <a:off x="4202723" y="5168863"/>
+            <a:ext cx="284167" cy="10342"/>
           </a:xfrm>
           <a:prstGeom prst="line">
             <a:avLst/>
@@ -33558,9 +33558,9 @@
           <p:nvPr/>
         </p:nvCxnSpPr>
         <p:spPr>
-          <a:xfrm>
-            <a:off x="4901184" y="5153297"/>
-            <a:ext cx="320040" cy="0"/>
+          <a:xfrm flipV="1">
+            <a:off x="4486890" y="5158522"/>
+            <a:ext cx="284167" cy="10341"/>
           </a:xfrm>
           <a:prstGeom prst="line">
             <a:avLst/>
@@ -33587,104 +33587,140 @@
           </a:fontRef>
         </p:style>
       </p:cxnSp>
-      <p:sp>
-        <p:nvSpPr>
-          <p:cNvPr id="84" name="Oval 83"/>
-          <p:cNvSpPr/>
-          <p:nvPr/>
-        </p:nvSpPr>
-        <p:spPr>
-          <a:xfrm>
-            <a:off x="2930652" y="4865914"/>
-            <a:ext cx="100584" cy="100584"/>
-          </a:xfrm>
-          <a:prstGeom prst="ellipse">
-            <a:avLst/>
-          </a:prstGeom>
-          <a:solidFill>
-            <a:srgbClr val="CC3328"/>
-          </a:solidFill>
-          <a:ln>
-            <a:noFill/>
-          </a:ln>
-          <a:effectLst/>
-        </p:spPr>
-        <p:style>
-          <a:lnRef idx="1">
-            <a:schemeClr val="accent1"/>
-          </a:lnRef>
-          <a:fillRef idx="3">
-            <a:schemeClr val="accent1"/>
-          </a:fillRef>
-          <a:effectRef idx="2">
-            <a:schemeClr val="accent1"/>
-          </a:effectRef>
-          <a:fontRef idx="minor">
-            <a:schemeClr val="lt1"/>
-          </a:fontRef>
-        </p:style>
-        <p:txBody>
-          <a:bodyPr rtlCol="0" anchor="ctr"/>
-          <a:lstStyle/>
-          <a:p>
-            <a:pPr algn="ctr"/>
-          </a:p>
-        </p:txBody>
-      </p:sp>
-      <p:sp>
-        <p:nvSpPr>
-          <p:cNvPr id="85" name="Diamond 84"/>
-          <p:cNvSpPr/>
-          <p:nvPr/>
-        </p:nvSpPr>
-        <p:spPr>
-          <a:xfrm>
-            <a:off x="4832604" y="5084717"/>
-            <a:ext cx="137160" cy="137160"/>
-          </a:xfrm>
-          <a:prstGeom prst="diamond">
-            <a:avLst/>
-          </a:prstGeom>
-          <a:solidFill>
-            <a:srgbClr val="0F1E3D"/>
-          </a:solidFill>
-          <a:ln>
-            <a:noFill/>
-          </a:ln>
-          <a:effectLst/>
-        </p:spPr>
-        <p:style>
-          <a:lnRef idx="1">
-            <a:schemeClr val="accent1"/>
-          </a:lnRef>
-          <a:fillRef idx="3">
-            <a:schemeClr val="accent1"/>
-          </a:fillRef>
-          <a:effectRef idx="2">
-            <a:schemeClr val="accent1"/>
-          </a:effectRef>
-          <a:fontRef idx="minor">
-            <a:schemeClr val="lt1"/>
-          </a:fontRef>
-        </p:style>
-        <p:txBody>
-          <a:bodyPr rtlCol="0" anchor="ctr"/>
-          <a:lstStyle/>
-          <a:p>
-            <a:pPr algn="ctr"/>
-          </a:p>
-        </p:txBody>
-      </p:sp>
       <p:cxnSp>
         <p:nvCxnSpPr>
-          <p:cNvPr id="86" name="Connector 85"/>
+          <p:cNvPr id="84" name="Connector 83"/>
           <p:cNvCxnSpPr/>
           <p:nvPr/>
         </p:nvCxnSpPr>
         <p:spPr>
           <a:xfrm>
-            <a:off x="1700784" y="5943600"/>
-            <a:ext cx="4160520" cy="0"/>
+            <a:off x="4771057" y="5158522"/>
+            <a:ext cx="284168" cy="0"/>
+          </a:xfrm>
+          <a:prstGeom prst="line">
+            <a:avLst/>
+          </a:prstGeom>
+          <a:ln w="35560">
+            <a:solidFill>
+              <a:srgbClr val="3A6FD0"/>
+            </a:solidFill>
+          </a:ln>
+          <a:effectLst/>
+        </p:spPr>
+        <p:style>
+          <a:lnRef idx="2">
+            <a:schemeClr val="accent1"/>
+          </a:lnRef>
+          <a:fillRef idx="0">
+            <a:schemeClr val="accent1"/>
+          </a:fillRef>
+          <a:effectRef idx="1">
+            <a:schemeClr val="accent1"/>
+          </a:effectRef>
+          <a:fontRef idx="minor">
+            <a:schemeClr val="tx1"/>
+          </a:fontRef>
+        </p:style>
+      </p:cxnSp>
+      <p:sp>
+        <p:nvSpPr>
+          <p:cNvPr id="85" name="Oval 84"/>
+          <p:cNvSpPr/>
+          <p:nvPr/>
+        </p:nvSpPr>
+        <p:spPr>
+          <a:xfrm>
+            <a:off x="3015761" y="4922084"/>
+            <a:ext cx="100584" cy="100584"/>
+          </a:xfrm>
+          <a:prstGeom prst="ellipse">
+            <a:avLst/>
+          </a:prstGeom>
+          <a:solidFill>
+            <a:srgbClr val="CC3328"/>
+          </a:solidFill>
+          <a:ln>
+            <a:noFill/>
+          </a:ln>
+          <a:effectLst/>
+        </p:spPr>
+        <p:style>
+          <a:lnRef idx="1">
+            <a:schemeClr val="accent1"/>
+          </a:lnRef>
+          <a:fillRef idx="3">
+            <a:schemeClr val="accent1"/>
+          </a:fillRef>
+          <a:effectRef idx="2">
+            <a:schemeClr val="accent1"/>
+          </a:effectRef>
+          <a:fontRef idx="minor">
+            <a:schemeClr val="lt1"/>
+          </a:fontRef>
+        </p:style>
+        <p:txBody>
+          <a:bodyPr rtlCol="0" anchor="ctr"/>
+          <a:lstStyle/>
+          <a:p>
+            <a:pPr algn="ctr"/>
+          </a:p>
+        </p:txBody>
+      </p:sp>
+      <p:sp>
+        <p:nvSpPr>
+          <p:cNvPr id="86" name="Diamond 85"/>
+          <p:cNvSpPr/>
+          <p:nvPr/>
+        </p:nvSpPr>
+        <p:spPr>
+          <a:xfrm>
+            <a:off x="4702477" y="5089942"/>
+            <a:ext cx="137160" cy="137160"/>
+          </a:xfrm>
+          <a:prstGeom prst="diamond">
+            <a:avLst/>
+          </a:prstGeom>
+          <a:solidFill>
+            <a:srgbClr val="0F1E3D"/>
+          </a:solidFill>
+          <a:ln>
+            <a:noFill/>
+          </a:ln>
+          <a:effectLst/>
+        </p:spPr>
+        <p:style>
+          <a:lnRef idx="1">
+            <a:schemeClr val="accent1"/>
+          </a:lnRef>
+          <a:fillRef idx="3">
+            <a:schemeClr val="accent1"/>
+          </a:fillRef>
+          <a:effectRef idx="2">
+            <a:schemeClr val="accent1"/>
+          </a:effectRef>
+          <a:fontRef idx="minor">
+            <a:schemeClr val="lt1"/>
+          </a:fontRef>
+        </p:style>
+        <p:txBody>
+          <a:bodyPr rtlCol="0" anchor="ctr"/>
+          <a:lstStyle/>
+          <a:p>
+            <a:pPr algn="ctr"/>
+          </a:p>
+        </p:txBody>
+      </p:sp>
+      <p:cxnSp>
+        <p:nvCxnSpPr>
+          <p:cNvPr id="87" name="Connector 86"/>
+          <p:cNvCxnSpPr/>
+          <p:nvPr/>
+        </p:nvCxnSpPr>
+        <p:spPr>
+          <a:xfrm>
+            <a:off x="1929384" y="5779008"/>
+            <a:ext cx="3694176" cy="0"/>
           </a:xfrm>
           <a:prstGeom prst="line">
             <a:avLst/>
@@ -33711,15 +33747,87 @@
           </a:fontRef>
         </p:style>
       </p:cxnSp>
-      <p:sp>
-        <p:nvSpPr>
-          <p:cNvPr id="87" name="TextBox 86"/>
+      <p:cxnSp>
+        <p:nvCxnSpPr>
+          <p:cNvPr id="88" name="Connector 87"/>
+          <p:cNvCxnSpPr/>
+          <p:nvPr/>
+        </p:nvCxnSpPr>
+        <p:spPr>
+          <a:xfrm>
+            <a:off x="1929384" y="4873752"/>
+            <a:ext cx="0" cy="905256"/>
+          </a:xfrm>
+          <a:prstGeom prst="line">
+            <a:avLst/>
+          </a:prstGeom>
+          <a:ln w="12700">
+            <a:solidFill>
+              <a:srgbClr val="C7CDD6"/>
+            </a:solidFill>
+          </a:ln>
+          <a:effectLst/>
+        </p:spPr>
+        <p:style>
+          <a:lnRef idx="2">
+            <a:schemeClr val="accent1"/>
+          </a:lnRef>
+          <a:fillRef idx="0">
+            <a:schemeClr val="accent1"/>
+          </a:fillRef>
+          <a:effectRef idx="1">
+            <a:schemeClr val="accent1"/>
+          </a:effectRef>
+          <a:fontRef idx="minor">
+            <a:schemeClr val="tx1"/>
+          </a:fontRef>
+        </p:style>
+      </p:cxnSp>
+      <p:sp>
+        <p:nvSpPr>
+          <p:cNvPr id="89" name="TextBox 88"/>
           <p:cNvSpPr txBox="1"/>
           <p:nvPr/>
         </p:nvSpPr>
         <p:spPr>
           <a:xfrm>
-            <a:off x="1609344" y="6012180"/>
+            <a:off x="1700784" y="5797296"/>
+            <a:ext cx="4151376" cy="155448"/>
+          </a:xfrm>
+          <a:prstGeom prst="rect">
+            <a:avLst/>
+          </a:prstGeom>
+          <a:noFill/>
+        </p:spPr>
+        <p:txBody>
+          <a:bodyPr wrap="none" anchor="ctr" lIns="0" rIns="0" tIns="0" bIns="0">
+            <a:spAutoFit/>
+          </a:bodyPr>
+          <a:lstStyle/>
+          <a:p>
+            <a:pPr algn="ctr"/>
+            <a:r>
+              <a:rPr sz="1100">
+                <a:solidFill>
+                  <a:srgbClr val="6B7280"/>
+                </a:solidFill>
+                <a:latin typeface="맑은 고딕"/>
+                <a:ea typeface="맑은 고딕"/>
+              </a:rPr>
+              <a:t>epoch</a:t>
+            </a:r>
+          </a:p>
+        </p:txBody>
+      </p:sp>
+      <p:sp>
+        <p:nvSpPr>
+          <p:cNvPr id="90" name="TextBox 89"/>
+          <p:cNvSpPr txBox="1"/>
+          <p:nvPr/>
+        </p:nvSpPr>
+        <p:spPr>
+          <a:xfrm>
+            <a:off x="1609344" y="6030468"/>
             <a:ext cx="4288536" cy="173736"/>
           </a:xfrm>
           <a:prstGeom prst="rect">
@@ -33759,7 +33867,7 @@
       </p:sp>
       <p:sp>
         <p:nvSpPr>
-          <p:cNvPr id="88" name="TextBox 87"/>
+          <p:cNvPr id="91" name="TextBox 90"/>
           <p:cNvSpPr txBox="1"/>
           <p:nvPr/>
         </p:nvSpPr>
@@ -33795,7 +33903,7 @@
       </p:sp>
       <p:sp>
         <p:nvSpPr>
-          <p:cNvPr id="89" name="TextBox 88"/>
+          <p:cNvPr id="92" name="TextBox 91"/>
           <p:cNvSpPr txBox="1"/>
           <p:nvPr/>
         </p:nvSpPr>
@@ -33831,7 +33939,7 @@
       </p:sp>
       <p:pic>
         <p:nvPicPr>
-          <p:cNvPr id="90" name="Picture 89" descr="p3r_color_baseline.png"/>
+          <p:cNvPr id="93" name="Picture 92" descr="p3r_color_baseline.png"/>
           <p:cNvPicPr>
             <a:picLocks noChangeAspect="1"/>
           </p:cNvPicPr>
@@ -33855,7 +33963,7 @@
       </p:pic>
       <p:sp>
         <p:nvSpPr>
-          <p:cNvPr id="91" name="TextBox 90"/>
+          <p:cNvPr id="94" name="TextBox 93"/>
           <p:cNvSpPr txBox="1"/>
           <p:nvPr/>
         </p:nvSpPr>
@@ -33891,7 +33999,7 @@
       </p:sp>
       <p:pic>
         <p:nvPicPr>
-          <p:cNvPr id="92" name="Picture 91" descr="p3r_color_c01.png"/>
+          <p:cNvPr id="95" name="Picture 94" descr="p3r_color_c01.png"/>
           <p:cNvPicPr>
             <a:picLocks noChangeAspect="1"/>
           </p:cNvPicPr>
@@ -33915,7 +34023,7 @@
       </p:pic>
       <p:sp>
         <p:nvSpPr>
-          <p:cNvPr id="93" name="TextBox 92"/>
+          <p:cNvPr id="96" name="TextBox 95"/>
           <p:cNvSpPr txBox="1"/>
           <p:nvPr/>
         </p:nvSpPr>
@@ -33951,7 +34059,7 @@
       </p:sp>
       <p:sp>
         <p:nvSpPr>
-          <p:cNvPr id="94" name="TextBox 93"/>
+          <p:cNvPr id="97" name="TextBox 96"/>
           <p:cNvSpPr txBox="1"/>
           <p:nvPr/>
         </p:nvSpPr>
@@ -33987,7 +34095,7 @@
       </p:sp>
       <p:sp>
         <p:nvSpPr>
-          <p:cNvPr id="95" name="TextBox 94"/>
+          <p:cNvPr id="98" name="TextBox 97"/>
           <p:cNvSpPr txBox="1"/>
           <p:nvPr/>
         </p:nvSpPr>

</xml_diff>

<commit_message>
P3 slide4 Q3 — x축 보조선(gridline) + epoch 눈금 숫자 추가
사용자: x축에 보조선/눈금(1,2,3..) 표시. 매 2 epoch 마다 light 세로 gridline + 눈금 tick + epoch 숫자(1,3,5,7,9,11,13) + 'epoch' 축 라벨. y축 'val F1' 유지.

Co-Authored-By: Claude Opus 4.8 (1M context) <noreply@anthropic.com>
</commit_message>
<xml_diff>
--- a/recommendation/presentation/발표_P3_데이터생성_최호길.pptx
+++ b/recommendation/presentation/발표_P3_데이터생성_최호길.pptx
@@ -32766,16 +32766,16 @@
           <p:nvPr/>
         </p:nvCxnSpPr>
         <p:spPr>
-          <a:xfrm flipV="1">
-            <a:off x="1929384" y="5489447"/>
-            <a:ext cx="284167" cy="124098"/>
+          <a:xfrm>
+            <a:off x="1929384" y="4892040"/>
+            <a:ext cx="0" cy="868680"/>
           </a:xfrm>
           <a:prstGeom prst="line">
             <a:avLst/>
           </a:prstGeom>
-          <a:ln w="19050">
+          <a:ln w="10160">
             <a:solidFill>
-              <a:srgbClr val="AEB4BD"/>
+              <a:srgbClr val="ECEFF4"/>
             </a:solidFill>
           </a:ln>
           <a:effectLst/>
@@ -32802,16 +32802,16 @@
           <p:nvPr/>
         </p:nvCxnSpPr>
         <p:spPr>
-          <a:xfrm flipV="1">
-            <a:off x="2213551" y="5406716"/>
-            <a:ext cx="284167" cy="82731"/>
+          <a:xfrm>
+            <a:off x="2497718" y="4892040"/>
+            <a:ext cx="0" cy="868680"/>
           </a:xfrm>
           <a:prstGeom prst="line">
             <a:avLst/>
           </a:prstGeom>
-          <a:ln w="19050">
+          <a:ln w="10160">
             <a:solidFill>
-              <a:srgbClr val="AEB4BD"/>
+              <a:srgbClr val="ECEFF4"/>
             </a:solidFill>
           </a:ln>
           <a:effectLst/>
@@ -32838,16 +32838,16 @@
           <p:nvPr/>
         </p:nvCxnSpPr>
         <p:spPr>
-          <a:xfrm flipV="1">
-            <a:off x="2497718" y="5344668"/>
-            <a:ext cx="284168" cy="62048"/>
+          <a:xfrm>
+            <a:off x="3066053" y="4892040"/>
+            <a:ext cx="0" cy="868680"/>
           </a:xfrm>
           <a:prstGeom prst="line">
             <a:avLst/>
           </a:prstGeom>
-          <a:ln w="19050">
+          <a:ln w="10160">
             <a:solidFill>
-              <a:srgbClr val="AEB4BD"/>
+              <a:srgbClr val="ECEFF4"/>
             </a:solidFill>
           </a:ln>
           <a:effectLst/>
@@ -32874,16 +32874,16 @@
           <p:nvPr/>
         </p:nvCxnSpPr>
         <p:spPr>
-          <a:xfrm flipV="1">
-            <a:off x="2781886" y="4972376"/>
-            <a:ext cx="284167" cy="372292"/>
+          <a:xfrm>
+            <a:off x="3634388" y="4892040"/>
+            <a:ext cx="0" cy="868680"/>
           </a:xfrm>
           <a:prstGeom prst="line">
             <a:avLst/>
           </a:prstGeom>
-          <a:ln w="19050">
+          <a:ln w="10160">
             <a:solidFill>
-              <a:srgbClr val="AEB4BD"/>
+              <a:srgbClr val="ECEFF4"/>
             </a:solidFill>
           </a:ln>
           <a:effectLst/>
@@ -32911,15 +32911,15 @@
         </p:nvCxnSpPr>
         <p:spPr>
           <a:xfrm>
-            <a:off x="3066053" y="4972376"/>
-            <a:ext cx="284167" cy="496389"/>
+            <a:off x="4202723" y="4892040"/>
+            <a:ext cx="0" cy="868680"/>
           </a:xfrm>
           <a:prstGeom prst="line">
             <a:avLst/>
           </a:prstGeom>
-          <a:ln w="19050">
+          <a:ln w="10160">
             <a:solidFill>
-              <a:srgbClr val="AEB4BD"/>
+              <a:srgbClr val="ECEFF4"/>
             </a:solidFill>
           </a:ln>
           <a:effectLst/>
@@ -32946,16 +32946,16 @@
           <p:nvPr/>
         </p:nvCxnSpPr>
         <p:spPr>
-          <a:xfrm flipV="1">
-            <a:off x="3350220" y="5323985"/>
-            <a:ext cx="284168" cy="144780"/>
+          <a:xfrm>
+            <a:off x="4771057" y="4892040"/>
+            <a:ext cx="0" cy="868680"/>
           </a:xfrm>
           <a:prstGeom prst="line">
             <a:avLst/>
           </a:prstGeom>
-          <a:ln w="19050">
+          <a:ln w="10160">
             <a:solidFill>
-              <a:srgbClr val="AEB4BD"/>
+              <a:srgbClr val="ECEFF4"/>
             </a:solidFill>
           </a:ln>
           <a:effectLst/>
@@ -32982,16 +32982,16 @@
           <p:nvPr/>
         </p:nvCxnSpPr>
         <p:spPr>
-          <a:xfrm flipV="1">
-            <a:off x="3634388" y="5261936"/>
-            <a:ext cx="284167" cy="62049"/>
+          <a:xfrm>
+            <a:off x="5339392" y="4892040"/>
+            <a:ext cx="0" cy="868680"/>
           </a:xfrm>
           <a:prstGeom prst="line">
             <a:avLst/>
           </a:prstGeom>
-          <a:ln w="19050">
+          <a:ln w="10160">
             <a:solidFill>
-              <a:srgbClr val="AEB4BD"/>
+              <a:srgbClr val="ECEFF4"/>
             </a:solidFill>
           </a:ln>
           <a:effectLst/>
@@ -33019,8 +33019,8 @@
         </p:nvCxnSpPr>
         <p:spPr>
           <a:xfrm flipV="1">
-            <a:off x="3918555" y="5220570"/>
-            <a:ext cx="284168" cy="41366"/>
+            <a:off x="1929384" y="5471159"/>
+            <a:ext cx="284167" cy="124098"/>
           </a:xfrm>
           <a:prstGeom prst="line">
             <a:avLst/>
@@ -33055,8 +33055,8 @@
         </p:nvCxnSpPr>
         <p:spPr>
           <a:xfrm flipV="1">
-            <a:off x="4202723" y="5179205"/>
-            <a:ext cx="284167" cy="41365"/>
+            <a:off x="2213551" y="5388428"/>
+            <a:ext cx="284167" cy="82731"/>
           </a:xfrm>
           <a:prstGeom prst="line">
             <a:avLst/>
@@ -33091,8 +33091,8 @@
         </p:nvCxnSpPr>
         <p:spPr>
           <a:xfrm flipV="1">
-            <a:off x="4486890" y="5168863"/>
-            <a:ext cx="284167" cy="10342"/>
+            <a:off x="2497718" y="5326380"/>
+            <a:ext cx="284168" cy="62048"/>
           </a:xfrm>
           <a:prstGeom prst="line">
             <a:avLst/>
@@ -33127,8 +33127,8 @@
         </p:nvCxnSpPr>
         <p:spPr>
           <a:xfrm flipV="1">
-            <a:off x="4771057" y="5158522"/>
-            <a:ext cx="284168" cy="10341"/>
+            <a:off x="2781886" y="4954088"/>
+            <a:ext cx="284167" cy="372292"/>
           </a:xfrm>
           <a:prstGeom prst="line">
             <a:avLst/>
@@ -33162,9 +33162,9 @@
           <p:nvPr/>
         </p:nvCxnSpPr>
         <p:spPr>
-          <a:xfrm flipV="1">
-            <a:off x="5055225" y="5148180"/>
-            <a:ext cx="284167" cy="10342"/>
+          <a:xfrm>
+            <a:off x="3066053" y="4954088"/>
+            <a:ext cx="284167" cy="496389"/>
           </a:xfrm>
           <a:prstGeom prst="line">
             <a:avLst/>
@@ -33198,9 +33198,9 @@
           <p:nvPr/>
         </p:nvCxnSpPr>
         <p:spPr>
-          <a:xfrm>
-            <a:off x="5339392" y="5148180"/>
-            <a:ext cx="284168" cy="10342"/>
+          <a:xfrm flipV="1">
+            <a:off x="3350220" y="5305697"/>
+            <a:ext cx="284168" cy="144780"/>
           </a:xfrm>
           <a:prstGeom prst="line">
             <a:avLst/>
@@ -33235,15 +33235,15 @@
         </p:nvCxnSpPr>
         <p:spPr>
           <a:xfrm flipV="1">
-            <a:off x="1929384" y="5406716"/>
-            <a:ext cx="284167" cy="82731"/>
+            <a:off x="3634388" y="5243648"/>
+            <a:ext cx="284167" cy="62049"/>
           </a:xfrm>
           <a:prstGeom prst="line">
             <a:avLst/>
           </a:prstGeom>
-          <a:ln w="35560">
+          <a:ln w="19050">
             <a:solidFill>
-              <a:srgbClr val="3A6FD0"/>
+              <a:srgbClr val="AEB4BD"/>
             </a:solidFill>
           </a:ln>
           <a:effectLst/>
@@ -33271,15 +33271,15 @@
         </p:nvCxnSpPr>
         <p:spPr>
           <a:xfrm flipV="1">
-            <a:off x="2213551" y="5344668"/>
-            <a:ext cx="284167" cy="62048"/>
+            <a:off x="3918555" y="5202282"/>
+            <a:ext cx="284168" cy="41366"/>
           </a:xfrm>
           <a:prstGeom prst="line">
             <a:avLst/>
           </a:prstGeom>
-          <a:ln w="35560">
+          <a:ln w="19050">
             <a:solidFill>
-              <a:srgbClr val="3A6FD0"/>
+              <a:srgbClr val="AEB4BD"/>
             </a:solidFill>
           </a:ln>
           <a:effectLst/>
@@ -33306,16 +33306,16 @@
           <p:nvPr/>
         </p:nvCxnSpPr>
         <p:spPr>
-          <a:xfrm>
-            <a:off x="2497718" y="5344668"/>
-            <a:ext cx="284168" cy="0"/>
+          <a:xfrm flipV="1">
+            <a:off x="4202723" y="5160917"/>
+            <a:ext cx="284167" cy="41365"/>
           </a:xfrm>
           <a:prstGeom prst="line">
             <a:avLst/>
           </a:prstGeom>
-          <a:ln w="35560">
+          <a:ln w="19050">
             <a:solidFill>
-              <a:srgbClr val="3A6FD0"/>
+              <a:srgbClr val="AEB4BD"/>
             </a:solidFill>
           </a:ln>
           <a:effectLst/>
@@ -33343,15 +33343,15 @@
         </p:nvCxnSpPr>
         <p:spPr>
           <a:xfrm flipV="1">
-            <a:off x="2781886" y="5323985"/>
-            <a:ext cx="284167" cy="20683"/>
+            <a:off x="4486890" y="5150575"/>
+            <a:ext cx="284167" cy="10342"/>
           </a:xfrm>
           <a:prstGeom prst="line">
             <a:avLst/>
           </a:prstGeom>
-          <a:ln w="35560">
+          <a:ln w="19050">
             <a:solidFill>
-              <a:srgbClr val="3A6FD0"/>
+              <a:srgbClr val="AEB4BD"/>
             </a:solidFill>
           </a:ln>
           <a:effectLst/>
@@ -33378,16 +33378,16 @@
           <p:nvPr/>
         </p:nvCxnSpPr>
         <p:spPr>
-          <a:xfrm>
-            <a:off x="3066053" y="5323985"/>
-            <a:ext cx="284167" cy="0"/>
+          <a:xfrm flipV="1">
+            <a:off x="4771057" y="5140234"/>
+            <a:ext cx="284168" cy="10341"/>
           </a:xfrm>
           <a:prstGeom prst="line">
             <a:avLst/>
           </a:prstGeom>
-          <a:ln w="35560">
+          <a:ln w="19050">
             <a:solidFill>
-              <a:srgbClr val="3A6FD0"/>
+              <a:srgbClr val="AEB4BD"/>
             </a:solidFill>
           </a:ln>
           <a:effectLst/>
@@ -33415,15 +33415,15 @@
         </p:nvCxnSpPr>
         <p:spPr>
           <a:xfrm flipV="1">
-            <a:off x="3350220" y="5261936"/>
-            <a:ext cx="284168" cy="62049"/>
+            <a:off x="5055225" y="5129892"/>
+            <a:ext cx="284167" cy="10342"/>
           </a:xfrm>
           <a:prstGeom prst="line">
             <a:avLst/>
           </a:prstGeom>
-          <a:ln w="35560">
+          <a:ln w="19050">
             <a:solidFill>
-              <a:srgbClr val="3A6FD0"/>
+              <a:srgbClr val="AEB4BD"/>
             </a:solidFill>
           </a:ln>
           <a:effectLst/>
@@ -33450,16 +33450,16 @@
           <p:nvPr/>
         </p:nvCxnSpPr>
         <p:spPr>
-          <a:xfrm flipV="1">
-            <a:off x="3634388" y="5220570"/>
-            <a:ext cx="284167" cy="41366"/>
+          <a:xfrm>
+            <a:off x="5339392" y="5129892"/>
+            <a:ext cx="284168" cy="10342"/>
           </a:xfrm>
           <a:prstGeom prst="line">
             <a:avLst/>
           </a:prstGeom>
-          <a:ln w="35560">
+          <a:ln w="19050">
             <a:solidFill>
-              <a:srgbClr val="3A6FD0"/>
+              <a:srgbClr val="AEB4BD"/>
             </a:solidFill>
           </a:ln>
           <a:effectLst/>
@@ -33487,8 +33487,8 @@
         </p:nvCxnSpPr>
         <p:spPr>
           <a:xfrm flipV="1">
-            <a:off x="3918555" y="5179205"/>
-            <a:ext cx="284168" cy="41365"/>
+            <a:off x="1929384" y="5388428"/>
+            <a:ext cx="284167" cy="82731"/>
           </a:xfrm>
           <a:prstGeom prst="line">
             <a:avLst/>
@@ -33523,8 +33523,8 @@
         </p:nvCxnSpPr>
         <p:spPr>
           <a:xfrm flipV="1">
-            <a:off x="4202723" y="5168863"/>
-            <a:ext cx="284167" cy="10342"/>
+            <a:off x="2213551" y="5326380"/>
+            <a:ext cx="284167" cy="62048"/>
           </a:xfrm>
           <a:prstGeom prst="line">
             <a:avLst/>
@@ -33558,9 +33558,9 @@
           <p:nvPr/>
         </p:nvCxnSpPr>
         <p:spPr>
-          <a:xfrm flipV="1">
-            <a:off x="4486890" y="5158522"/>
-            <a:ext cx="284167" cy="10341"/>
+          <a:xfrm>
+            <a:off x="2497718" y="5326380"/>
+            <a:ext cx="284168" cy="0"/>
           </a:xfrm>
           <a:prstGeom prst="line">
             <a:avLst/>
@@ -33594,9 +33594,9 @@
           <p:nvPr/>
         </p:nvCxnSpPr>
         <p:spPr>
-          <a:xfrm>
-            <a:off x="4771057" y="5158522"/>
-            <a:ext cx="284168" cy="0"/>
+          <a:xfrm flipV="1">
+            <a:off x="2781886" y="5305697"/>
+            <a:ext cx="284167" cy="20683"/>
           </a:xfrm>
           <a:prstGeom prst="line">
             <a:avLst/>
@@ -33623,94 +33623,78 @@
           </a:fontRef>
         </p:style>
       </p:cxnSp>
-      <p:sp>
-        <p:nvSpPr>
-          <p:cNvPr id="85" name="Oval 84"/>
-          <p:cNvSpPr/>
-          <p:nvPr/>
-        </p:nvSpPr>
-        <p:spPr>
-          <a:xfrm>
-            <a:off x="3015761" y="4922084"/>
-            <a:ext cx="100584" cy="100584"/>
-          </a:xfrm>
-          <a:prstGeom prst="ellipse">
-            <a:avLst/>
-          </a:prstGeom>
-          <a:solidFill>
-            <a:srgbClr val="CC3328"/>
-          </a:solidFill>
-          <a:ln>
-            <a:noFill/>
-          </a:ln>
-          <a:effectLst/>
-        </p:spPr>
-        <p:style>
-          <a:lnRef idx="1">
-            <a:schemeClr val="accent1"/>
-          </a:lnRef>
-          <a:fillRef idx="3">
-            <a:schemeClr val="accent1"/>
-          </a:fillRef>
-          <a:effectRef idx="2">
-            <a:schemeClr val="accent1"/>
-          </a:effectRef>
-          <a:fontRef idx="minor">
-            <a:schemeClr val="lt1"/>
-          </a:fontRef>
-        </p:style>
-        <p:txBody>
-          <a:bodyPr rtlCol="0" anchor="ctr"/>
-          <a:lstStyle/>
-          <a:p>
-            <a:pPr algn="ctr"/>
-          </a:p>
-        </p:txBody>
-      </p:sp>
-      <p:sp>
-        <p:nvSpPr>
-          <p:cNvPr id="86" name="Diamond 85"/>
-          <p:cNvSpPr/>
-          <p:nvPr/>
-        </p:nvSpPr>
-        <p:spPr>
-          <a:xfrm>
-            <a:off x="4702477" y="5089942"/>
-            <a:ext cx="137160" cy="137160"/>
-          </a:xfrm>
-          <a:prstGeom prst="diamond">
-            <a:avLst/>
-          </a:prstGeom>
-          <a:solidFill>
-            <a:srgbClr val="0F1E3D"/>
-          </a:solidFill>
-          <a:ln>
-            <a:noFill/>
-          </a:ln>
-          <a:effectLst/>
-        </p:spPr>
-        <p:style>
-          <a:lnRef idx="1">
-            <a:schemeClr val="accent1"/>
-          </a:lnRef>
-          <a:fillRef idx="3">
-            <a:schemeClr val="accent1"/>
-          </a:fillRef>
-          <a:effectRef idx="2">
-            <a:schemeClr val="accent1"/>
-          </a:effectRef>
-          <a:fontRef idx="minor">
-            <a:schemeClr val="lt1"/>
-          </a:fontRef>
-        </p:style>
-        <p:txBody>
-          <a:bodyPr rtlCol="0" anchor="ctr"/>
-          <a:lstStyle/>
-          <a:p>
-            <a:pPr algn="ctr"/>
-          </a:p>
-        </p:txBody>
-      </p:sp>
+      <p:cxnSp>
+        <p:nvCxnSpPr>
+          <p:cNvPr id="85" name="Connector 84"/>
+          <p:cNvCxnSpPr/>
+          <p:nvPr/>
+        </p:nvCxnSpPr>
+        <p:spPr>
+          <a:xfrm>
+            <a:off x="3066053" y="5305697"/>
+            <a:ext cx="284167" cy="0"/>
+          </a:xfrm>
+          <a:prstGeom prst="line">
+            <a:avLst/>
+          </a:prstGeom>
+          <a:ln w="35560">
+            <a:solidFill>
+              <a:srgbClr val="3A6FD0"/>
+            </a:solidFill>
+          </a:ln>
+          <a:effectLst/>
+        </p:spPr>
+        <p:style>
+          <a:lnRef idx="2">
+            <a:schemeClr val="accent1"/>
+          </a:lnRef>
+          <a:fillRef idx="0">
+            <a:schemeClr val="accent1"/>
+          </a:fillRef>
+          <a:effectRef idx="1">
+            <a:schemeClr val="accent1"/>
+          </a:effectRef>
+          <a:fontRef idx="minor">
+            <a:schemeClr val="tx1"/>
+          </a:fontRef>
+        </p:style>
+      </p:cxnSp>
+      <p:cxnSp>
+        <p:nvCxnSpPr>
+          <p:cNvPr id="86" name="Connector 85"/>
+          <p:cNvCxnSpPr/>
+          <p:nvPr/>
+        </p:nvCxnSpPr>
+        <p:spPr>
+          <a:xfrm flipV="1">
+            <a:off x="3350220" y="5243648"/>
+            <a:ext cx="284168" cy="62049"/>
+          </a:xfrm>
+          <a:prstGeom prst="line">
+            <a:avLst/>
+          </a:prstGeom>
+          <a:ln w="35560">
+            <a:solidFill>
+              <a:srgbClr val="3A6FD0"/>
+            </a:solidFill>
+          </a:ln>
+          <a:effectLst/>
+        </p:spPr>
+        <p:style>
+          <a:lnRef idx="2">
+            <a:schemeClr val="accent1"/>
+          </a:lnRef>
+          <a:fillRef idx="0">
+            <a:schemeClr val="accent1"/>
+          </a:fillRef>
+          <a:effectRef idx="1">
+            <a:schemeClr val="accent1"/>
+          </a:effectRef>
+          <a:fontRef idx="minor">
+            <a:schemeClr val="tx1"/>
+          </a:fontRef>
+        </p:style>
+      </p:cxnSp>
       <p:cxnSp>
         <p:nvCxnSpPr>
           <p:cNvPr id="87" name="Connector 86"/>
@@ -33718,16 +33702,16 @@
           <p:nvPr/>
         </p:nvCxnSpPr>
         <p:spPr>
-          <a:xfrm>
-            <a:off x="1929384" y="5779008"/>
-            <a:ext cx="3694176" cy="0"/>
+          <a:xfrm flipV="1">
+            <a:off x="3634388" y="5202282"/>
+            <a:ext cx="284167" cy="41366"/>
           </a:xfrm>
           <a:prstGeom prst="line">
             <a:avLst/>
           </a:prstGeom>
-          <a:ln w="12700">
+          <a:ln w="35560">
             <a:solidFill>
-              <a:srgbClr val="C7CDD6"/>
+              <a:srgbClr val="3A6FD0"/>
             </a:solidFill>
           </a:ln>
           <a:effectLst/>
@@ -33754,9 +33738,241 @@
           <p:nvPr/>
         </p:nvCxnSpPr>
         <p:spPr>
-          <a:xfrm>
-            <a:off x="1929384" y="4873752"/>
-            <a:ext cx="0" cy="905256"/>
+          <a:xfrm flipV="1">
+            <a:off x="3918555" y="5160917"/>
+            <a:ext cx="284168" cy="41365"/>
+          </a:xfrm>
+          <a:prstGeom prst="line">
+            <a:avLst/>
+          </a:prstGeom>
+          <a:ln w="35560">
+            <a:solidFill>
+              <a:srgbClr val="3A6FD0"/>
+            </a:solidFill>
+          </a:ln>
+          <a:effectLst/>
+        </p:spPr>
+        <p:style>
+          <a:lnRef idx="2">
+            <a:schemeClr val="accent1"/>
+          </a:lnRef>
+          <a:fillRef idx="0">
+            <a:schemeClr val="accent1"/>
+          </a:fillRef>
+          <a:effectRef idx="1">
+            <a:schemeClr val="accent1"/>
+          </a:effectRef>
+          <a:fontRef idx="minor">
+            <a:schemeClr val="tx1"/>
+          </a:fontRef>
+        </p:style>
+      </p:cxnSp>
+      <p:cxnSp>
+        <p:nvCxnSpPr>
+          <p:cNvPr id="89" name="Connector 88"/>
+          <p:cNvCxnSpPr/>
+          <p:nvPr/>
+        </p:nvCxnSpPr>
+        <p:spPr>
+          <a:xfrm flipV="1">
+            <a:off x="4202723" y="5150575"/>
+            <a:ext cx="284167" cy="10342"/>
+          </a:xfrm>
+          <a:prstGeom prst="line">
+            <a:avLst/>
+          </a:prstGeom>
+          <a:ln w="35560">
+            <a:solidFill>
+              <a:srgbClr val="3A6FD0"/>
+            </a:solidFill>
+          </a:ln>
+          <a:effectLst/>
+        </p:spPr>
+        <p:style>
+          <a:lnRef idx="2">
+            <a:schemeClr val="accent1"/>
+          </a:lnRef>
+          <a:fillRef idx="0">
+            <a:schemeClr val="accent1"/>
+          </a:fillRef>
+          <a:effectRef idx="1">
+            <a:schemeClr val="accent1"/>
+          </a:effectRef>
+          <a:fontRef idx="minor">
+            <a:schemeClr val="tx1"/>
+          </a:fontRef>
+        </p:style>
+      </p:cxnSp>
+      <p:cxnSp>
+        <p:nvCxnSpPr>
+          <p:cNvPr id="90" name="Connector 89"/>
+          <p:cNvCxnSpPr/>
+          <p:nvPr/>
+        </p:nvCxnSpPr>
+        <p:spPr>
+          <a:xfrm flipV="1">
+            <a:off x="4486890" y="5140234"/>
+            <a:ext cx="284167" cy="10341"/>
+          </a:xfrm>
+          <a:prstGeom prst="line">
+            <a:avLst/>
+          </a:prstGeom>
+          <a:ln w="35560">
+            <a:solidFill>
+              <a:srgbClr val="3A6FD0"/>
+            </a:solidFill>
+          </a:ln>
+          <a:effectLst/>
+        </p:spPr>
+        <p:style>
+          <a:lnRef idx="2">
+            <a:schemeClr val="accent1"/>
+          </a:lnRef>
+          <a:fillRef idx="0">
+            <a:schemeClr val="accent1"/>
+          </a:fillRef>
+          <a:effectRef idx="1">
+            <a:schemeClr val="accent1"/>
+          </a:effectRef>
+          <a:fontRef idx="minor">
+            <a:schemeClr val="tx1"/>
+          </a:fontRef>
+        </p:style>
+      </p:cxnSp>
+      <p:cxnSp>
+        <p:nvCxnSpPr>
+          <p:cNvPr id="91" name="Connector 90"/>
+          <p:cNvCxnSpPr/>
+          <p:nvPr/>
+        </p:nvCxnSpPr>
+        <p:spPr>
+          <a:xfrm>
+            <a:off x="4771057" y="5140234"/>
+            <a:ext cx="284168" cy="0"/>
+          </a:xfrm>
+          <a:prstGeom prst="line">
+            <a:avLst/>
+          </a:prstGeom>
+          <a:ln w="35560">
+            <a:solidFill>
+              <a:srgbClr val="3A6FD0"/>
+            </a:solidFill>
+          </a:ln>
+          <a:effectLst/>
+        </p:spPr>
+        <p:style>
+          <a:lnRef idx="2">
+            <a:schemeClr val="accent1"/>
+          </a:lnRef>
+          <a:fillRef idx="0">
+            <a:schemeClr val="accent1"/>
+          </a:fillRef>
+          <a:effectRef idx="1">
+            <a:schemeClr val="accent1"/>
+          </a:effectRef>
+          <a:fontRef idx="minor">
+            <a:schemeClr val="tx1"/>
+          </a:fontRef>
+        </p:style>
+      </p:cxnSp>
+      <p:sp>
+        <p:nvSpPr>
+          <p:cNvPr id="92" name="Oval 91"/>
+          <p:cNvSpPr/>
+          <p:nvPr/>
+        </p:nvSpPr>
+        <p:spPr>
+          <a:xfrm>
+            <a:off x="3015761" y="4903796"/>
+            <a:ext cx="100584" cy="100584"/>
+          </a:xfrm>
+          <a:prstGeom prst="ellipse">
+            <a:avLst/>
+          </a:prstGeom>
+          <a:solidFill>
+            <a:srgbClr val="CC3328"/>
+          </a:solidFill>
+          <a:ln>
+            <a:noFill/>
+          </a:ln>
+          <a:effectLst/>
+        </p:spPr>
+        <p:style>
+          <a:lnRef idx="1">
+            <a:schemeClr val="accent1"/>
+          </a:lnRef>
+          <a:fillRef idx="3">
+            <a:schemeClr val="accent1"/>
+          </a:fillRef>
+          <a:effectRef idx="2">
+            <a:schemeClr val="accent1"/>
+          </a:effectRef>
+          <a:fontRef idx="minor">
+            <a:schemeClr val="lt1"/>
+          </a:fontRef>
+        </p:style>
+        <p:txBody>
+          <a:bodyPr rtlCol="0" anchor="ctr"/>
+          <a:lstStyle/>
+          <a:p>
+            <a:pPr algn="ctr"/>
+          </a:p>
+        </p:txBody>
+      </p:sp>
+      <p:sp>
+        <p:nvSpPr>
+          <p:cNvPr id="93" name="Diamond 92"/>
+          <p:cNvSpPr/>
+          <p:nvPr/>
+        </p:nvSpPr>
+        <p:spPr>
+          <a:xfrm>
+            <a:off x="4702477" y="5071654"/>
+            <a:ext cx="137160" cy="137160"/>
+          </a:xfrm>
+          <a:prstGeom prst="diamond">
+            <a:avLst/>
+          </a:prstGeom>
+          <a:solidFill>
+            <a:srgbClr val="0F1E3D"/>
+          </a:solidFill>
+          <a:ln>
+            <a:noFill/>
+          </a:ln>
+          <a:effectLst/>
+        </p:spPr>
+        <p:style>
+          <a:lnRef idx="1">
+            <a:schemeClr val="accent1"/>
+          </a:lnRef>
+          <a:fillRef idx="3">
+            <a:schemeClr val="accent1"/>
+          </a:fillRef>
+          <a:effectRef idx="2">
+            <a:schemeClr val="accent1"/>
+          </a:effectRef>
+          <a:fontRef idx="minor">
+            <a:schemeClr val="lt1"/>
+          </a:fontRef>
+        </p:style>
+        <p:txBody>
+          <a:bodyPr rtlCol="0" anchor="ctr"/>
+          <a:lstStyle/>
+          <a:p>
+            <a:pPr algn="ctr"/>
+          </a:p>
+        </p:txBody>
+      </p:sp>
+      <p:cxnSp>
+        <p:nvCxnSpPr>
+          <p:cNvPr id="94" name="Connector 93"/>
+          <p:cNvCxnSpPr/>
+          <p:nvPr/>
+        </p:nvCxnSpPr>
+        <p:spPr>
+          <a:xfrm>
+            <a:off x="1929384" y="5760720"/>
+            <a:ext cx="3694176" cy="0"/>
           </a:xfrm>
           <a:prstGeom prst="line">
             <a:avLst/>
@@ -33783,16 +33999,88 @@
           </a:fontRef>
         </p:style>
       </p:cxnSp>
-      <p:sp>
-        <p:nvSpPr>
-          <p:cNvPr id="89" name="TextBox 88"/>
+      <p:cxnSp>
+        <p:nvCxnSpPr>
+          <p:cNvPr id="95" name="Connector 94"/>
+          <p:cNvCxnSpPr/>
+          <p:nvPr/>
+        </p:nvCxnSpPr>
+        <p:spPr>
+          <a:xfrm>
+            <a:off x="1929384" y="4855464"/>
+            <a:ext cx="0" cy="905256"/>
+          </a:xfrm>
+          <a:prstGeom prst="line">
+            <a:avLst/>
+          </a:prstGeom>
+          <a:ln w="12700">
+            <a:solidFill>
+              <a:srgbClr val="C7CDD6"/>
+            </a:solidFill>
+          </a:ln>
+          <a:effectLst/>
+        </p:spPr>
+        <p:style>
+          <a:lnRef idx="2">
+            <a:schemeClr val="accent1"/>
+          </a:lnRef>
+          <a:fillRef idx="0">
+            <a:schemeClr val="accent1"/>
+          </a:fillRef>
+          <a:effectRef idx="1">
+            <a:schemeClr val="accent1"/>
+          </a:effectRef>
+          <a:fontRef idx="minor">
+            <a:schemeClr val="tx1"/>
+          </a:fontRef>
+        </p:style>
+      </p:cxnSp>
+      <p:cxnSp>
+        <p:nvCxnSpPr>
+          <p:cNvPr id="96" name="Connector 95"/>
+          <p:cNvCxnSpPr/>
+          <p:nvPr/>
+        </p:nvCxnSpPr>
+        <p:spPr>
+          <a:xfrm>
+            <a:off x="1929384" y="5760720"/>
+            <a:ext cx="0" cy="36576"/>
+          </a:xfrm>
+          <a:prstGeom prst="line">
+            <a:avLst/>
+          </a:prstGeom>
+          <a:ln w="12700">
+            <a:solidFill>
+              <a:srgbClr val="C7CDD6"/>
+            </a:solidFill>
+          </a:ln>
+          <a:effectLst/>
+        </p:spPr>
+        <p:style>
+          <a:lnRef idx="2">
+            <a:schemeClr val="accent1"/>
+          </a:lnRef>
+          <a:fillRef idx="0">
+            <a:schemeClr val="accent1"/>
+          </a:fillRef>
+          <a:effectRef idx="1">
+            <a:schemeClr val="accent1"/>
+          </a:effectRef>
+          <a:fontRef idx="minor">
+            <a:schemeClr val="tx1"/>
+          </a:fontRef>
+        </p:style>
+      </p:cxnSp>
+      <p:sp>
+        <p:nvSpPr>
+          <p:cNvPr id="97" name="TextBox 96"/>
           <p:cNvSpPr txBox="1"/>
           <p:nvPr/>
         </p:nvSpPr>
         <p:spPr>
           <a:xfrm>
-            <a:off x="1700784" y="5797296"/>
-            <a:ext cx="4151376" cy="155448"/>
+            <a:off x="1728216" y="5797296"/>
+            <a:ext cx="402336" cy="137160"/>
           </a:xfrm>
           <a:prstGeom prst="rect">
             <a:avLst/>
@@ -33814,6 +34102,474 @@
                 <a:latin typeface="맑은 고딕"/>
                 <a:ea typeface="맑은 고딕"/>
               </a:rPr>
+              <a:t>1</a:t>
+            </a:r>
+          </a:p>
+        </p:txBody>
+      </p:sp>
+      <p:cxnSp>
+        <p:nvCxnSpPr>
+          <p:cNvPr id="98" name="Connector 97"/>
+          <p:cNvCxnSpPr/>
+          <p:nvPr/>
+        </p:nvCxnSpPr>
+        <p:spPr>
+          <a:xfrm>
+            <a:off x="2497718" y="5760720"/>
+            <a:ext cx="0" cy="36576"/>
+          </a:xfrm>
+          <a:prstGeom prst="line">
+            <a:avLst/>
+          </a:prstGeom>
+          <a:ln w="12700">
+            <a:solidFill>
+              <a:srgbClr val="C7CDD6"/>
+            </a:solidFill>
+          </a:ln>
+          <a:effectLst/>
+        </p:spPr>
+        <p:style>
+          <a:lnRef idx="2">
+            <a:schemeClr val="accent1"/>
+          </a:lnRef>
+          <a:fillRef idx="0">
+            <a:schemeClr val="accent1"/>
+          </a:fillRef>
+          <a:effectRef idx="1">
+            <a:schemeClr val="accent1"/>
+          </a:effectRef>
+          <a:fontRef idx="minor">
+            <a:schemeClr val="tx1"/>
+          </a:fontRef>
+        </p:style>
+      </p:cxnSp>
+      <p:sp>
+        <p:nvSpPr>
+          <p:cNvPr id="99" name="TextBox 98"/>
+          <p:cNvSpPr txBox="1"/>
+          <p:nvPr/>
+        </p:nvSpPr>
+        <p:spPr>
+          <a:xfrm>
+            <a:off x="2296550" y="5797296"/>
+            <a:ext cx="402336" cy="137160"/>
+          </a:xfrm>
+          <a:prstGeom prst="rect">
+            <a:avLst/>
+          </a:prstGeom>
+          <a:noFill/>
+        </p:spPr>
+        <p:txBody>
+          <a:bodyPr wrap="none" anchor="ctr" lIns="0" rIns="0" tIns="0" bIns="0">
+            <a:spAutoFit/>
+          </a:bodyPr>
+          <a:lstStyle/>
+          <a:p>
+            <a:pPr algn="ctr"/>
+            <a:r>
+              <a:rPr sz="1100">
+                <a:solidFill>
+                  <a:srgbClr val="6B7280"/>
+                </a:solidFill>
+                <a:latin typeface="맑은 고딕"/>
+                <a:ea typeface="맑은 고딕"/>
+              </a:rPr>
+              <a:t>3</a:t>
+            </a:r>
+          </a:p>
+        </p:txBody>
+      </p:sp>
+      <p:cxnSp>
+        <p:nvCxnSpPr>
+          <p:cNvPr id="100" name="Connector 99"/>
+          <p:cNvCxnSpPr/>
+          <p:nvPr/>
+        </p:nvCxnSpPr>
+        <p:spPr>
+          <a:xfrm>
+            <a:off x="3066053" y="5760720"/>
+            <a:ext cx="0" cy="36576"/>
+          </a:xfrm>
+          <a:prstGeom prst="line">
+            <a:avLst/>
+          </a:prstGeom>
+          <a:ln w="12700">
+            <a:solidFill>
+              <a:srgbClr val="C7CDD6"/>
+            </a:solidFill>
+          </a:ln>
+          <a:effectLst/>
+        </p:spPr>
+        <p:style>
+          <a:lnRef idx="2">
+            <a:schemeClr val="accent1"/>
+          </a:lnRef>
+          <a:fillRef idx="0">
+            <a:schemeClr val="accent1"/>
+          </a:fillRef>
+          <a:effectRef idx="1">
+            <a:schemeClr val="accent1"/>
+          </a:effectRef>
+          <a:fontRef idx="minor">
+            <a:schemeClr val="tx1"/>
+          </a:fontRef>
+        </p:style>
+      </p:cxnSp>
+      <p:sp>
+        <p:nvSpPr>
+          <p:cNvPr id="101" name="TextBox 100"/>
+          <p:cNvSpPr txBox="1"/>
+          <p:nvPr/>
+        </p:nvSpPr>
+        <p:spPr>
+          <a:xfrm>
+            <a:off x="2864885" y="5797296"/>
+            <a:ext cx="402336" cy="137160"/>
+          </a:xfrm>
+          <a:prstGeom prst="rect">
+            <a:avLst/>
+          </a:prstGeom>
+          <a:noFill/>
+        </p:spPr>
+        <p:txBody>
+          <a:bodyPr wrap="none" anchor="ctr" lIns="0" rIns="0" tIns="0" bIns="0">
+            <a:spAutoFit/>
+          </a:bodyPr>
+          <a:lstStyle/>
+          <a:p>
+            <a:pPr algn="ctr"/>
+            <a:r>
+              <a:rPr sz="1100">
+                <a:solidFill>
+                  <a:srgbClr val="6B7280"/>
+                </a:solidFill>
+                <a:latin typeface="맑은 고딕"/>
+                <a:ea typeface="맑은 고딕"/>
+              </a:rPr>
+              <a:t>5</a:t>
+            </a:r>
+          </a:p>
+        </p:txBody>
+      </p:sp>
+      <p:cxnSp>
+        <p:nvCxnSpPr>
+          <p:cNvPr id="102" name="Connector 101"/>
+          <p:cNvCxnSpPr/>
+          <p:nvPr/>
+        </p:nvCxnSpPr>
+        <p:spPr>
+          <a:xfrm>
+            <a:off x="3634388" y="5760720"/>
+            <a:ext cx="0" cy="36576"/>
+          </a:xfrm>
+          <a:prstGeom prst="line">
+            <a:avLst/>
+          </a:prstGeom>
+          <a:ln w="12700">
+            <a:solidFill>
+              <a:srgbClr val="C7CDD6"/>
+            </a:solidFill>
+          </a:ln>
+          <a:effectLst/>
+        </p:spPr>
+        <p:style>
+          <a:lnRef idx="2">
+            <a:schemeClr val="accent1"/>
+          </a:lnRef>
+          <a:fillRef idx="0">
+            <a:schemeClr val="accent1"/>
+          </a:fillRef>
+          <a:effectRef idx="1">
+            <a:schemeClr val="accent1"/>
+          </a:effectRef>
+          <a:fontRef idx="minor">
+            <a:schemeClr val="tx1"/>
+          </a:fontRef>
+        </p:style>
+      </p:cxnSp>
+      <p:sp>
+        <p:nvSpPr>
+          <p:cNvPr id="103" name="TextBox 102"/>
+          <p:cNvSpPr txBox="1"/>
+          <p:nvPr/>
+        </p:nvSpPr>
+        <p:spPr>
+          <a:xfrm>
+            <a:off x="3433220" y="5797296"/>
+            <a:ext cx="402336" cy="137160"/>
+          </a:xfrm>
+          <a:prstGeom prst="rect">
+            <a:avLst/>
+          </a:prstGeom>
+          <a:noFill/>
+        </p:spPr>
+        <p:txBody>
+          <a:bodyPr wrap="none" anchor="ctr" lIns="0" rIns="0" tIns="0" bIns="0">
+            <a:spAutoFit/>
+          </a:bodyPr>
+          <a:lstStyle/>
+          <a:p>
+            <a:pPr algn="ctr"/>
+            <a:r>
+              <a:rPr sz="1100">
+                <a:solidFill>
+                  <a:srgbClr val="6B7280"/>
+                </a:solidFill>
+                <a:latin typeface="맑은 고딕"/>
+                <a:ea typeface="맑은 고딕"/>
+              </a:rPr>
+              <a:t>7</a:t>
+            </a:r>
+          </a:p>
+        </p:txBody>
+      </p:sp>
+      <p:cxnSp>
+        <p:nvCxnSpPr>
+          <p:cNvPr id="104" name="Connector 103"/>
+          <p:cNvCxnSpPr/>
+          <p:nvPr/>
+        </p:nvCxnSpPr>
+        <p:spPr>
+          <a:xfrm>
+            <a:off x="4202723" y="5760720"/>
+            <a:ext cx="0" cy="36576"/>
+          </a:xfrm>
+          <a:prstGeom prst="line">
+            <a:avLst/>
+          </a:prstGeom>
+          <a:ln w="12700">
+            <a:solidFill>
+              <a:srgbClr val="C7CDD6"/>
+            </a:solidFill>
+          </a:ln>
+          <a:effectLst/>
+        </p:spPr>
+        <p:style>
+          <a:lnRef idx="2">
+            <a:schemeClr val="accent1"/>
+          </a:lnRef>
+          <a:fillRef idx="0">
+            <a:schemeClr val="accent1"/>
+          </a:fillRef>
+          <a:effectRef idx="1">
+            <a:schemeClr val="accent1"/>
+          </a:effectRef>
+          <a:fontRef idx="minor">
+            <a:schemeClr val="tx1"/>
+          </a:fontRef>
+        </p:style>
+      </p:cxnSp>
+      <p:sp>
+        <p:nvSpPr>
+          <p:cNvPr id="105" name="TextBox 104"/>
+          <p:cNvSpPr txBox="1"/>
+          <p:nvPr/>
+        </p:nvSpPr>
+        <p:spPr>
+          <a:xfrm>
+            <a:off x="4001555" y="5797296"/>
+            <a:ext cx="402336" cy="137160"/>
+          </a:xfrm>
+          <a:prstGeom prst="rect">
+            <a:avLst/>
+          </a:prstGeom>
+          <a:noFill/>
+        </p:spPr>
+        <p:txBody>
+          <a:bodyPr wrap="none" anchor="ctr" lIns="0" rIns="0" tIns="0" bIns="0">
+            <a:spAutoFit/>
+          </a:bodyPr>
+          <a:lstStyle/>
+          <a:p>
+            <a:pPr algn="ctr"/>
+            <a:r>
+              <a:rPr sz="1100">
+                <a:solidFill>
+                  <a:srgbClr val="6B7280"/>
+                </a:solidFill>
+                <a:latin typeface="맑은 고딕"/>
+                <a:ea typeface="맑은 고딕"/>
+              </a:rPr>
+              <a:t>9</a:t>
+            </a:r>
+          </a:p>
+        </p:txBody>
+      </p:sp>
+      <p:cxnSp>
+        <p:nvCxnSpPr>
+          <p:cNvPr id="106" name="Connector 105"/>
+          <p:cNvCxnSpPr/>
+          <p:nvPr/>
+        </p:nvCxnSpPr>
+        <p:spPr>
+          <a:xfrm>
+            <a:off x="4771057" y="5760720"/>
+            <a:ext cx="0" cy="36576"/>
+          </a:xfrm>
+          <a:prstGeom prst="line">
+            <a:avLst/>
+          </a:prstGeom>
+          <a:ln w="12700">
+            <a:solidFill>
+              <a:srgbClr val="C7CDD6"/>
+            </a:solidFill>
+          </a:ln>
+          <a:effectLst/>
+        </p:spPr>
+        <p:style>
+          <a:lnRef idx="2">
+            <a:schemeClr val="accent1"/>
+          </a:lnRef>
+          <a:fillRef idx="0">
+            <a:schemeClr val="accent1"/>
+          </a:fillRef>
+          <a:effectRef idx="1">
+            <a:schemeClr val="accent1"/>
+          </a:effectRef>
+          <a:fontRef idx="minor">
+            <a:schemeClr val="tx1"/>
+          </a:fontRef>
+        </p:style>
+      </p:cxnSp>
+      <p:sp>
+        <p:nvSpPr>
+          <p:cNvPr id="107" name="TextBox 106"/>
+          <p:cNvSpPr txBox="1"/>
+          <p:nvPr/>
+        </p:nvSpPr>
+        <p:spPr>
+          <a:xfrm>
+            <a:off x="4569889" y="5797296"/>
+            <a:ext cx="402336" cy="137160"/>
+          </a:xfrm>
+          <a:prstGeom prst="rect">
+            <a:avLst/>
+          </a:prstGeom>
+          <a:noFill/>
+        </p:spPr>
+        <p:txBody>
+          <a:bodyPr wrap="none" anchor="ctr" lIns="0" rIns="0" tIns="0" bIns="0">
+            <a:spAutoFit/>
+          </a:bodyPr>
+          <a:lstStyle/>
+          <a:p>
+            <a:pPr algn="ctr"/>
+            <a:r>
+              <a:rPr sz="1100">
+                <a:solidFill>
+                  <a:srgbClr val="6B7280"/>
+                </a:solidFill>
+                <a:latin typeface="맑은 고딕"/>
+                <a:ea typeface="맑은 고딕"/>
+              </a:rPr>
+              <a:t>11</a:t>
+            </a:r>
+          </a:p>
+        </p:txBody>
+      </p:sp>
+      <p:cxnSp>
+        <p:nvCxnSpPr>
+          <p:cNvPr id="108" name="Connector 107"/>
+          <p:cNvCxnSpPr/>
+          <p:nvPr/>
+        </p:nvCxnSpPr>
+        <p:spPr>
+          <a:xfrm>
+            <a:off x="5339392" y="5760720"/>
+            <a:ext cx="0" cy="36576"/>
+          </a:xfrm>
+          <a:prstGeom prst="line">
+            <a:avLst/>
+          </a:prstGeom>
+          <a:ln w="12700">
+            <a:solidFill>
+              <a:srgbClr val="C7CDD6"/>
+            </a:solidFill>
+          </a:ln>
+          <a:effectLst/>
+        </p:spPr>
+        <p:style>
+          <a:lnRef idx="2">
+            <a:schemeClr val="accent1"/>
+          </a:lnRef>
+          <a:fillRef idx="0">
+            <a:schemeClr val="accent1"/>
+          </a:fillRef>
+          <a:effectRef idx="1">
+            <a:schemeClr val="accent1"/>
+          </a:effectRef>
+          <a:fontRef idx="minor">
+            <a:schemeClr val="tx1"/>
+          </a:fontRef>
+        </p:style>
+      </p:cxnSp>
+      <p:sp>
+        <p:nvSpPr>
+          <p:cNvPr id="109" name="TextBox 108"/>
+          <p:cNvSpPr txBox="1"/>
+          <p:nvPr/>
+        </p:nvSpPr>
+        <p:spPr>
+          <a:xfrm>
+            <a:off x="5138224" y="5797296"/>
+            <a:ext cx="402336" cy="137160"/>
+          </a:xfrm>
+          <a:prstGeom prst="rect">
+            <a:avLst/>
+          </a:prstGeom>
+          <a:noFill/>
+        </p:spPr>
+        <p:txBody>
+          <a:bodyPr wrap="none" anchor="ctr" lIns="0" rIns="0" tIns="0" bIns="0">
+            <a:spAutoFit/>
+          </a:bodyPr>
+          <a:lstStyle/>
+          <a:p>
+            <a:pPr algn="ctr"/>
+            <a:r>
+              <a:rPr sz="1100">
+                <a:solidFill>
+                  <a:srgbClr val="6B7280"/>
+                </a:solidFill>
+                <a:latin typeface="맑은 고딕"/>
+                <a:ea typeface="맑은 고딕"/>
+              </a:rPr>
+              <a:t>13</a:t>
+            </a:r>
+          </a:p>
+        </p:txBody>
+      </p:sp>
+      <p:sp>
+        <p:nvSpPr>
+          <p:cNvPr id="110" name="TextBox 109"/>
+          <p:cNvSpPr txBox="1"/>
+          <p:nvPr/>
+        </p:nvSpPr>
+        <p:spPr>
+          <a:xfrm>
+            <a:off x="1700784" y="5934456"/>
+            <a:ext cx="4151376" cy="128016"/>
+          </a:xfrm>
+          <a:prstGeom prst="rect">
+            <a:avLst/>
+          </a:prstGeom>
+          <a:noFill/>
+        </p:spPr>
+        <p:txBody>
+          <a:bodyPr wrap="none" anchor="ctr" lIns="0" rIns="0" tIns="0" bIns="0">
+            <a:spAutoFit/>
+          </a:bodyPr>
+          <a:lstStyle/>
+          <a:p>
+            <a:pPr algn="ctr"/>
+            <a:r>
+              <a:rPr sz="1050">
+                <a:solidFill>
+                  <a:srgbClr val="6B7280"/>
+                </a:solidFill>
+                <a:latin typeface="맑은 고딕"/>
+                <a:ea typeface="맑은 고딕"/>
+              </a:rPr>
               <a:t>epoch</a:t>
             </a:r>
           </a:p>
@@ -33821,14 +34577,14 @@
       </p:sp>
       <p:sp>
         <p:nvSpPr>
-          <p:cNvPr id="90" name="TextBox 89"/>
+          <p:cNvPr id="111" name="TextBox 110"/>
           <p:cNvSpPr txBox="1"/>
           <p:nvPr/>
         </p:nvSpPr>
         <p:spPr>
           <a:xfrm>
-            <a:off x="1609344" y="6030468"/>
-            <a:ext cx="4288536" cy="173736"/>
+            <a:off x="1609344" y="6067044"/>
+            <a:ext cx="4288536" cy="155448"/>
           </a:xfrm>
           <a:prstGeom prst="rect">
             <a:avLst/>
@@ -33867,7 +34623,7 @@
       </p:sp>
       <p:sp>
         <p:nvSpPr>
-          <p:cNvPr id="91" name="TextBox 90"/>
+          <p:cNvPr id="112" name="TextBox 111"/>
           <p:cNvSpPr txBox="1"/>
           <p:nvPr/>
         </p:nvSpPr>
@@ -33903,7 +34659,7 @@
       </p:sp>
       <p:sp>
         <p:nvSpPr>
-          <p:cNvPr id="92" name="TextBox 91"/>
+          <p:cNvPr id="113" name="TextBox 112"/>
           <p:cNvSpPr txBox="1"/>
           <p:nvPr/>
         </p:nvSpPr>
@@ -33939,7 +34695,7 @@
       </p:sp>
       <p:pic>
         <p:nvPicPr>
-          <p:cNvPr id="93" name="Picture 92" descr="p3r_color_baseline.png"/>
+          <p:cNvPr id="114" name="Picture 113" descr="p3r_color_baseline.png"/>
           <p:cNvPicPr>
             <a:picLocks noChangeAspect="1"/>
           </p:cNvPicPr>
@@ -33963,7 +34719,7 @@
       </p:pic>
       <p:sp>
         <p:nvSpPr>
-          <p:cNvPr id="94" name="TextBox 93"/>
+          <p:cNvPr id="115" name="TextBox 114"/>
           <p:cNvSpPr txBox="1"/>
           <p:nvPr/>
         </p:nvSpPr>
@@ -33999,7 +34755,7 @@
       </p:sp>
       <p:pic>
         <p:nvPicPr>
-          <p:cNvPr id="95" name="Picture 94" descr="p3r_color_c01.png"/>
+          <p:cNvPr id="116" name="Picture 115" descr="p3r_color_c01.png"/>
           <p:cNvPicPr>
             <a:picLocks noChangeAspect="1"/>
           </p:cNvPicPr>
@@ -34023,7 +34779,7 @@
       </p:pic>
       <p:sp>
         <p:nvSpPr>
-          <p:cNvPr id="96" name="TextBox 95"/>
+          <p:cNvPr id="117" name="TextBox 116"/>
           <p:cNvSpPr txBox="1"/>
           <p:nvPr/>
         </p:nvSpPr>
@@ -34059,7 +34815,7 @@
       </p:sp>
       <p:sp>
         <p:nvSpPr>
-          <p:cNvPr id="97" name="TextBox 96"/>
+          <p:cNvPr id="118" name="TextBox 117"/>
           <p:cNvSpPr txBox="1"/>
           <p:nvPr/>
         </p:nvSpPr>
@@ -34095,7 +34851,7 @@
       </p:sp>
       <p:sp>
         <p:nvSpPr>
-          <p:cNvPr id="98" name="TextBox 97"/>
+          <p:cNvPr id="119" name="TextBox 118"/>
           <p:cNvSpPr txBox="1"/>
           <p:nvPr/>
         </p:nvSpPr>

</xml_diff>